<commit_message>
Use explicit Edition 006 publication links
</commit_message>
<xml_diff>
--- a/social/Bridge_X_Brief_006_LinkedIn_Carousel.pptx
+++ b/social/Bridge_X_Brief_006_LinkedIn_Carousel.pptx
@@ -2,19 +2,19 @@
 <file path=ppt/presentation.xml><?xml version="1.0" encoding="utf-8"?>
 <p:presentation xmlns:p="http://schemas.openxmlformats.org/presentationml/2006/main">
   <p:sldMasterIdLst>
-    <p:sldMasterId xmlns:r="http://schemas.openxmlformats.org/officeDocument/2006/relationships" id="2147483648" r:id="Rba958f9294a94a87"/>
+    <p:sldMasterId xmlns:r="http://schemas.openxmlformats.org/officeDocument/2006/relationships" id="2147483648" r:id="Rbc006a04a99d4e27"/>
   </p:sldMasterIdLst>
   <p:notesMasterIdLst>
-    <p:notesMasterId xmlns:r="http://schemas.openxmlformats.org/officeDocument/2006/relationships" r:id="R6b871fae73d844f1"/>
+    <p:notesMasterId xmlns:r="http://schemas.openxmlformats.org/officeDocument/2006/relationships" r:id="Rd3fb27d323424eb6"/>
   </p:notesMasterIdLst>
   <p:sldIdLst>
-    <p:sldId xmlns:r="http://schemas.openxmlformats.org/officeDocument/2006/relationships" id="256" r:id="R246e8da5639f4566"/>
-    <p:sldId xmlns:r="http://schemas.openxmlformats.org/officeDocument/2006/relationships" id="257" r:id="Rf8f163a99dec4cee"/>
-    <p:sldId xmlns:r="http://schemas.openxmlformats.org/officeDocument/2006/relationships" id="258" r:id="R9a0dc32f304e4ada"/>
-    <p:sldId xmlns:r="http://schemas.openxmlformats.org/officeDocument/2006/relationships" id="259" r:id="R0a7a3e3e425849d3"/>
-    <p:sldId xmlns:r="http://schemas.openxmlformats.org/officeDocument/2006/relationships" id="260" r:id="R83f815393f314302"/>
-    <p:sldId xmlns:r="http://schemas.openxmlformats.org/officeDocument/2006/relationships" id="261" r:id="Rd23f9af4061a4ed2"/>
-    <p:sldId xmlns:r="http://schemas.openxmlformats.org/officeDocument/2006/relationships" id="262" r:id="R9226635474824c77"/>
+    <p:sldId xmlns:r="http://schemas.openxmlformats.org/officeDocument/2006/relationships" id="256" r:id="Rc59bb2220a324fcb"/>
+    <p:sldId xmlns:r="http://schemas.openxmlformats.org/officeDocument/2006/relationships" id="257" r:id="Rd84558f03c3e4afe"/>
+    <p:sldId xmlns:r="http://schemas.openxmlformats.org/officeDocument/2006/relationships" id="258" r:id="R148b176c1f5b4a18"/>
+    <p:sldId xmlns:r="http://schemas.openxmlformats.org/officeDocument/2006/relationships" id="259" r:id="Rd3a1523efe674fac"/>
+    <p:sldId xmlns:r="http://schemas.openxmlformats.org/officeDocument/2006/relationships" id="260" r:id="R4758d850876b44cb"/>
+    <p:sldId xmlns:r="http://schemas.openxmlformats.org/officeDocument/2006/relationships" id="261" r:id="R425aaf32262c4223"/>
+    <p:sldId xmlns:r="http://schemas.openxmlformats.org/officeDocument/2006/relationships" id="262" r:id="R37484b393a564b26"/>
   </p:sldIdLst>
   <p:sldSz cx="15240000" cy="8572500"/>
   <p:notesSz cx="6858000" cy="9144000"/>
@@ -1111,7 +1111,7 @@
   </p:cSld>
   <p:clrMap bg1="lt1" tx1="dk1" bg2="lt2" tx2="dk2" accent1="accent1" accent2="accent2" accent3="accent3" accent4="accent4" accent5="accent5" accent6="accent6" hlink="hlink" folHlink="folHlink"/>
   <p:sldLayoutIdLst>
-    <p:sldLayoutId xmlns:r="http://schemas.openxmlformats.org/officeDocument/2006/relationships" id="2147483649" r:id="R220189dc15fd4fa4"/>
+    <p:sldLayoutId xmlns:r="http://schemas.openxmlformats.org/officeDocument/2006/relationships" id="2147483649" r:id="R6105f2d55fe74edc"/>
   </p:sldLayoutIdLst>
   <p:txStyles>
     <p:titleStyle>
@@ -1662,7 +1662,7 @@
           <p:cNvPr id="84" name="">
             <a:extLst xmlns:a="http://schemas.openxmlformats.org/drawingml/2006/main">
               <a:ext uri="{FF2B5EF4-FFF2-40B4-BE49-F238E27FC236}">
-                <a16:creationId xmlns:a16="http://schemas.microsoft.com/office/drawing/2014/main" id="{6951EC16-0CC0-496A-8AE4-1ED6139971DC}"/>
+                <a16:creationId xmlns:a16="http://schemas.microsoft.com/office/drawing/2014/main" id="{C107686E-4F42-48D0-98B4-54C724B81B95}"/>
               </a:ext>
             </a:extLst>
           </p:cNvPr>
@@ -1693,7 +1693,7 @@
           <p:cNvPr id="2" name="">
             <a:extLst xmlns:a="http://schemas.openxmlformats.org/drawingml/2006/main">
               <a:ext uri="{FF2B5EF4-FFF2-40B4-BE49-F238E27FC236}">
-                <a16:creationId xmlns:a16="http://schemas.microsoft.com/office/drawing/2014/main" id="{4419D492-6BAE-4FBD-A311-4DD2D9A3BBED}"/>
+                <a16:creationId xmlns:a16="http://schemas.microsoft.com/office/drawing/2014/main" id="{5BCF5FAE-6F7C-45C3-9832-14A12F781871}"/>
               </a:ext>
             </a:extLst>
           </p:cNvPr>
@@ -1724,7 +1724,7 @@
           <p:cNvPr id="3" name="">
             <a:extLst xmlns:a="http://schemas.openxmlformats.org/drawingml/2006/main">
               <a:ext uri="{FF2B5EF4-FFF2-40B4-BE49-F238E27FC236}">
-                <a16:creationId xmlns:a16="http://schemas.microsoft.com/office/drawing/2014/main" id="{50139218-6BB1-4628-95A6-AEC46B8B94E5}"/>
+                <a16:creationId xmlns:a16="http://schemas.microsoft.com/office/drawing/2014/main" id="{56CE0B30-9187-4F79-88EE-EB2D530100B4}"/>
               </a:ext>
             </a:extLst>
           </p:cNvPr>
@@ -1755,7 +1755,7 @@
           <p:cNvPr id="4" name="">
             <a:extLst xmlns:a="http://schemas.openxmlformats.org/drawingml/2006/main">
               <a:ext uri="{FF2B5EF4-FFF2-40B4-BE49-F238E27FC236}">
-                <a16:creationId xmlns:a16="http://schemas.microsoft.com/office/drawing/2014/main" id="{26F56C41-E72D-4B1E-857F-8B9BC0559543}"/>
+                <a16:creationId xmlns:a16="http://schemas.microsoft.com/office/drawing/2014/main" id="{8E0922B1-0358-4591-A7ED-99C80A8526FA}"/>
               </a:ext>
             </a:extLst>
           </p:cNvPr>
@@ -1786,7 +1786,7 @@
           <p:cNvPr id="5" name="">
             <a:extLst xmlns:a="http://schemas.openxmlformats.org/drawingml/2006/main">
               <a:ext uri="{FF2B5EF4-FFF2-40B4-BE49-F238E27FC236}">
-                <a16:creationId xmlns:a16="http://schemas.microsoft.com/office/drawing/2014/main" id="{D096B4D3-9343-430B-AFA2-559268D15C6F}"/>
+                <a16:creationId xmlns:a16="http://schemas.microsoft.com/office/drawing/2014/main" id="{C84E222C-C957-4B37-A452-FB0BD34CDA6A}"/>
               </a:ext>
             </a:extLst>
           </p:cNvPr>
@@ -1817,7 +1817,7 @@
           <p:cNvPr id="6" name="">
             <a:extLst xmlns:a="http://schemas.openxmlformats.org/drawingml/2006/main">
               <a:ext uri="{FF2B5EF4-FFF2-40B4-BE49-F238E27FC236}">
-                <a16:creationId xmlns:a16="http://schemas.microsoft.com/office/drawing/2014/main" id="{485ABAA1-AD2B-448E-AD53-4F5AB121027C}"/>
+                <a16:creationId xmlns:a16="http://schemas.microsoft.com/office/drawing/2014/main" id="{F5B76E4E-B0D1-487A-9F52-5944EF3B2584}"/>
               </a:ext>
             </a:extLst>
           </p:cNvPr>
@@ -1848,7 +1848,7 @@
           <p:cNvPr id="7" name="">
             <a:extLst xmlns:a="http://schemas.openxmlformats.org/drawingml/2006/main">
               <a:ext uri="{FF2B5EF4-FFF2-40B4-BE49-F238E27FC236}">
-                <a16:creationId xmlns:a16="http://schemas.microsoft.com/office/drawing/2014/main" id="{97474889-2B20-48A6-8854-72C9BA29CBC4}"/>
+                <a16:creationId xmlns:a16="http://schemas.microsoft.com/office/drawing/2014/main" id="{C5273E30-27A7-4C69-9ED5-633751C97748}"/>
               </a:ext>
             </a:extLst>
           </p:cNvPr>
@@ -1879,7 +1879,7 @@
           <p:cNvPr id="8" name="">
             <a:extLst xmlns:a="http://schemas.openxmlformats.org/drawingml/2006/main">
               <a:ext uri="{FF2B5EF4-FFF2-40B4-BE49-F238E27FC236}">
-                <a16:creationId xmlns:a16="http://schemas.microsoft.com/office/drawing/2014/main" id="{73AE6029-6F71-410D-A05C-B8B0381054FC}"/>
+                <a16:creationId xmlns:a16="http://schemas.microsoft.com/office/drawing/2014/main" id="{CDB4DB34-42B1-4068-8E50-82CFE9AB85D6}"/>
               </a:ext>
             </a:extLst>
           </p:cNvPr>
@@ -1910,7 +1910,7 @@
           <p:cNvPr id="9" name="">
             <a:extLst xmlns:a="http://schemas.openxmlformats.org/drawingml/2006/main">
               <a:ext uri="{FF2B5EF4-FFF2-40B4-BE49-F238E27FC236}">
-                <a16:creationId xmlns:a16="http://schemas.microsoft.com/office/drawing/2014/main" id="{EE272C59-060A-4E5C-9099-DD6F19809A37}"/>
+                <a16:creationId xmlns:a16="http://schemas.microsoft.com/office/drawing/2014/main" id="{541A91C7-66E6-4CB7-9C0D-F66CD5A21CBC}"/>
               </a:ext>
             </a:extLst>
           </p:cNvPr>
@@ -1941,7 +1941,7 @@
           <p:cNvPr id="10" name="">
             <a:extLst xmlns:a="http://schemas.openxmlformats.org/drawingml/2006/main">
               <a:ext uri="{FF2B5EF4-FFF2-40B4-BE49-F238E27FC236}">
-                <a16:creationId xmlns:a16="http://schemas.microsoft.com/office/drawing/2014/main" id="{2F53F6F9-D1A2-4D97-A235-6F73D8B77A95}"/>
+                <a16:creationId xmlns:a16="http://schemas.microsoft.com/office/drawing/2014/main" id="{CD0BA2EC-0A36-439E-B9F9-0AC4A941239A}"/>
               </a:ext>
             </a:extLst>
           </p:cNvPr>
@@ -1972,7 +1972,7 @@
           <p:cNvPr id="11" name="">
             <a:extLst xmlns:a="http://schemas.openxmlformats.org/drawingml/2006/main">
               <a:ext uri="{FF2B5EF4-FFF2-40B4-BE49-F238E27FC236}">
-                <a16:creationId xmlns:a16="http://schemas.microsoft.com/office/drawing/2014/main" id="{B0C0A7CA-D503-4FA4-A1C1-10F6ABD2C911}"/>
+                <a16:creationId xmlns:a16="http://schemas.microsoft.com/office/drawing/2014/main" id="{7D2E2988-DD82-4FB1-BB80-8E4D70A37F8E}"/>
               </a:ext>
             </a:extLst>
           </p:cNvPr>
@@ -2003,7 +2003,7 @@
           <p:cNvPr id="12" name="">
             <a:extLst xmlns:a="http://schemas.openxmlformats.org/drawingml/2006/main">
               <a:ext uri="{FF2B5EF4-FFF2-40B4-BE49-F238E27FC236}">
-                <a16:creationId xmlns:a16="http://schemas.microsoft.com/office/drawing/2014/main" id="{40E63708-5360-4813-B3AC-92B5DCC7BB19}"/>
+                <a16:creationId xmlns:a16="http://schemas.microsoft.com/office/drawing/2014/main" id="{36F75E05-D90E-421D-9D2C-4D016CD884AE}"/>
               </a:ext>
             </a:extLst>
           </p:cNvPr>
@@ -2034,7 +2034,7 @@
           <p:cNvPr id="13" name="">
             <a:extLst xmlns:a="http://schemas.openxmlformats.org/drawingml/2006/main">
               <a:ext uri="{FF2B5EF4-FFF2-40B4-BE49-F238E27FC236}">
-                <a16:creationId xmlns:a16="http://schemas.microsoft.com/office/drawing/2014/main" id="{8B5EAFDD-D718-49A4-ACD1-671A609B3F58}"/>
+                <a16:creationId xmlns:a16="http://schemas.microsoft.com/office/drawing/2014/main" id="{1971194F-BAEC-4CCC-8560-3C12AA1E69F7}"/>
               </a:ext>
             </a:extLst>
           </p:cNvPr>
@@ -2065,7 +2065,7 @@
           <p:cNvPr id="14" name="">
             <a:extLst xmlns:a="http://schemas.openxmlformats.org/drawingml/2006/main">
               <a:ext uri="{FF2B5EF4-FFF2-40B4-BE49-F238E27FC236}">
-                <a16:creationId xmlns:a16="http://schemas.microsoft.com/office/drawing/2014/main" id="{1F72CFC4-96CF-4999-9BD9-B815FEF9F76A}"/>
+                <a16:creationId xmlns:a16="http://schemas.microsoft.com/office/drawing/2014/main" id="{7B82A052-C22F-405E-89FD-58E4804F20EF}"/>
               </a:ext>
             </a:extLst>
           </p:cNvPr>
@@ -2096,7 +2096,7 @@
           <p:cNvPr id="15" name="">
             <a:extLst xmlns:a="http://schemas.openxmlformats.org/drawingml/2006/main">
               <a:ext uri="{FF2B5EF4-FFF2-40B4-BE49-F238E27FC236}">
-                <a16:creationId xmlns:a16="http://schemas.microsoft.com/office/drawing/2014/main" id="{ED50BEA6-18D9-4807-91E0-A14AA534508C}"/>
+                <a16:creationId xmlns:a16="http://schemas.microsoft.com/office/drawing/2014/main" id="{C92CDCC3-52B0-42F4-A09A-D98A6E3CD16C}"/>
               </a:ext>
             </a:extLst>
           </p:cNvPr>
@@ -2127,7 +2127,7 @@
           <p:cNvPr id="16" name="">
             <a:extLst xmlns:a="http://schemas.openxmlformats.org/drawingml/2006/main">
               <a:ext uri="{FF2B5EF4-FFF2-40B4-BE49-F238E27FC236}">
-                <a16:creationId xmlns:a16="http://schemas.microsoft.com/office/drawing/2014/main" id="{A75481D2-C7A3-4B20-B0C0-72614767E504}"/>
+                <a16:creationId xmlns:a16="http://schemas.microsoft.com/office/drawing/2014/main" id="{A0DA6149-5120-4429-A6B5-AD278CBF7610}"/>
               </a:ext>
             </a:extLst>
           </p:cNvPr>
@@ -2158,7 +2158,7 @@
           <p:cNvPr id="17" name="">
             <a:extLst xmlns:a="http://schemas.openxmlformats.org/drawingml/2006/main">
               <a:ext uri="{FF2B5EF4-FFF2-40B4-BE49-F238E27FC236}">
-                <a16:creationId xmlns:a16="http://schemas.microsoft.com/office/drawing/2014/main" id="{59D81078-A5DE-42FD-B4B4-14EA25AC803B}"/>
+                <a16:creationId xmlns:a16="http://schemas.microsoft.com/office/drawing/2014/main" id="{078E6978-2C33-45A9-8735-0E411938E9AB}"/>
               </a:ext>
             </a:extLst>
           </p:cNvPr>
@@ -2189,7 +2189,7 @@
           <p:cNvPr id="18" name="">
             <a:extLst xmlns:a="http://schemas.openxmlformats.org/drawingml/2006/main">
               <a:ext uri="{FF2B5EF4-FFF2-40B4-BE49-F238E27FC236}">
-                <a16:creationId xmlns:a16="http://schemas.microsoft.com/office/drawing/2014/main" id="{08025673-CD37-4FC8-A6D1-64CFA79D86BC}"/>
+                <a16:creationId xmlns:a16="http://schemas.microsoft.com/office/drawing/2014/main" id="{53A2A83C-FE5A-4081-A197-AB8A280D16C7}"/>
               </a:ext>
             </a:extLst>
           </p:cNvPr>
@@ -2220,7 +2220,7 @@
           <p:cNvPr id="19" name="">
             <a:extLst xmlns:a="http://schemas.openxmlformats.org/drawingml/2006/main">
               <a:ext uri="{FF2B5EF4-FFF2-40B4-BE49-F238E27FC236}">
-                <a16:creationId xmlns:a16="http://schemas.microsoft.com/office/drawing/2014/main" id="{8E2609F8-C801-4A6D-AAE9-2811C83FE7BF}"/>
+                <a16:creationId xmlns:a16="http://schemas.microsoft.com/office/drawing/2014/main" id="{0364B2A4-F0D6-4968-9E71-062862FCA4AF}"/>
               </a:ext>
             </a:extLst>
           </p:cNvPr>
@@ -2251,7 +2251,7 @@
           <p:cNvPr id="20" name="">
             <a:extLst xmlns:a="http://schemas.openxmlformats.org/drawingml/2006/main">
               <a:ext uri="{FF2B5EF4-FFF2-40B4-BE49-F238E27FC236}">
-                <a16:creationId xmlns:a16="http://schemas.microsoft.com/office/drawing/2014/main" id="{B6294512-37DB-4ECF-8524-08A234A06D13}"/>
+                <a16:creationId xmlns:a16="http://schemas.microsoft.com/office/drawing/2014/main" id="{E471EA5F-4EAF-4AF4-BCBA-901AF7683B23}"/>
               </a:ext>
             </a:extLst>
           </p:cNvPr>
@@ -2282,7 +2282,7 @@
           <p:cNvPr id="21" name="">
             <a:extLst xmlns:a="http://schemas.openxmlformats.org/drawingml/2006/main">
               <a:ext uri="{FF2B5EF4-FFF2-40B4-BE49-F238E27FC236}">
-                <a16:creationId xmlns:a16="http://schemas.microsoft.com/office/drawing/2014/main" id="{139CB91F-A28F-417D-9805-187EA92B33C6}"/>
+                <a16:creationId xmlns:a16="http://schemas.microsoft.com/office/drawing/2014/main" id="{FDE95FD1-85FC-48CA-A2C8-E9F21E834DC6}"/>
               </a:ext>
             </a:extLst>
           </p:cNvPr>
@@ -2313,7 +2313,7 @@
           <p:cNvPr id="22" name="">
             <a:extLst xmlns:a="http://schemas.openxmlformats.org/drawingml/2006/main">
               <a:ext uri="{FF2B5EF4-FFF2-40B4-BE49-F238E27FC236}">
-                <a16:creationId xmlns:a16="http://schemas.microsoft.com/office/drawing/2014/main" id="{94F2AE27-5F23-45CF-A6DD-604611E31B58}"/>
+                <a16:creationId xmlns:a16="http://schemas.microsoft.com/office/drawing/2014/main" id="{D60AD761-721E-4613-8EA2-B2FAF919A2C0}"/>
               </a:ext>
             </a:extLst>
           </p:cNvPr>
@@ -2344,7 +2344,7 @@
           <p:cNvPr id="23" name="">
             <a:extLst xmlns:a="http://schemas.openxmlformats.org/drawingml/2006/main">
               <a:ext uri="{FF2B5EF4-FFF2-40B4-BE49-F238E27FC236}">
-                <a16:creationId xmlns:a16="http://schemas.microsoft.com/office/drawing/2014/main" id="{5FF15112-B390-4836-AC0E-D3FC0728F5DD}"/>
+                <a16:creationId xmlns:a16="http://schemas.microsoft.com/office/drawing/2014/main" id="{F754BF49-1A4F-4FF5-BB49-EDF3F513B306}"/>
               </a:ext>
             </a:extLst>
           </p:cNvPr>
@@ -2375,7 +2375,7 @@
           <p:cNvPr id="24" name="">
             <a:extLst xmlns:a="http://schemas.openxmlformats.org/drawingml/2006/main">
               <a:ext uri="{FF2B5EF4-FFF2-40B4-BE49-F238E27FC236}">
-                <a16:creationId xmlns:a16="http://schemas.microsoft.com/office/drawing/2014/main" id="{037CA316-0D43-455F-AF9A-1513BFDD047B}"/>
+                <a16:creationId xmlns:a16="http://schemas.microsoft.com/office/drawing/2014/main" id="{B3ACDF92-1D61-4EF8-B3D0-794E134FC5C8}"/>
               </a:ext>
             </a:extLst>
           </p:cNvPr>
@@ -2406,7 +2406,7 @@
           <p:cNvPr id="25" name="">
             <a:extLst xmlns:a="http://schemas.openxmlformats.org/drawingml/2006/main">
               <a:ext uri="{FF2B5EF4-FFF2-40B4-BE49-F238E27FC236}">
-                <a16:creationId xmlns:a16="http://schemas.microsoft.com/office/drawing/2014/main" id="{81C51F48-54CA-4C2A-9D25-EF020D493C1B}"/>
+                <a16:creationId xmlns:a16="http://schemas.microsoft.com/office/drawing/2014/main" id="{3A91094A-D175-4584-85D5-3A4B27283CE2}"/>
               </a:ext>
             </a:extLst>
           </p:cNvPr>
@@ -2437,7 +2437,7 @@
           <p:cNvPr id="26" name="">
             <a:extLst xmlns:a="http://schemas.openxmlformats.org/drawingml/2006/main">
               <a:ext uri="{FF2B5EF4-FFF2-40B4-BE49-F238E27FC236}">
-                <a16:creationId xmlns:a16="http://schemas.microsoft.com/office/drawing/2014/main" id="{BF368418-4DEA-48C4-8E39-28ED0484F3F8}"/>
+                <a16:creationId xmlns:a16="http://schemas.microsoft.com/office/drawing/2014/main" id="{3777346F-A660-43DB-94C8-CC25CEE9734C}"/>
               </a:ext>
             </a:extLst>
           </p:cNvPr>
@@ -2468,7 +2468,7 @@
           <p:cNvPr id="27" name="">
             <a:extLst xmlns:a="http://schemas.openxmlformats.org/drawingml/2006/main">
               <a:ext uri="{FF2B5EF4-FFF2-40B4-BE49-F238E27FC236}">
-                <a16:creationId xmlns:a16="http://schemas.microsoft.com/office/drawing/2014/main" id="{235FCFCA-0D8E-487A-8C57-DA76796F79E0}"/>
+                <a16:creationId xmlns:a16="http://schemas.microsoft.com/office/drawing/2014/main" id="{CA8C6DF8-E768-4A38-B9D6-6F75C798EFD1}"/>
               </a:ext>
             </a:extLst>
           </p:cNvPr>
@@ -2499,7 +2499,7 @@
           <p:cNvPr id="28" name="">
             <a:extLst xmlns:a="http://schemas.openxmlformats.org/drawingml/2006/main">
               <a:ext uri="{FF2B5EF4-FFF2-40B4-BE49-F238E27FC236}">
-                <a16:creationId xmlns:a16="http://schemas.microsoft.com/office/drawing/2014/main" id="{C1336291-9EA4-4B25-81F7-9F9FF2D4EAC4}"/>
+                <a16:creationId xmlns:a16="http://schemas.microsoft.com/office/drawing/2014/main" id="{88EB00CF-70C9-4090-877E-03611974E17B}"/>
               </a:ext>
             </a:extLst>
           </p:cNvPr>
@@ -2530,7 +2530,7 @@
           <p:cNvPr id="29" name="">
             <a:extLst xmlns:a="http://schemas.openxmlformats.org/drawingml/2006/main">
               <a:ext uri="{FF2B5EF4-FFF2-40B4-BE49-F238E27FC236}">
-                <a16:creationId xmlns:a16="http://schemas.microsoft.com/office/drawing/2014/main" id="{69EAF600-C8AD-4443-8D64-6B6281E77A56}"/>
+                <a16:creationId xmlns:a16="http://schemas.microsoft.com/office/drawing/2014/main" id="{58F4B48E-1845-4AB8-ACD4-4B6A9D0F0F54}"/>
               </a:ext>
             </a:extLst>
           </p:cNvPr>
@@ -2561,7 +2561,7 @@
           <p:cNvPr id="30" name="">
             <a:extLst xmlns:a="http://schemas.openxmlformats.org/drawingml/2006/main">
               <a:ext uri="{FF2B5EF4-FFF2-40B4-BE49-F238E27FC236}">
-                <a16:creationId xmlns:a16="http://schemas.microsoft.com/office/drawing/2014/main" id="{D849CA03-6FB5-4BCC-BBDF-11937E2AF201}"/>
+                <a16:creationId xmlns:a16="http://schemas.microsoft.com/office/drawing/2014/main" id="{569B0295-EA1E-44A9-A405-3C9615C44813}"/>
               </a:ext>
             </a:extLst>
           </p:cNvPr>
@@ -2592,7 +2592,7 @@
           <p:cNvPr id="31" name="">
             <a:extLst xmlns:a="http://schemas.openxmlformats.org/drawingml/2006/main">
               <a:ext uri="{FF2B5EF4-FFF2-40B4-BE49-F238E27FC236}">
-                <a16:creationId xmlns:a16="http://schemas.microsoft.com/office/drawing/2014/main" id="{8E30FAD3-8312-4AF6-9D63-63F50F9B3A63}"/>
+                <a16:creationId xmlns:a16="http://schemas.microsoft.com/office/drawing/2014/main" id="{04BBB489-2FE8-471C-B9A7-C0457DC6B2F0}"/>
               </a:ext>
             </a:extLst>
           </p:cNvPr>
@@ -2623,7 +2623,7 @@
           <p:cNvPr id="32" name="">
             <a:extLst xmlns:a="http://schemas.openxmlformats.org/drawingml/2006/main">
               <a:ext uri="{FF2B5EF4-FFF2-40B4-BE49-F238E27FC236}">
-                <a16:creationId xmlns:a16="http://schemas.microsoft.com/office/drawing/2014/main" id="{80D21A7D-A261-468B-8211-F41D39B58E50}"/>
+                <a16:creationId xmlns:a16="http://schemas.microsoft.com/office/drawing/2014/main" id="{6F923EB2-06E4-4BB7-B4FD-BB292B6C9A0E}"/>
               </a:ext>
             </a:extLst>
           </p:cNvPr>
@@ -2654,7 +2654,7 @@
           <p:cNvPr id="33" name="">
             <a:extLst xmlns:a="http://schemas.openxmlformats.org/drawingml/2006/main">
               <a:ext uri="{FF2B5EF4-FFF2-40B4-BE49-F238E27FC236}">
-                <a16:creationId xmlns:a16="http://schemas.microsoft.com/office/drawing/2014/main" id="{01D0097B-DFE9-406B-9A9A-5AAA90EAA4D7}"/>
+                <a16:creationId xmlns:a16="http://schemas.microsoft.com/office/drawing/2014/main" id="{0F900AB3-5713-4F1A-8624-A5251FADEA8A}"/>
               </a:ext>
             </a:extLst>
           </p:cNvPr>
@@ -2685,7 +2685,7 @@
           <p:cNvPr id="34" name="">
             <a:extLst xmlns:a="http://schemas.openxmlformats.org/drawingml/2006/main">
               <a:ext uri="{FF2B5EF4-FFF2-40B4-BE49-F238E27FC236}">
-                <a16:creationId xmlns:a16="http://schemas.microsoft.com/office/drawing/2014/main" id="{C885703C-78E4-4B4F-B330-08573A04A39A}"/>
+                <a16:creationId xmlns:a16="http://schemas.microsoft.com/office/drawing/2014/main" id="{8DE7186F-F838-4403-87DD-DE059DBFCACE}"/>
               </a:ext>
             </a:extLst>
           </p:cNvPr>
@@ -2718,7 +2718,7 @@
           <p:cNvPr id="35" name="">
             <a:extLst xmlns:a="http://schemas.openxmlformats.org/drawingml/2006/main">
               <a:ext uri="{FF2B5EF4-FFF2-40B4-BE49-F238E27FC236}">
-                <a16:creationId xmlns:a16="http://schemas.microsoft.com/office/drawing/2014/main" id="{35C0FB5B-6CC6-49CD-B6A8-214DC2029922}"/>
+                <a16:creationId xmlns:a16="http://schemas.microsoft.com/office/drawing/2014/main" id="{3C42713F-6EF3-4AD0-BE37-57F24ED05F86}"/>
               </a:ext>
             </a:extLst>
           </p:cNvPr>
@@ -2780,7 +2780,7 @@
           <p:cNvPr id="36" name="">
             <a:extLst xmlns:a="http://schemas.openxmlformats.org/drawingml/2006/main">
               <a:ext uri="{FF2B5EF4-FFF2-40B4-BE49-F238E27FC236}">
-                <a16:creationId xmlns:a16="http://schemas.microsoft.com/office/drawing/2014/main" id="{6A5C63AC-A099-4C1D-AD05-902FB1F67F4C}"/>
+                <a16:creationId xmlns:a16="http://schemas.microsoft.com/office/drawing/2014/main" id="{9FAF25FB-29D0-47F8-8E93-7C4141D61152}"/>
               </a:ext>
             </a:extLst>
           </p:cNvPr>
@@ -2842,7 +2842,7 @@
           <p:cNvPr id="37" name="">
             <a:extLst xmlns:a="http://schemas.openxmlformats.org/drawingml/2006/main">
               <a:ext uri="{FF2B5EF4-FFF2-40B4-BE49-F238E27FC236}">
-                <a16:creationId xmlns:a16="http://schemas.microsoft.com/office/drawing/2014/main" id="{514260D8-14D3-4C9F-A749-126D41B76CE1}"/>
+                <a16:creationId xmlns:a16="http://schemas.microsoft.com/office/drawing/2014/main" id="{E8222208-6FD3-4348-B4FD-2A554EB8593F}"/>
               </a:ext>
             </a:extLst>
           </p:cNvPr>
@@ -2904,7 +2904,7 @@
           <p:cNvPr id="38" name="">
             <a:extLst xmlns:a="http://schemas.openxmlformats.org/drawingml/2006/main">
               <a:ext uri="{FF2B5EF4-FFF2-40B4-BE49-F238E27FC236}">
-                <a16:creationId xmlns:a16="http://schemas.microsoft.com/office/drawing/2014/main" id="{AE328369-3F96-458E-9DFC-CE3FDD251B39}"/>
+                <a16:creationId xmlns:a16="http://schemas.microsoft.com/office/drawing/2014/main" id="{6A4A01D4-BAED-46ED-A71B-1D87CCA36A40}"/>
               </a:ext>
             </a:extLst>
           </p:cNvPr>
@@ -2966,7 +2966,7 @@
           <p:cNvPr id="39" name="">
             <a:extLst xmlns:a="http://schemas.openxmlformats.org/drawingml/2006/main">
               <a:ext uri="{FF2B5EF4-FFF2-40B4-BE49-F238E27FC236}">
-                <a16:creationId xmlns:a16="http://schemas.microsoft.com/office/drawing/2014/main" id="{020A1843-AABC-40B8-BF03-BB874AB295B2}"/>
+                <a16:creationId xmlns:a16="http://schemas.microsoft.com/office/drawing/2014/main" id="{387416B8-04D5-4EAE-ACE1-486520F8F377}"/>
               </a:ext>
             </a:extLst>
           </p:cNvPr>
@@ -2997,7 +2997,7 @@
           <p:cNvPr id="40" name="">
             <a:extLst xmlns:a="http://schemas.openxmlformats.org/drawingml/2006/main">
               <a:ext uri="{FF2B5EF4-FFF2-40B4-BE49-F238E27FC236}">
-                <a16:creationId xmlns:a16="http://schemas.microsoft.com/office/drawing/2014/main" id="{2374792E-FB16-422A-BF92-2281E169222E}"/>
+                <a16:creationId xmlns:a16="http://schemas.microsoft.com/office/drawing/2014/main" id="{971EB52F-51C7-4A0C-A59E-F9589E077ABE}"/>
               </a:ext>
             </a:extLst>
           </p:cNvPr>
@@ -3028,7 +3028,7 @@
           <p:cNvPr id="41" name="">
             <a:extLst xmlns:a="http://schemas.openxmlformats.org/drawingml/2006/main">
               <a:ext uri="{FF2B5EF4-FFF2-40B4-BE49-F238E27FC236}">
-                <a16:creationId xmlns:a16="http://schemas.microsoft.com/office/drawing/2014/main" id="{15D31FB9-17D4-49A3-81A5-E8966DF699FC}"/>
+                <a16:creationId xmlns:a16="http://schemas.microsoft.com/office/drawing/2014/main" id="{18D91C3A-24F8-4EFE-AA20-B29F038B5ADD}"/>
               </a:ext>
             </a:extLst>
           </p:cNvPr>
@@ -3059,7 +3059,7 @@
           <p:cNvPr id="42" name="">
             <a:extLst xmlns:a="http://schemas.openxmlformats.org/drawingml/2006/main">
               <a:ext uri="{FF2B5EF4-FFF2-40B4-BE49-F238E27FC236}">
-                <a16:creationId xmlns:a16="http://schemas.microsoft.com/office/drawing/2014/main" id="{BB9B1E1E-388A-42A6-A40E-4EAEBE942B92}"/>
+                <a16:creationId xmlns:a16="http://schemas.microsoft.com/office/drawing/2014/main" id="{DCC3D383-5D4A-4744-B20D-6DB4406A8598}"/>
               </a:ext>
             </a:extLst>
           </p:cNvPr>
@@ -3090,7 +3090,7 @@
           <p:cNvPr id="43" name="">
             <a:extLst xmlns:a="http://schemas.openxmlformats.org/drawingml/2006/main">
               <a:ext uri="{FF2B5EF4-FFF2-40B4-BE49-F238E27FC236}">
-                <a16:creationId xmlns:a16="http://schemas.microsoft.com/office/drawing/2014/main" id="{FC966792-6D8A-4D7B-AC83-6D37C7657E54}"/>
+                <a16:creationId xmlns:a16="http://schemas.microsoft.com/office/drawing/2014/main" id="{89B7BBED-1755-4DA7-8CF5-1C73B5A5A030}"/>
               </a:ext>
             </a:extLst>
           </p:cNvPr>
@@ -3121,7 +3121,7 @@
           <p:cNvPr id="44" name="">
             <a:extLst xmlns:a="http://schemas.openxmlformats.org/drawingml/2006/main">
               <a:ext uri="{FF2B5EF4-FFF2-40B4-BE49-F238E27FC236}">
-                <a16:creationId xmlns:a16="http://schemas.microsoft.com/office/drawing/2014/main" id="{F30FDFF2-B9C6-4C23-9DA7-A13A267D70E3}"/>
+                <a16:creationId xmlns:a16="http://schemas.microsoft.com/office/drawing/2014/main" id="{5DF20E9B-9B1C-4DBF-99E5-98405E47E3F2}"/>
               </a:ext>
             </a:extLst>
           </p:cNvPr>
@@ -3152,7 +3152,7 @@
           <p:cNvPr id="45" name="">
             <a:extLst xmlns:a="http://schemas.openxmlformats.org/drawingml/2006/main">
               <a:ext uri="{FF2B5EF4-FFF2-40B4-BE49-F238E27FC236}">
-                <a16:creationId xmlns:a16="http://schemas.microsoft.com/office/drawing/2014/main" id="{9134A434-D6D2-4BCB-94D4-D7478B64B091}"/>
+                <a16:creationId xmlns:a16="http://schemas.microsoft.com/office/drawing/2014/main" id="{E6568C38-E7BD-4762-9118-C2645F253A75}"/>
               </a:ext>
             </a:extLst>
           </p:cNvPr>
@@ -3183,7 +3183,7 @@
           <p:cNvPr id="46" name="">
             <a:extLst xmlns:a="http://schemas.openxmlformats.org/drawingml/2006/main">
               <a:ext uri="{FF2B5EF4-FFF2-40B4-BE49-F238E27FC236}">
-                <a16:creationId xmlns:a16="http://schemas.microsoft.com/office/drawing/2014/main" id="{2988DD6D-E588-45B5-AD69-9F4993AC591B}"/>
+                <a16:creationId xmlns:a16="http://schemas.microsoft.com/office/drawing/2014/main" id="{F7FFB08A-124B-4D0F-943E-7B2109B0F231}"/>
               </a:ext>
             </a:extLst>
           </p:cNvPr>
@@ -3214,7 +3214,7 @@
           <p:cNvPr id="47" name="">
             <a:extLst xmlns:a="http://schemas.openxmlformats.org/drawingml/2006/main">
               <a:ext uri="{FF2B5EF4-FFF2-40B4-BE49-F238E27FC236}">
-                <a16:creationId xmlns:a16="http://schemas.microsoft.com/office/drawing/2014/main" id="{890C9ECE-ABCC-4DBA-B01E-F7D3861BEE47}"/>
+                <a16:creationId xmlns:a16="http://schemas.microsoft.com/office/drawing/2014/main" id="{6529ADC4-0175-4CFA-B4C5-F2F39E40E533}"/>
               </a:ext>
             </a:extLst>
           </p:cNvPr>
@@ -3245,7 +3245,7 @@
           <p:cNvPr id="48" name="">
             <a:extLst xmlns:a="http://schemas.openxmlformats.org/drawingml/2006/main">
               <a:ext uri="{FF2B5EF4-FFF2-40B4-BE49-F238E27FC236}">
-                <a16:creationId xmlns:a16="http://schemas.microsoft.com/office/drawing/2014/main" id="{4F80AA60-DF77-40A1-B68A-32FF4813F68A}"/>
+                <a16:creationId xmlns:a16="http://schemas.microsoft.com/office/drawing/2014/main" id="{4000B908-15EC-475C-9760-FBD4CD396503}"/>
               </a:ext>
             </a:extLst>
           </p:cNvPr>
@@ -3276,7 +3276,7 @@
           <p:cNvPr id="49" name="">
             <a:extLst xmlns:a="http://schemas.openxmlformats.org/drawingml/2006/main">
               <a:ext uri="{FF2B5EF4-FFF2-40B4-BE49-F238E27FC236}">
-                <a16:creationId xmlns:a16="http://schemas.microsoft.com/office/drawing/2014/main" id="{8C1E1E6C-FDB5-4B16-A871-E1C3AD9D382D}"/>
+                <a16:creationId xmlns:a16="http://schemas.microsoft.com/office/drawing/2014/main" id="{322E7363-FC0C-4CEA-A50C-C43104711B4D}"/>
               </a:ext>
             </a:extLst>
           </p:cNvPr>
@@ -3307,7 +3307,7 @@
           <p:cNvPr id="50" name="">
             <a:extLst xmlns:a="http://schemas.openxmlformats.org/drawingml/2006/main">
               <a:ext uri="{FF2B5EF4-FFF2-40B4-BE49-F238E27FC236}">
-                <a16:creationId xmlns:a16="http://schemas.microsoft.com/office/drawing/2014/main" id="{A5D6DF0F-D7E8-471A-B9E0-780E0BC0A49E}"/>
+                <a16:creationId xmlns:a16="http://schemas.microsoft.com/office/drawing/2014/main" id="{81376470-E265-47E1-B857-88212CEF1638}"/>
               </a:ext>
             </a:extLst>
           </p:cNvPr>
@@ -3338,7 +3338,7 @@
           <p:cNvPr id="51" name="">
             <a:extLst xmlns:a="http://schemas.openxmlformats.org/drawingml/2006/main">
               <a:ext uri="{FF2B5EF4-FFF2-40B4-BE49-F238E27FC236}">
-                <a16:creationId xmlns:a16="http://schemas.microsoft.com/office/drawing/2014/main" id="{0E2DA911-5E96-491B-A394-53BD0FC14B22}"/>
+                <a16:creationId xmlns:a16="http://schemas.microsoft.com/office/drawing/2014/main" id="{2C177C40-A048-4FAF-81A5-A6DE87342F89}"/>
               </a:ext>
             </a:extLst>
           </p:cNvPr>
@@ -3373,7 +3373,7 @@
           <p:cNvPr id="52" name="">
             <a:extLst xmlns:a="http://schemas.openxmlformats.org/drawingml/2006/main">
               <a:ext uri="{FF2B5EF4-FFF2-40B4-BE49-F238E27FC236}">
-                <a16:creationId xmlns:a16="http://schemas.microsoft.com/office/drawing/2014/main" id="{400B420E-7B76-437C-B709-BD7FB9C587B4}"/>
+                <a16:creationId xmlns:a16="http://schemas.microsoft.com/office/drawing/2014/main" id="{8FFDECC8-13C4-4EE7-B1D1-705A246DAC5B}"/>
               </a:ext>
             </a:extLst>
           </p:cNvPr>
@@ -3408,7 +3408,7 @@
           <p:cNvPr id="53" name="">
             <a:extLst xmlns:a="http://schemas.openxmlformats.org/drawingml/2006/main">
               <a:ext uri="{FF2B5EF4-FFF2-40B4-BE49-F238E27FC236}">
-                <a16:creationId xmlns:a16="http://schemas.microsoft.com/office/drawing/2014/main" id="{B934C748-77D6-45C4-B9A0-AAE60E9E982A}"/>
+                <a16:creationId xmlns:a16="http://schemas.microsoft.com/office/drawing/2014/main" id="{28FFE4D6-EDFB-4893-8D60-ADC5A77A7E6C}"/>
               </a:ext>
             </a:extLst>
           </p:cNvPr>
@@ -3443,7 +3443,7 @@
           <p:cNvPr id="54" name="">
             <a:extLst xmlns:a="http://schemas.openxmlformats.org/drawingml/2006/main">
               <a:ext uri="{FF2B5EF4-FFF2-40B4-BE49-F238E27FC236}">
-                <a16:creationId xmlns:a16="http://schemas.microsoft.com/office/drawing/2014/main" id="{64567D3A-72EB-4E9D-9AC0-EA4C36C93243}"/>
+                <a16:creationId xmlns:a16="http://schemas.microsoft.com/office/drawing/2014/main" id="{C816A620-5447-4A64-A86C-877C80C0B27D}"/>
               </a:ext>
             </a:extLst>
           </p:cNvPr>
@@ -3478,7 +3478,7 @@
           <p:cNvPr id="55" name="">
             <a:extLst xmlns:a="http://schemas.openxmlformats.org/drawingml/2006/main">
               <a:ext uri="{FF2B5EF4-FFF2-40B4-BE49-F238E27FC236}">
-                <a16:creationId xmlns:a16="http://schemas.microsoft.com/office/drawing/2014/main" id="{472F3916-1335-4659-B22D-C7D37D641A52}"/>
+                <a16:creationId xmlns:a16="http://schemas.microsoft.com/office/drawing/2014/main" id="{3858B579-31C8-4791-8B70-D27B481D8CE3}"/>
               </a:ext>
             </a:extLst>
           </p:cNvPr>
@@ -3540,7 +3540,7 @@
           <p:cNvPr id="56" name="">
             <a:extLst xmlns:a="http://schemas.openxmlformats.org/drawingml/2006/main">
               <a:ext uri="{FF2B5EF4-FFF2-40B4-BE49-F238E27FC236}">
-                <a16:creationId xmlns:a16="http://schemas.microsoft.com/office/drawing/2014/main" id="{BB59C769-4154-4268-B039-6868B8C9490C}"/>
+                <a16:creationId xmlns:a16="http://schemas.microsoft.com/office/drawing/2014/main" id="{9ABDD57F-0C14-472E-971A-F6C642F61A11}"/>
               </a:ext>
             </a:extLst>
           </p:cNvPr>
@@ -3602,7 +3602,7 @@
           <p:cNvPr id="57" name="">
             <a:extLst xmlns:a="http://schemas.openxmlformats.org/drawingml/2006/main">
               <a:ext uri="{FF2B5EF4-FFF2-40B4-BE49-F238E27FC236}">
-                <a16:creationId xmlns:a16="http://schemas.microsoft.com/office/drawing/2014/main" id="{357098A8-74C3-4E57-94DC-6D80CB587DB4}"/>
+                <a16:creationId xmlns:a16="http://schemas.microsoft.com/office/drawing/2014/main" id="{8E0B39B5-9CAE-4E93-B65F-C64F83A4566F}"/>
               </a:ext>
             </a:extLst>
           </p:cNvPr>
@@ -3664,7 +3664,7 @@
           <p:cNvPr id="58" name="">
             <a:extLst xmlns:a="http://schemas.openxmlformats.org/drawingml/2006/main">
               <a:ext uri="{FF2B5EF4-FFF2-40B4-BE49-F238E27FC236}">
-                <a16:creationId xmlns:a16="http://schemas.microsoft.com/office/drawing/2014/main" id="{6450C1B7-2966-465C-A858-EFB3CBD110D6}"/>
+                <a16:creationId xmlns:a16="http://schemas.microsoft.com/office/drawing/2014/main" id="{B75A09CC-25BB-4BC7-8AAD-F23ED7783908}"/>
               </a:ext>
             </a:extLst>
           </p:cNvPr>
@@ -3697,7 +3697,7 @@
           <p:cNvPr id="59" name="">
             <a:extLst xmlns:a="http://schemas.openxmlformats.org/drawingml/2006/main">
               <a:ext uri="{FF2B5EF4-FFF2-40B4-BE49-F238E27FC236}">
-                <a16:creationId xmlns:a16="http://schemas.microsoft.com/office/drawing/2014/main" id="{68D11D40-9600-4F64-BC71-430EBEE85D43}"/>
+                <a16:creationId xmlns:a16="http://schemas.microsoft.com/office/drawing/2014/main" id="{7D9ABD16-A0D0-4C4B-9AF5-E526602CE610}"/>
               </a:ext>
             </a:extLst>
           </p:cNvPr>
@@ -3730,7 +3730,7 @@
           <p:cNvPr id="60" name="">
             <a:extLst xmlns:a="http://schemas.openxmlformats.org/drawingml/2006/main">
               <a:ext uri="{FF2B5EF4-FFF2-40B4-BE49-F238E27FC236}">
-                <a16:creationId xmlns:a16="http://schemas.microsoft.com/office/drawing/2014/main" id="{FC17331B-5883-498F-AAAE-86E37D0F4073}"/>
+                <a16:creationId xmlns:a16="http://schemas.microsoft.com/office/drawing/2014/main" id="{EC2D4D1A-DF56-413C-A385-83BBA02646E9}"/>
               </a:ext>
             </a:extLst>
           </p:cNvPr>
@@ -3763,7 +3763,7 @@
           <p:cNvPr id="61" name="">
             <a:extLst xmlns:a="http://schemas.openxmlformats.org/drawingml/2006/main">
               <a:ext uri="{FF2B5EF4-FFF2-40B4-BE49-F238E27FC236}">
-                <a16:creationId xmlns:a16="http://schemas.microsoft.com/office/drawing/2014/main" id="{DF7376A1-CAE8-4082-8738-F8D19D2C0C6B}"/>
+                <a16:creationId xmlns:a16="http://schemas.microsoft.com/office/drawing/2014/main" id="{1449FD76-4A22-4A76-9766-58DDFB3763E1}"/>
               </a:ext>
             </a:extLst>
           </p:cNvPr>
@@ -3825,7 +3825,7 @@
           <p:cNvPr id="62" name="">
             <a:extLst xmlns:a="http://schemas.openxmlformats.org/drawingml/2006/main">
               <a:ext uri="{FF2B5EF4-FFF2-40B4-BE49-F238E27FC236}">
-                <a16:creationId xmlns:a16="http://schemas.microsoft.com/office/drawing/2014/main" id="{BD30A92B-1022-4DB5-8645-CC6CFB6DC430}"/>
+                <a16:creationId xmlns:a16="http://schemas.microsoft.com/office/drawing/2014/main" id="{08E5C96D-5AB0-4ABB-B943-20EE12D232A8}"/>
               </a:ext>
             </a:extLst>
           </p:cNvPr>
@@ -3887,7 +3887,7 @@
           <p:cNvPr id="63" name="">
             <a:extLst xmlns:a="http://schemas.openxmlformats.org/drawingml/2006/main">
               <a:ext uri="{FF2B5EF4-FFF2-40B4-BE49-F238E27FC236}">
-                <a16:creationId xmlns:a16="http://schemas.microsoft.com/office/drawing/2014/main" id="{72217DBF-4E4A-4478-9DD5-710284C2056E}"/>
+                <a16:creationId xmlns:a16="http://schemas.microsoft.com/office/drawing/2014/main" id="{D8A626C9-D435-452F-BC62-39D323150308}"/>
               </a:ext>
             </a:extLst>
           </p:cNvPr>
@@ -3949,7 +3949,7 @@
           <p:cNvPr id="64" name="">
             <a:extLst xmlns:a="http://schemas.openxmlformats.org/drawingml/2006/main">
               <a:ext uri="{FF2B5EF4-FFF2-40B4-BE49-F238E27FC236}">
-                <a16:creationId xmlns:a16="http://schemas.microsoft.com/office/drawing/2014/main" id="{0B9CAD37-510C-4973-BE68-9AC8BA050A54}"/>
+                <a16:creationId xmlns:a16="http://schemas.microsoft.com/office/drawing/2014/main" id="{3C15188C-388D-4DC4-B7D4-69AAB8DA3EB8}"/>
               </a:ext>
             </a:extLst>
           </p:cNvPr>
@@ -3984,7 +3984,7 @@
           <p:cNvPr id="65" name="">
             <a:extLst xmlns:a="http://schemas.openxmlformats.org/drawingml/2006/main">
               <a:ext uri="{FF2B5EF4-FFF2-40B4-BE49-F238E27FC236}">
-                <a16:creationId xmlns:a16="http://schemas.microsoft.com/office/drawing/2014/main" id="{2CFEADB2-692A-40B9-BE02-5DBB25EAC81A}"/>
+                <a16:creationId xmlns:a16="http://schemas.microsoft.com/office/drawing/2014/main" id="{AA4284B2-205B-4A87-B7DC-E02FF71FFA88}"/>
               </a:ext>
             </a:extLst>
           </p:cNvPr>
@@ -4046,7 +4046,7 @@
           <p:cNvPr id="66" name="">
             <a:extLst xmlns:a="http://schemas.openxmlformats.org/drawingml/2006/main">
               <a:ext uri="{FF2B5EF4-FFF2-40B4-BE49-F238E27FC236}">
-                <a16:creationId xmlns:a16="http://schemas.microsoft.com/office/drawing/2014/main" id="{7D5C5D26-4CF9-4237-BB31-C023A8AC73F9}"/>
+                <a16:creationId xmlns:a16="http://schemas.microsoft.com/office/drawing/2014/main" id="{445A97FD-3303-4217-8EAE-4DD9B008EE9D}"/>
               </a:ext>
             </a:extLst>
           </p:cNvPr>
@@ -4108,7 +4108,7 @@
           <p:cNvPr id="67" name="">
             <a:extLst xmlns:a="http://schemas.openxmlformats.org/drawingml/2006/main">
               <a:ext uri="{FF2B5EF4-FFF2-40B4-BE49-F238E27FC236}">
-                <a16:creationId xmlns:a16="http://schemas.microsoft.com/office/drawing/2014/main" id="{1CF70706-81B6-4F8C-984A-94A179405DEE}"/>
+                <a16:creationId xmlns:a16="http://schemas.microsoft.com/office/drawing/2014/main" id="{CD1ABFDB-815B-4D36-A457-D7C7872B78E3}"/>
               </a:ext>
             </a:extLst>
           </p:cNvPr>
@@ -4170,7 +4170,7 @@
           <p:cNvPr id="68" name="">
             <a:extLst xmlns:a="http://schemas.openxmlformats.org/drawingml/2006/main">
               <a:ext uri="{FF2B5EF4-FFF2-40B4-BE49-F238E27FC236}">
-                <a16:creationId xmlns:a16="http://schemas.microsoft.com/office/drawing/2014/main" id="{D56FAB0E-BDFD-4EC5-B946-4A5A08B63A21}"/>
+                <a16:creationId xmlns:a16="http://schemas.microsoft.com/office/drawing/2014/main" id="{93516AC2-40A7-4B51-8A91-347386B638A4}"/>
               </a:ext>
             </a:extLst>
           </p:cNvPr>
@@ -4205,7 +4205,7 @@
           <p:cNvPr id="69" name="">
             <a:extLst xmlns:a="http://schemas.openxmlformats.org/drawingml/2006/main">
               <a:ext uri="{FF2B5EF4-FFF2-40B4-BE49-F238E27FC236}">
-                <a16:creationId xmlns:a16="http://schemas.microsoft.com/office/drawing/2014/main" id="{29D3A18D-B898-44EC-8C3B-63C6E9C3939E}"/>
+                <a16:creationId xmlns:a16="http://schemas.microsoft.com/office/drawing/2014/main" id="{65D18788-CDB0-40D5-A94E-DF2255614DC1}"/>
               </a:ext>
             </a:extLst>
           </p:cNvPr>
@@ -4267,7 +4267,7 @@
           <p:cNvPr id="70" name="">
             <a:extLst xmlns:a="http://schemas.openxmlformats.org/drawingml/2006/main">
               <a:ext uri="{FF2B5EF4-FFF2-40B4-BE49-F238E27FC236}">
-                <a16:creationId xmlns:a16="http://schemas.microsoft.com/office/drawing/2014/main" id="{069C3A79-DD63-421B-9963-4D39F80A99FA}"/>
+                <a16:creationId xmlns:a16="http://schemas.microsoft.com/office/drawing/2014/main" id="{B2D6813D-EBBD-4023-8A31-D613750390F6}"/>
               </a:ext>
             </a:extLst>
           </p:cNvPr>
@@ -4329,7 +4329,7 @@
           <p:cNvPr id="71" name="">
             <a:extLst xmlns:a="http://schemas.openxmlformats.org/drawingml/2006/main">
               <a:ext uri="{FF2B5EF4-FFF2-40B4-BE49-F238E27FC236}">
-                <a16:creationId xmlns:a16="http://schemas.microsoft.com/office/drawing/2014/main" id="{437C716C-F869-4B84-91B9-32A346FE51B4}"/>
+                <a16:creationId xmlns:a16="http://schemas.microsoft.com/office/drawing/2014/main" id="{6A7B332A-B10A-44AF-A4F4-352446284F7D}"/>
               </a:ext>
             </a:extLst>
           </p:cNvPr>
@@ -4391,7 +4391,7 @@
           <p:cNvPr id="72" name="">
             <a:extLst xmlns:a="http://schemas.openxmlformats.org/drawingml/2006/main">
               <a:ext uri="{FF2B5EF4-FFF2-40B4-BE49-F238E27FC236}">
-                <a16:creationId xmlns:a16="http://schemas.microsoft.com/office/drawing/2014/main" id="{12646757-E930-4876-9B3B-96F4B2D9A335}"/>
+                <a16:creationId xmlns:a16="http://schemas.microsoft.com/office/drawing/2014/main" id="{B954E4C3-FA4E-4F1A-B5EE-AF7B1DE13105}"/>
               </a:ext>
             </a:extLst>
           </p:cNvPr>
@@ -4426,7 +4426,7 @@
           <p:cNvPr id="73" name="">
             <a:extLst xmlns:a="http://schemas.openxmlformats.org/drawingml/2006/main">
               <a:ext uri="{FF2B5EF4-FFF2-40B4-BE49-F238E27FC236}">
-                <a16:creationId xmlns:a16="http://schemas.microsoft.com/office/drawing/2014/main" id="{D8FF7963-B13F-494B-85D2-DF6D9B414DB7}"/>
+                <a16:creationId xmlns:a16="http://schemas.microsoft.com/office/drawing/2014/main" id="{07017E91-DF9F-46F1-853E-DE1FC1F80E79}"/>
               </a:ext>
             </a:extLst>
           </p:cNvPr>
@@ -4488,7 +4488,7 @@
           <p:cNvPr id="74" name="">
             <a:extLst xmlns:a="http://schemas.openxmlformats.org/drawingml/2006/main">
               <a:ext uri="{FF2B5EF4-FFF2-40B4-BE49-F238E27FC236}">
-                <a16:creationId xmlns:a16="http://schemas.microsoft.com/office/drawing/2014/main" id="{1900733D-1A60-4581-BA33-D0B66ED2C957}"/>
+                <a16:creationId xmlns:a16="http://schemas.microsoft.com/office/drawing/2014/main" id="{9B69AFF1-5ECD-4A38-A431-32016638B2F6}"/>
               </a:ext>
             </a:extLst>
           </p:cNvPr>
@@ -4550,7 +4550,7 @@
           <p:cNvPr id="75" name="">
             <a:extLst xmlns:a="http://schemas.openxmlformats.org/drawingml/2006/main">
               <a:ext uri="{FF2B5EF4-FFF2-40B4-BE49-F238E27FC236}">
-                <a16:creationId xmlns:a16="http://schemas.microsoft.com/office/drawing/2014/main" id="{796904FB-D73C-4837-8532-62087F348EF3}"/>
+                <a16:creationId xmlns:a16="http://schemas.microsoft.com/office/drawing/2014/main" id="{5420F558-3F1B-42B2-84BC-DD57F42194C9}"/>
               </a:ext>
             </a:extLst>
           </p:cNvPr>
@@ -4612,7 +4612,7 @@
           <p:cNvPr id="76" name="">
             <a:extLst xmlns:a="http://schemas.openxmlformats.org/drawingml/2006/main">
               <a:ext uri="{FF2B5EF4-FFF2-40B4-BE49-F238E27FC236}">
-                <a16:creationId xmlns:a16="http://schemas.microsoft.com/office/drawing/2014/main" id="{02CF814D-814D-4F2C-88DC-C2C58F31BB83}"/>
+                <a16:creationId xmlns:a16="http://schemas.microsoft.com/office/drawing/2014/main" id="{44F69EAE-A4CB-4AAE-BB1D-EBD4B83D4030}"/>
               </a:ext>
             </a:extLst>
           </p:cNvPr>
@@ -4647,7 +4647,7 @@
           <p:cNvPr id="77" name="">
             <a:extLst xmlns:a="http://schemas.openxmlformats.org/drawingml/2006/main">
               <a:ext uri="{FF2B5EF4-FFF2-40B4-BE49-F238E27FC236}">
-                <a16:creationId xmlns:a16="http://schemas.microsoft.com/office/drawing/2014/main" id="{D5FFF970-DCBD-403B-86E2-874D696F0791}"/>
+                <a16:creationId xmlns:a16="http://schemas.microsoft.com/office/drawing/2014/main" id="{4A68049E-BCD1-4231-B26A-B02413205211}"/>
               </a:ext>
             </a:extLst>
           </p:cNvPr>
@@ -4709,7 +4709,7 @@
           <p:cNvPr id="78" name="">
             <a:extLst xmlns:a="http://schemas.openxmlformats.org/drawingml/2006/main">
               <a:ext uri="{FF2B5EF4-FFF2-40B4-BE49-F238E27FC236}">
-                <a16:creationId xmlns:a16="http://schemas.microsoft.com/office/drawing/2014/main" id="{8690015C-C5CB-421E-A3BF-23D1C7667E61}"/>
+                <a16:creationId xmlns:a16="http://schemas.microsoft.com/office/drawing/2014/main" id="{4D30C294-B214-4454-9175-8E4C38F9364D}"/>
               </a:ext>
             </a:extLst>
           </p:cNvPr>
@@ -4744,7 +4744,7 @@
           <p:cNvPr id="79" name="">
             <a:extLst xmlns:a="http://schemas.openxmlformats.org/drawingml/2006/main">
               <a:ext uri="{FF2B5EF4-FFF2-40B4-BE49-F238E27FC236}">
-                <a16:creationId xmlns:a16="http://schemas.microsoft.com/office/drawing/2014/main" id="{B2B886EB-8363-48E0-8179-947CD63FE310}"/>
+                <a16:creationId xmlns:a16="http://schemas.microsoft.com/office/drawing/2014/main" id="{AE46E8AC-6090-471B-A100-321A5A914908}"/>
               </a:ext>
             </a:extLst>
           </p:cNvPr>
@@ -4806,7 +4806,7 @@
           <p:cNvPr id="80" name="">
             <a:extLst xmlns:a="http://schemas.openxmlformats.org/drawingml/2006/main">
               <a:ext uri="{FF2B5EF4-FFF2-40B4-BE49-F238E27FC236}">
-                <a16:creationId xmlns:a16="http://schemas.microsoft.com/office/drawing/2014/main" id="{A033D371-FE5F-4FB8-84D3-AD2DCECF1056}"/>
+                <a16:creationId xmlns:a16="http://schemas.microsoft.com/office/drawing/2014/main" id="{C70436D6-4B78-4843-8430-8B8230DE7183}"/>
               </a:ext>
             </a:extLst>
           </p:cNvPr>
@@ -4868,7 +4868,7 @@
           <p:cNvPr id="81" name="">
             <a:extLst xmlns:a="http://schemas.openxmlformats.org/drawingml/2006/main">
               <a:ext uri="{FF2B5EF4-FFF2-40B4-BE49-F238E27FC236}">
-                <a16:creationId xmlns:a16="http://schemas.microsoft.com/office/drawing/2014/main" id="{C26BD906-9A6E-4CC5-8876-D4E3553E3442}"/>
+                <a16:creationId xmlns:a16="http://schemas.microsoft.com/office/drawing/2014/main" id="{16EEB6CB-606A-4335-A15F-52469242DB06}"/>
               </a:ext>
             </a:extLst>
           </p:cNvPr>
@@ -4930,7 +4930,7 @@
           <p:cNvPr id="82" name="">
             <a:extLst xmlns:a="http://schemas.openxmlformats.org/drawingml/2006/main">
               <a:ext uri="{FF2B5EF4-FFF2-40B4-BE49-F238E27FC236}">
-                <a16:creationId xmlns:a16="http://schemas.microsoft.com/office/drawing/2014/main" id="{93362F8F-3018-4B3F-B3D0-12BBEE9F4E40}"/>
+                <a16:creationId xmlns:a16="http://schemas.microsoft.com/office/drawing/2014/main" id="{11249D7C-A7CD-4D28-86F8-FA5D9611EB37}"/>
               </a:ext>
             </a:extLst>
           </p:cNvPr>
@@ -4981,7 +4981,7 @@
                 <a:latin typeface="Arial"/>
                 <a:ea typeface="Arial"/>
                 <a:cs typeface="Arial"/>
-                <a:hlinkClick xmlns:r="http://schemas.openxmlformats.org/officeDocument/2006/relationships" r:id="R16c465af0c1b4d6f"/>
+                <a:hlinkClick xmlns:r="http://schemas.openxmlformats.org/officeDocument/2006/relationships" r:id="Rd0cb60a1616a4eb6"/>
               </a:rPr>
               <a:t>READ THE FULL BRIEF  →  BRIEF.BRIDGEXCAPITAL.AI</a:t>
             </a:r>
@@ -4993,7 +4993,7 @@
           <p:cNvPr id="83" name="">
             <a:extLst xmlns:a="http://schemas.openxmlformats.org/drawingml/2006/main">
               <a:ext uri="{FF2B5EF4-FFF2-40B4-BE49-F238E27FC236}">
-                <a16:creationId xmlns:a16="http://schemas.microsoft.com/office/drawing/2014/main" id="{4E22113D-2958-4ADC-802C-4BA85BD87DDD}"/>
+                <a16:creationId xmlns:a16="http://schemas.microsoft.com/office/drawing/2014/main" id="{91592140-FFC2-494A-B340-0A22B24BBD15}"/>
               </a:ext>
             </a:extLst>
           </p:cNvPr>
@@ -5053,7 +5053,7 @@
     </p:spTree>
     <p:extLst>
       <p:ext uri="{BB962C8B-B14F-4D97-AF65-F5344CB8AC3E}">
-        <p14:creationId xmlns:p14="http://schemas.microsoft.com/office/powerpoint/2010/main" val="564868238"/>
+        <p14:creationId xmlns:p14="http://schemas.microsoft.com/office/powerpoint/2010/main" val="909739851"/>
       </p:ext>
     </p:extLst>
   </p:cSld>
@@ -5084,7 +5084,7 @@
           <p:cNvPr id="57" name="">
             <a:extLst xmlns:a="http://schemas.openxmlformats.org/drawingml/2006/main">
               <a:ext uri="{FF2B5EF4-FFF2-40B4-BE49-F238E27FC236}">
-                <a16:creationId xmlns:a16="http://schemas.microsoft.com/office/drawing/2014/main" id="{A1ED22DC-C792-417F-9A73-14835A8FE7D2}"/>
+                <a16:creationId xmlns:a16="http://schemas.microsoft.com/office/drawing/2014/main" id="{D2DAC778-6D49-4210-94E1-F718015D4112}"/>
               </a:ext>
             </a:extLst>
           </p:cNvPr>
@@ -5115,7 +5115,7 @@
           <p:cNvPr id="2" name="">
             <a:extLst xmlns:a="http://schemas.openxmlformats.org/drawingml/2006/main">
               <a:ext uri="{FF2B5EF4-FFF2-40B4-BE49-F238E27FC236}">
-                <a16:creationId xmlns:a16="http://schemas.microsoft.com/office/drawing/2014/main" id="{62EC3718-8E6C-40A4-BA8B-7C5F416E7A9D}"/>
+                <a16:creationId xmlns:a16="http://schemas.microsoft.com/office/drawing/2014/main" id="{0294A183-98E7-4E5E-BDB4-5FC9290A6EDA}"/>
               </a:ext>
             </a:extLst>
           </p:cNvPr>
@@ -5146,7 +5146,7 @@
           <p:cNvPr id="3" name="">
             <a:extLst xmlns:a="http://schemas.openxmlformats.org/drawingml/2006/main">
               <a:ext uri="{FF2B5EF4-FFF2-40B4-BE49-F238E27FC236}">
-                <a16:creationId xmlns:a16="http://schemas.microsoft.com/office/drawing/2014/main" id="{2D8DB43E-C260-4788-B898-6B9A821455A2}"/>
+                <a16:creationId xmlns:a16="http://schemas.microsoft.com/office/drawing/2014/main" id="{153F437F-0518-4B45-95C4-9C64AB5C3EA7}"/>
               </a:ext>
             </a:extLst>
           </p:cNvPr>
@@ -5177,7 +5177,7 @@
           <p:cNvPr id="4" name="">
             <a:extLst xmlns:a="http://schemas.openxmlformats.org/drawingml/2006/main">
               <a:ext uri="{FF2B5EF4-FFF2-40B4-BE49-F238E27FC236}">
-                <a16:creationId xmlns:a16="http://schemas.microsoft.com/office/drawing/2014/main" id="{5189A0CE-02B1-4B16-8F66-CE2B350A3985}"/>
+                <a16:creationId xmlns:a16="http://schemas.microsoft.com/office/drawing/2014/main" id="{D5F127F3-7A54-4D27-B0E0-1227E2311A24}"/>
               </a:ext>
             </a:extLst>
           </p:cNvPr>
@@ -5208,7 +5208,7 @@
           <p:cNvPr id="5" name="">
             <a:extLst xmlns:a="http://schemas.openxmlformats.org/drawingml/2006/main">
               <a:ext uri="{FF2B5EF4-FFF2-40B4-BE49-F238E27FC236}">
-                <a16:creationId xmlns:a16="http://schemas.microsoft.com/office/drawing/2014/main" id="{D0536A07-5EE8-4488-B5EE-ABD7668E7A17}"/>
+                <a16:creationId xmlns:a16="http://schemas.microsoft.com/office/drawing/2014/main" id="{21E1925D-84FA-4EB0-86FD-C13C2A18ABDB}"/>
               </a:ext>
             </a:extLst>
           </p:cNvPr>
@@ -5239,7 +5239,7 @@
           <p:cNvPr id="6" name="">
             <a:extLst xmlns:a="http://schemas.openxmlformats.org/drawingml/2006/main">
               <a:ext uri="{FF2B5EF4-FFF2-40B4-BE49-F238E27FC236}">
-                <a16:creationId xmlns:a16="http://schemas.microsoft.com/office/drawing/2014/main" id="{E7B5338E-6C30-4C17-8F04-F9D0EE410D06}"/>
+                <a16:creationId xmlns:a16="http://schemas.microsoft.com/office/drawing/2014/main" id="{B8A41796-5170-4BDE-A4FB-88A6BFBC4141}"/>
               </a:ext>
             </a:extLst>
           </p:cNvPr>
@@ -5270,7 +5270,7 @@
           <p:cNvPr id="7" name="">
             <a:extLst xmlns:a="http://schemas.openxmlformats.org/drawingml/2006/main">
               <a:ext uri="{FF2B5EF4-FFF2-40B4-BE49-F238E27FC236}">
-                <a16:creationId xmlns:a16="http://schemas.microsoft.com/office/drawing/2014/main" id="{717D93ED-C4CB-49F2-8496-61CA94D477B0}"/>
+                <a16:creationId xmlns:a16="http://schemas.microsoft.com/office/drawing/2014/main" id="{CBEEDA85-6314-44B3-96A8-FE32AACB0CA6}"/>
               </a:ext>
             </a:extLst>
           </p:cNvPr>
@@ -5301,7 +5301,7 @@
           <p:cNvPr id="8" name="">
             <a:extLst xmlns:a="http://schemas.openxmlformats.org/drawingml/2006/main">
               <a:ext uri="{FF2B5EF4-FFF2-40B4-BE49-F238E27FC236}">
-                <a16:creationId xmlns:a16="http://schemas.microsoft.com/office/drawing/2014/main" id="{E9C864E2-32EA-4325-B1F3-0311BED0194B}"/>
+                <a16:creationId xmlns:a16="http://schemas.microsoft.com/office/drawing/2014/main" id="{FBC7FEE1-A0A8-4633-8F5A-4219F027B835}"/>
               </a:ext>
             </a:extLst>
           </p:cNvPr>
@@ -5332,7 +5332,7 @@
           <p:cNvPr id="9" name="">
             <a:extLst xmlns:a="http://schemas.openxmlformats.org/drawingml/2006/main">
               <a:ext uri="{FF2B5EF4-FFF2-40B4-BE49-F238E27FC236}">
-                <a16:creationId xmlns:a16="http://schemas.microsoft.com/office/drawing/2014/main" id="{EBCDF880-265E-4581-95A7-D8FA267DE886}"/>
+                <a16:creationId xmlns:a16="http://schemas.microsoft.com/office/drawing/2014/main" id="{DFC22F78-768F-494D-811B-EAB8A489A902}"/>
               </a:ext>
             </a:extLst>
           </p:cNvPr>
@@ -5363,7 +5363,7 @@
           <p:cNvPr id="10" name="">
             <a:extLst xmlns:a="http://schemas.openxmlformats.org/drawingml/2006/main">
               <a:ext uri="{FF2B5EF4-FFF2-40B4-BE49-F238E27FC236}">
-                <a16:creationId xmlns:a16="http://schemas.microsoft.com/office/drawing/2014/main" id="{739F0AA2-BD55-43B4-ADBD-B5AB830DC53E}"/>
+                <a16:creationId xmlns:a16="http://schemas.microsoft.com/office/drawing/2014/main" id="{C1E89F8D-2082-4F03-A273-C31644D6A47D}"/>
               </a:ext>
             </a:extLst>
           </p:cNvPr>
@@ -5394,7 +5394,7 @@
           <p:cNvPr id="11" name="">
             <a:extLst xmlns:a="http://schemas.openxmlformats.org/drawingml/2006/main">
               <a:ext uri="{FF2B5EF4-FFF2-40B4-BE49-F238E27FC236}">
-                <a16:creationId xmlns:a16="http://schemas.microsoft.com/office/drawing/2014/main" id="{C90CE40D-5A2E-4FA1-AA15-C6306113AC31}"/>
+                <a16:creationId xmlns:a16="http://schemas.microsoft.com/office/drawing/2014/main" id="{1F1C3CCF-21C0-4D26-8F74-5FBB39155CA8}"/>
               </a:ext>
             </a:extLst>
           </p:cNvPr>
@@ -5425,7 +5425,7 @@
           <p:cNvPr id="12" name="">
             <a:extLst xmlns:a="http://schemas.openxmlformats.org/drawingml/2006/main">
               <a:ext uri="{FF2B5EF4-FFF2-40B4-BE49-F238E27FC236}">
-                <a16:creationId xmlns:a16="http://schemas.microsoft.com/office/drawing/2014/main" id="{4A9CF8AB-16B2-4332-9D3A-B52CE330D2EE}"/>
+                <a16:creationId xmlns:a16="http://schemas.microsoft.com/office/drawing/2014/main" id="{4085C30B-9AC0-4835-B912-F5B0E604D4B3}"/>
               </a:ext>
             </a:extLst>
           </p:cNvPr>
@@ -5456,7 +5456,7 @@
           <p:cNvPr id="13" name="">
             <a:extLst xmlns:a="http://schemas.openxmlformats.org/drawingml/2006/main">
               <a:ext uri="{FF2B5EF4-FFF2-40B4-BE49-F238E27FC236}">
-                <a16:creationId xmlns:a16="http://schemas.microsoft.com/office/drawing/2014/main" id="{FABA0693-B652-4BA6-BA2C-6B07FF08B806}"/>
+                <a16:creationId xmlns:a16="http://schemas.microsoft.com/office/drawing/2014/main" id="{1F6D41D1-FC0C-41DB-BBB2-4A9F60575784}"/>
               </a:ext>
             </a:extLst>
           </p:cNvPr>
@@ -5487,7 +5487,7 @@
           <p:cNvPr id="14" name="">
             <a:extLst xmlns:a="http://schemas.openxmlformats.org/drawingml/2006/main">
               <a:ext uri="{FF2B5EF4-FFF2-40B4-BE49-F238E27FC236}">
-                <a16:creationId xmlns:a16="http://schemas.microsoft.com/office/drawing/2014/main" id="{51607A14-C7E4-48AB-85AC-66C38A3D132F}"/>
+                <a16:creationId xmlns:a16="http://schemas.microsoft.com/office/drawing/2014/main" id="{35308C6A-063F-438B-A459-5B7871FCD1B4}"/>
               </a:ext>
             </a:extLst>
           </p:cNvPr>
@@ -5518,7 +5518,7 @@
           <p:cNvPr id="15" name="">
             <a:extLst xmlns:a="http://schemas.openxmlformats.org/drawingml/2006/main">
               <a:ext uri="{FF2B5EF4-FFF2-40B4-BE49-F238E27FC236}">
-                <a16:creationId xmlns:a16="http://schemas.microsoft.com/office/drawing/2014/main" id="{A7683BC1-40CD-400D-B556-1EE3834B25C5}"/>
+                <a16:creationId xmlns:a16="http://schemas.microsoft.com/office/drawing/2014/main" id="{ABCCA76C-FA40-4DBC-84D2-52F44999B5A0}"/>
               </a:ext>
             </a:extLst>
           </p:cNvPr>
@@ -5549,7 +5549,7 @@
           <p:cNvPr id="16" name="">
             <a:extLst xmlns:a="http://schemas.openxmlformats.org/drawingml/2006/main">
               <a:ext uri="{FF2B5EF4-FFF2-40B4-BE49-F238E27FC236}">
-                <a16:creationId xmlns:a16="http://schemas.microsoft.com/office/drawing/2014/main" id="{AB2B2603-A8B4-4B57-8FDA-B61E1B5EA4BC}"/>
+                <a16:creationId xmlns:a16="http://schemas.microsoft.com/office/drawing/2014/main" id="{A16B57DD-E868-4205-A621-6318ABCF95D4}"/>
               </a:ext>
             </a:extLst>
           </p:cNvPr>
@@ -5580,7 +5580,7 @@
           <p:cNvPr id="17" name="">
             <a:extLst xmlns:a="http://schemas.openxmlformats.org/drawingml/2006/main">
               <a:ext uri="{FF2B5EF4-FFF2-40B4-BE49-F238E27FC236}">
-                <a16:creationId xmlns:a16="http://schemas.microsoft.com/office/drawing/2014/main" id="{A0E8D142-9DB8-46C4-8088-D8D8CFB74F22}"/>
+                <a16:creationId xmlns:a16="http://schemas.microsoft.com/office/drawing/2014/main" id="{7AF3F150-ED2C-4B9C-91EA-0BFF6C5D7AE2}"/>
               </a:ext>
             </a:extLst>
           </p:cNvPr>
@@ -5611,7 +5611,7 @@
           <p:cNvPr id="18" name="">
             <a:extLst xmlns:a="http://schemas.openxmlformats.org/drawingml/2006/main">
               <a:ext uri="{FF2B5EF4-FFF2-40B4-BE49-F238E27FC236}">
-                <a16:creationId xmlns:a16="http://schemas.microsoft.com/office/drawing/2014/main" id="{30345087-ECBB-4F6B-8D47-0E717E818DC9}"/>
+                <a16:creationId xmlns:a16="http://schemas.microsoft.com/office/drawing/2014/main" id="{8A4D20AD-D965-4777-A352-B5A33426320E}"/>
               </a:ext>
             </a:extLst>
           </p:cNvPr>
@@ -5642,7 +5642,7 @@
           <p:cNvPr id="19" name="">
             <a:extLst xmlns:a="http://schemas.openxmlformats.org/drawingml/2006/main">
               <a:ext uri="{FF2B5EF4-FFF2-40B4-BE49-F238E27FC236}">
-                <a16:creationId xmlns:a16="http://schemas.microsoft.com/office/drawing/2014/main" id="{261D4347-BE20-488F-9F4B-7793B56AC48F}"/>
+                <a16:creationId xmlns:a16="http://schemas.microsoft.com/office/drawing/2014/main" id="{FA655F3C-0A58-42C5-B815-58BE1FDA792D}"/>
               </a:ext>
             </a:extLst>
           </p:cNvPr>
@@ -5673,7 +5673,7 @@
           <p:cNvPr id="20" name="">
             <a:extLst xmlns:a="http://schemas.openxmlformats.org/drawingml/2006/main">
               <a:ext uri="{FF2B5EF4-FFF2-40B4-BE49-F238E27FC236}">
-                <a16:creationId xmlns:a16="http://schemas.microsoft.com/office/drawing/2014/main" id="{5185F85A-15D2-4FD2-9A31-9D8220047B9B}"/>
+                <a16:creationId xmlns:a16="http://schemas.microsoft.com/office/drawing/2014/main" id="{6AD0BF99-486F-4E67-A922-6F15E902E312}"/>
               </a:ext>
             </a:extLst>
           </p:cNvPr>
@@ -5704,7 +5704,7 @@
           <p:cNvPr id="21" name="">
             <a:extLst xmlns:a="http://schemas.openxmlformats.org/drawingml/2006/main">
               <a:ext uri="{FF2B5EF4-FFF2-40B4-BE49-F238E27FC236}">
-                <a16:creationId xmlns:a16="http://schemas.microsoft.com/office/drawing/2014/main" id="{9B72C33E-7497-478F-A610-3337A9238873}"/>
+                <a16:creationId xmlns:a16="http://schemas.microsoft.com/office/drawing/2014/main" id="{AD4A643E-E848-4A0A-9635-AE15280F7876}"/>
               </a:ext>
             </a:extLst>
           </p:cNvPr>
@@ -5735,7 +5735,7 @@
           <p:cNvPr id="22" name="">
             <a:extLst xmlns:a="http://schemas.openxmlformats.org/drawingml/2006/main">
               <a:ext uri="{FF2B5EF4-FFF2-40B4-BE49-F238E27FC236}">
-                <a16:creationId xmlns:a16="http://schemas.microsoft.com/office/drawing/2014/main" id="{0EE5DE14-A79B-4A60-955D-007DDF007113}"/>
+                <a16:creationId xmlns:a16="http://schemas.microsoft.com/office/drawing/2014/main" id="{3C1A081D-4F5C-457C-85DA-06809D86627B}"/>
               </a:ext>
             </a:extLst>
           </p:cNvPr>
@@ -5766,7 +5766,7 @@
           <p:cNvPr id="23" name="">
             <a:extLst xmlns:a="http://schemas.openxmlformats.org/drawingml/2006/main">
               <a:ext uri="{FF2B5EF4-FFF2-40B4-BE49-F238E27FC236}">
-                <a16:creationId xmlns:a16="http://schemas.microsoft.com/office/drawing/2014/main" id="{6AE7C2AC-1887-4653-BF6C-085560B95041}"/>
+                <a16:creationId xmlns:a16="http://schemas.microsoft.com/office/drawing/2014/main" id="{AFAFB108-E304-4E81-B591-B98F5A5A27F1}"/>
               </a:ext>
             </a:extLst>
           </p:cNvPr>
@@ -5797,7 +5797,7 @@
           <p:cNvPr id="24" name="">
             <a:extLst xmlns:a="http://schemas.openxmlformats.org/drawingml/2006/main">
               <a:ext uri="{FF2B5EF4-FFF2-40B4-BE49-F238E27FC236}">
-                <a16:creationId xmlns:a16="http://schemas.microsoft.com/office/drawing/2014/main" id="{FD09FF14-3F84-42A2-A76C-32C8F4880270}"/>
+                <a16:creationId xmlns:a16="http://schemas.microsoft.com/office/drawing/2014/main" id="{66FA6B03-A300-46CE-9478-0AB048526FED}"/>
               </a:ext>
             </a:extLst>
           </p:cNvPr>
@@ -5828,7 +5828,7 @@
           <p:cNvPr id="25" name="">
             <a:extLst xmlns:a="http://schemas.openxmlformats.org/drawingml/2006/main">
               <a:ext uri="{FF2B5EF4-FFF2-40B4-BE49-F238E27FC236}">
-                <a16:creationId xmlns:a16="http://schemas.microsoft.com/office/drawing/2014/main" id="{DAA04B1D-0C55-483E-A8ED-0A5B947A05EC}"/>
+                <a16:creationId xmlns:a16="http://schemas.microsoft.com/office/drawing/2014/main" id="{DF55312F-B71E-4669-A4B7-A0C3B04FF70D}"/>
               </a:ext>
             </a:extLst>
           </p:cNvPr>
@@ -5859,7 +5859,7 @@
           <p:cNvPr id="26" name="">
             <a:extLst xmlns:a="http://schemas.openxmlformats.org/drawingml/2006/main">
               <a:ext uri="{FF2B5EF4-FFF2-40B4-BE49-F238E27FC236}">
-                <a16:creationId xmlns:a16="http://schemas.microsoft.com/office/drawing/2014/main" id="{5556527A-ABF0-42CC-AD25-A6A4424C2AED}"/>
+                <a16:creationId xmlns:a16="http://schemas.microsoft.com/office/drawing/2014/main" id="{EECE79D7-D035-429C-A363-DA58FAA811BB}"/>
               </a:ext>
             </a:extLst>
           </p:cNvPr>
@@ -5890,7 +5890,7 @@
           <p:cNvPr id="27" name="">
             <a:extLst xmlns:a="http://schemas.openxmlformats.org/drawingml/2006/main">
               <a:ext uri="{FF2B5EF4-FFF2-40B4-BE49-F238E27FC236}">
-                <a16:creationId xmlns:a16="http://schemas.microsoft.com/office/drawing/2014/main" id="{A64540EF-E328-46C5-B2EE-17DA65BA64EC}"/>
+                <a16:creationId xmlns:a16="http://schemas.microsoft.com/office/drawing/2014/main" id="{423D3D2B-7882-4527-BECA-E1F1843B2CD1}"/>
               </a:ext>
             </a:extLst>
           </p:cNvPr>
@@ -5921,7 +5921,7 @@
           <p:cNvPr id="28" name="">
             <a:extLst xmlns:a="http://schemas.openxmlformats.org/drawingml/2006/main">
               <a:ext uri="{FF2B5EF4-FFF2-40B4-BE49-F238E27FC236}">
-                <a16:creationId xmlns:a16="http://schemas.microsoft.com/office/drawing/2014/main" id="{08B1420C-89F6-423E-8DCD-DD45A92ADA4C}"/>
+                <a16:creationId xmlns:a16="http://schemas.microsoft.com/office/drawing/2014/main" id="{DE8CFD5F-842F-4048-8225-BC353E0C5E5F}"/>
               </a:ext>
             </a:extLst>
           </p:cNvPr>
@@ -5952,7 +5952,7 @@
           <p:cNvPr id="29" name="">
             <a:extLst xmlns:a="http://schemas.openxmlformats.org/drawingml/2006/main">
               <a:ext uri="{FF2B5EF4-FFF2-40B4-BE49-F238E27FC236}">
-                <a16:creationId xmlns:a16="http://schemas.microsoft.com/office/drawing/2014/main" id="{0D32FBCA-5D17-48E7-AFD8-8934E29414E9}"/>
+                <a16:creationId xmlns:a16="http://schemas.microsoft.com/office/drawing/2014/main" id="{4FB5AD48-46D9-4E60-8BF0-2E160DE92ECA}"/>
               </a:ext>
             </a:extLst>
           </p:cNvPr>
@@ -5983,7 +5983,7 @@
           <p:cNvPr id="30" name="">
             <a:extLst xmlns:a="http://schemas.openxmlformats.org/drawingml/2006/main">
               <a:ext uri="{FF2B5EF4-FFF2-40B4-BE49-F238E27FC236}">
-                <a16:creationId xmlns:a16="http://schemas.microsoft.com/office/drawing/2014/main" id="{436EDFE8-D858-4C9D-B280-B5E8DD22857D}"/>
+                <a16:creationId xmlns:a16="http://schemas.microsoft.com/office/drawing/2014/main" id="{2456FD5F-2305-4116-A5F8-637A8482B54D}"/>
               </a:ext>
             </a:extLst>
           </p:cNvPr>
@@ -6014,7 +6014,7 @@
           <p:cNvPr id="31" name="">
             <a:extLst xmlns:a="http://schemas.openxmlformats.org/drawingml/2006/main">
               <a:ext uri="{FF2B5EF4-FFF2-40B4-BE49-F238E27FC236}">
-                <a16:creationId xmlns:a16="http://schemas.microsoft.com/office/drawing/2014/main" id="{C562823C-1F45-4E32-B64D-8EC5D2FB3575}"/>
+                <a16:creationId xmlns:a16="http://schemas.microsoft.com/office/drawing/2014/main" id="{D4119FE0-16DC-42AF-A190-784ED3DB79E2}"/>
               </a:ext>
             </a:extLst>
           </p:cNvPr>
@@ -6045,7 +6045,7 @@
           <p:cNvPr id="32" name="">
             <a:extLst xmlns:a="http://schemas.openxmlformats.org/drawingml/2006/main">
               <a:ext uri="{FF2B5EF4-FFF2-40B4-BE49-F238E27FC236}">
-                <a16:creationId xmlns:a16="http://schemas.microsoft.com/office/drawing/2014/main" id="{7B81AD8D-AE70-45F5-8752-7BE2904DB61E}"/>
+                <a16:creationId xmlns:a16="http://schemas.microsoft.com/office/drawing/2014/main" id="{FF0BFA25-37DF-498A-B91B-D46609C04171}"/>
               </a:ext>
             </a:extLst>
           </p:cNvPr>
@@ -6076,7 +6076,7 @@
           <p:cNvPr id="33" name="">
             <a:extLst xmlns:a="http://schemas.openxmlformats.org/drawingml/2006/main">
               <a:ext uri="{FF2B5EF4-FFF2-40B4-BE49-F238E27FC236}">
-                <a16:creationId xmlns:a16="http://schemas.microsoft.com/office/drawing/2014/main" id="{3DA2B2A4-AB28-46DA-807E-893AEF26CF63}"/>
+                <a16:creationId xmlns:a16="http://schemas.microsoft.com/office/drawing/2014/main" id="{BFD0B383-6C72-4076-BADE-303EA424813E}"/>
               </a:ext>
             </a:extLst>
           </p:cNvPr>
@@ -6107,7 +6107,7 @@
           <p:cNvPr id="34" name="">
             <a:extLst xmlns:a="http://schemas.openxmlformats.org/drawingml/2006/main">
               <a:ext uri="{FF2B5EF4-FFF2-40B4-BE49-F238E27FC236}">
-                <a16:creationId xmlns:a16="http://schemas.microsoft.com/office/drawing/2014/main" id="{4748FCCD-E7A4-4A6C-B555-B842F24E5857}"/>
+                <a16:creationId xmlns:a16="http://schemas.microsoft.com/office/drawing/2014/main" id="{00E5529E-883C-414A-BBFD-C06E751E4370}"/>
               </a:ext>
             </a:extLst>
           </p:cNvPr>
@@ -6140,7 +6140,7 @@
           <p:cNvPr id="35" name="">
             <a:extLst xmlns:a="http://schemas.openxmlformats.org/drawingml/2006/main">
               <a:ext uri="{FF2B5EF4-FFF2-40B4-BE49-F238E27FC236}">
-                <a16:creationId xmlns:a16="http://schemas.microsoft.com/office/drawing/2014/main" id="{558838DC-1B24-4A20-8650-9F90C59E3B54}"/>
+                <a16:creationId xmlns:a16="http://schemas.microsoft.com/office/drawing/2014/main" id="{0CAE545E-8EA5-45AF-A5AE-B3D481F1B1B8}"/>
               </a:ext>
             </a:extLst>
           </p:cNvPr>
@@ -6202,7 +6202,7 @@
           <p:cNvPr id="36" name="">
             <a:extLst xmlns:a="http://schemas.openxmlformats.org/drawingml/2006/main">
               <a:ext uri="{FF2B5EF4-FFF2-40B4-BE49-F238E27FC236}">
-                <a16:creationId xmlns:a16="http://schemas.microsoft.com/office/drawing/2014/main" id="{8A8780EE-D03B-45E6-88BB-C381BE2E845B}"/>
+                <a16:creationId xmlns:a16="http://schemas.microsoft.com/office/drawing/2014/main" id="{8F773779-00F4-4958-AC96-7D376D103EB0}"/>
               </a:ext>
             </a:extLst>
           </p:cNvPr>
@@ -6264,7 +6264,7 @@
           <p:cNvPr id="37" name="">
             <a:extLst xmlns:a="http://schemas.openxmlformats.org/drawingml/2006/main">
               <a:ext uri="{FF2B5EF4-FFF2-40B4-BE49-F238E27FC236}">
-                <a16:creationId xmlns:a16="http://schemas.microsoft.com/office/drawing/2014/main" id="{6A4CBAE2-819A-46A8-9263-A297878FC97D}"/>
+                <a16:creationId xmlns:a16="http://schemas.microsoft.com/office/drawing/2014/main" id="{A18AA8C9-CE9B-4DBF-8EF6-299807408F2F}"/>
               </a:ext>
             </a:extLst>
           </p:cNvPr>
@@ -6326,7 +6326,7 @@
           <p:cNvPr id="38" name="">
             <a:extLst xmlns:a="http://schemas.openxmlformats.org/drawingml/2006/main">
               <a:ext uri="{FF2B5EF4-FFF2-40B4-BE49-F238E27FC236}">
-                <a16:creationId xmlns:a16="http://schemas.microsoft.com/office/drawing/2014/main" id="{54A58E9E-796A-4D35-8298-F09B7A1A0FB1}"/>
+                <a16:creationId xmlns:a16="http://schemas.microsoft.com/office/drawing/2014/main" id="{AAC50092-2803-45A0-A04F-CF1C29DCA092}"/>
               </a:ext>
             </a:extLst>
           </p:cNvPr>
@@ -6388,7 +6388,7 @@
           <p:cNvPr id="39" name="">
             <a:extLst xmlns:a="http://schemas.openxmlformats.org/drawingml/2006/main">
               <a:ext uri="{FF2B5EF4-FFF2-40B4-BE49-F238E27FC236}">
-                <a16:creationId xmlns:a16="http://schemas.microsoft.com/office/drawing/2014/main" id="{4D4E5D8F-E7D5-4CBA-BE31-9DDDD966E3DA}"/>
+                <a16:creationId xmlns:a16="http://schemas.microsoft.com/office/drawing/2014/main" id="{86F2080A-CCC9-44A1-A9BB-EB88D552E73A}"/>
               </a:ext>
             </a:extLst>
           </p:cNvPr>
@@ -6419,7 +6419,7 @@
           <p:cNvPr id="40" name="">
             <a:extLst xmlns:a="http://schemas.openxmlformats.org/drawingml/2006/main">
               <a:ext uri="{FF2B5EF4-FFF2-40B4-BE49-F238E27FC236}">
-                <a16:creationId xmlns:a16="http://schemas.microsoft.com/office/drawing/2014/main" id="{00B60B46-E607-480E-978A-75F1A9F3A68F}"/>
+                <a16:creationId xmlns:a16="http://schemas.microsoft.com/office/drawing/2014/main" id="{83D0722C-0151-401A-8396-C4D502C4D8F2}"/>
               </a:ext>
             </a:extLst>
           </p:cNvPr>
@@ -6450,7 +6450,7 @@
           <p:cNvPr id="41" name="">
             <a:extLst xmlns:a="http://schemas.openxmlformats.org/drawingml/2006/main">
               <a:ext uri="{FF2B5EF4-FFF2-40B4-BE49-F238E27FC236}">
-                <a16:creationId xmlns:a16="http://schemas.microsoft.com/office/drawing/2014/main" id="{2EDF9FB6-4150-4160-98E6-0B3359AD86BB}"/>
+                <a16:creationId xmlns:a16="http://schemas.microsoft.com/office/drawing/2014/main" id="{06CC2019-CD12-4D0C-9226-1E70D9C5D730}"/>
               </a:ext>
             </a:extLst>
           </p:cNvPr>
@@ -6512,7 +6512,7 @@
           <p:cNvPr id="42" name="">
             <a:extLst xmlns:a="http://schemas.openxmlformats.org/drawingml/2006/main">
               <a:ext uri="{FF2B5EF4-FFF2-40B4-BE49-F238E27FC236}">
-                <a16:creationId xmlns:a16="http://schemas.microsoft.com/office/drawing/2014/main" id="{963C13F2-6AF9-4316-9BF4-9E5678C68EA2}"/>
+                <a16:creationId xmlns:a16="http://schemas.microsoft.com/office/drawing/2014/main" id="{DE18101A-3941-4404-8A49-35C55203985E}"/>
               </a:ext>
             </a:extLst>
           </p:cNvPr>
@@ -6574,7 +6574,7 @@
           <p:cNvPr id="43" name="">
             <a:extLst xmlns:a="http://schemas.openxmlformats.org/drawingml/2006/main">
               <a:ext uri="{FF2B5EF4-FFF2-40B4-BE49-F238E27FC236}">
-                <a16:creationId xmlns:a16="http://schemas.microsoft.com/office/drawing/2014/main" id="{BCEB0EE1-7D7C-451C-B30E-E95AA9588445}"/>
+                <a16:creationId xmlns:a16="http://schemas.microsoft.com/office/drawing/2014/main" id="{76D01D8B-DF18-4A11-AF82-F3F9B1BB341D}"/>
               </a:ext>
             </a:extLst>
           </p:cNvPr>
@@ -6609,7 +6609,7 @@
           <p:cNvPr id="44" name="">
             <a:extLst xmlns:a="http://schemas.openxmlformats.org/drawingml/2006/main">
               <a:ext uri="{FF2B5EF4-FFF2-40B4-BE49-F238E27FC236}">
-                <a16:creationId xmlns:a16="http://schemas.microsoft.com/office/drawing/2014/main" id="{66723F55-65C1-400D-A9CD-D7B05978A562}"/>
+                <a16:creationId xmlns:a16="http://schemas.microsoft.com/office/drawing/2014/main" id="{F84D26FF-8A69-4E0F-9705-2FBAE88BA179}"/>
               </a:ext>
             </a:extLst>
           </p:cNvPr>
@@ -6671,7 +6671,7 @@
           <p:cNvPr id="45" name="">
             <a:extLst xmlns:a="http://schemas.openxmlformats.org/drawingml/2006/main">
               <a:ext uri="{FF2B5EF4-FFF2-40B4-BE49-F238E27FC236}">
-                <a16:creationId xmlns:a16="http://schemas.microsoft.com/office/drawing/2014/main" id="{C918825E-C903-4165-BD16-C4DE63DA1AF4}"/>
+                <a16:creationId xmlns:a16="http://schemas.microsoft.com/office/drawing/2014/main" id="{A69961B0-CD80-4D43-A73D-90DFFCBC5DEC}"/>
               </a:ext>
             </a:extLst>
           </p:cNvPr>
@@ -6733,7 +6733,7 @@
           <p:cNvPr id="46" name="">
             <a:extLst xmlns:a="http://schemas.openxmlformats.org/drawingml/2006/main">
               <a:ext uri="{FF2B5EF4-FFF2-40B4-BE49-F238E27FC236}">
-                <a16:creationId xmlns:a16="http://schemas.microsoft.com/office/drawing/2014/main" id="{425DBA47-3D7F-4E65-94E1-ADD3AC99411E}"/>
+                <a16:creationId xmlns:a16="http://schemas.microsoft.com/office/drawing/2014/main" id="{9450937B-CA34-491D-A478-EA539E8C70A8}"/>
               </a:ext>
             </a:extLst>
           </p:cNvPr>
@@ -6795,7 +6795,7 @@
           <p:cNvPr id="47" name="">
             <a:extLst xmlns:a="http://schemas.openxmlformats.org/drawingml/2006/main">
               <a:ext uri="{FF2B5EF4-FFF2-40B4-BE49-F238E27FC236}">
-                <a16:creationId xmlns:a16="http://schemas.microsoft.com/office/drawing/2014/main" id="{340B6FDA-4073-4ADF-9526-0EC131EA2628}"/>
+                <a16:creationId xmlns:a16="http://schemas.microsoft.com/office/drawing/2014/main" id="{608DA0D6-F9AC-4C54-B7F5-4C499C02F2BF}"/>
               </a:ext>
             </a:extLst>
           </p:cNvPr>
@@ -6830,7 +6830,7 @@
           <p:cNvPr id="48" name="">
             <a:extLst xmlns:a="http://schemas.openxmlformats.org/drawingml/2006/main">
               <a:ext uri="{FF2B5EF4-FFF2-40B4-BE49-F238E27FC236}">
-                <a16:creationId xmlns:a16="http://schemas.microsoft.com/office/drawing/2014/main" id="{849D4DBE-7BC1-418C-A3DF-678F013F2731}"/>
+                <a16:creationId xmlns:a16="http://schemas.microsoft.com/office/drawing/2014/main" id="{A8879370-AF08-49F4-90CC-868B0D7085B4}"/>
               </a:ext>
             </a:extLst>
           </p:cNvPr>
@@ -6892,7 +6892,7 @@
           <p:cNvPr id="49" name="">
             <a:extLst xmlns:a="http://schemas.openxmlformats.org/drawingml/2006/main">
               <a:ext uri="{FF2B5EF4-FFF2-40B4-BE49-F238E27FC236}">
-                <a16:creationId xmlns:a16="http://schemas.microsoft.com/office/drawing/2014/main" id="{C555353C-1685-4A6C-855A-D7E19482BA73}"/>
+                <a16:creationId xmlns:a16="http://schemas.microsoft.com/office/drawing/2014/main" id="{2D20CDA8-55A3-43E9-A7D4-6E6C5EADE1AD}"/>
               </a:ext>
             </a:extLst>
           </p:cNvPr>
@@ -6954,7 +6954,7 @@
           <p:cNvPr id="50" name="">
             <a:extLst xmlns:a="http://schemas.openxmlformats.org/drawingml/2006/main">
               <a:ext uri="{FF2B5EF4-FFF2-40B4-BE49-F238E27FC236}">
-                <a16:creationId xmlns:a16="http://schemas.microsoft.com/office/drawing/2014/main" id="{1E4FADBD-F540-4366-AC76-7C5086780AB6}"/>
+                <a16:creationId xmlns:a16="http://schemas.microsoft.com/office/drawing/2014/main" id="{DE16E104-2458-480C-81C5-4CEE0C248E1E}"/>
               </a:ext>
             </a:extLst>
           </p:cNvPr>
@@ -7016,7 +7016,7 @@
           <p:cNvPr id="51" name="">
             <a:extLst xmlns:a="http://schemas.openxmlformats.org/drawingml/2006/main">
               <a:ext uri="{FF2B5EF4-FFF2-40B4-BE49-F238E27FC236}">
-                <a16:creationId xmlns:a16="http://schemas.microsoft.com/office/drawing/2014/main" id="{7204EF32-296C-4386-AFE2-C87CD3C2A338}"/>
+                <a16:creationId xmlns:a16="http://schemas.microsoft.com/office/drawing/2014/main" id="{A2DBA94F-57E0-4885-BBC2-094F83B55EC5}"/>
               </a:ext>
             </a:extLst>
           </p:cNvPr>
@@ -7051,7 +7051,7 @@
           <p:cNvPr id="52" name="">
             <a:extLst xmlns:a="http://schemas.openxmlformats.org/drawingml/2006/main">
               <a:ext uri="{FF2B5EF4-FFF2-40B4-BE49-F238E27FC236}">
-                <a16:creationId xmlns:a16="http://schemas.microsoft.com/office/drawing/2014/main" id="{8CB5BC27-547A-4C45-9D96-9B3E770C4259}"/>
+                <a16:creationId xmlns:a16="http://schemas.microsoft.com/office/drawing/2014/main" id="{5F57D3A3-C457-4071-B582-9D28EB3C4935}"/>
               </a:ext>
             </a:extLst>
           </p:cNvPr>
@@ -7113,7 +7113,7 @@
           <p:cNvPr id="53" name="">
             <a:extLst xmlns:a="http://schemas.openxmlformats.org/drawingml/2006/main">
               <a:ext uri="{FF2B5EF4-FFF2-40B4-BE49-F238E27FC236}">
-                <a16:creationId xmlns:a16="http://schemas.microsoft.com/office/drawing/2014/main" id="{B92C8CD7-6C6A-42C2-9B52-7BEABB1FCB2F}"/>
+                <a16:creationId xmlns:a16="http://schemas.microsoft.com/office/drawing/2014/main" id="{02A3FB47-4406-419F-80B6-0F9CB3A035A4}"/>
               </a:ext>
             </a:extLst>
           </p:cNvPr>
@@ -7175,7 +7175,7 @@
           <p:cNvPr id="54" name="">
             <a:extLst xmlns:a="http://schemas.openxmlformats.org/drawingml/2006/main">
               <a:ext uri="{FF2B5EF4-FFF2-40B4-BE49-F238E27FC236}">
-                <a16:creationId xmlns:a16="http://schemas.microsoft.com/office/drawing/2014/main" id="{F617959B-1082-416E-AFAA-8DA21B55C2B0}"/>
+                <a16:creationId xmlns:a16="http://schemas.microsoft.com/office/drawing/2014/main" id="{17408028-7816-428E-BBA1-E1E79B6B276D}"/>
               </a:ext>
             </a:extLst>
           </p:cNvPr>
@@ -7237,7 +7237,7 @@
           <p:cNvPr id="55" name="">
             <a:extLst xmlns:a="http://schemas.openxmlformats.org/drawingml/2006/main">
               <a:ext uri="{FF2B5EF4-FFF2-40B4-BE49-F238E27FC236}">
-                <a16:creationId xmlns:a16="http://schemas.microsoft.com/office/drawing/2014/main" id="{5FB458A0-B8A8-431E-9FE7-E8D546941208}"/>
+                <a16:creationId xmlns:a16="http://schemas.microsoft.com/office/drawing/2014/main" id="{30A0DCFD-A0DD-4043-B07F-3195773470DE}"/>
               </a:ext>
             </a:extLst>
           </p:cNvPr>
@@ -7299,7 +7299,7 @@
           <p:cNvPr id="56" name="">
             <a:extLst xmlns:a="http://schemas.openxmlformats.org/drawingml/2006/main">
               <a:ext uri="{FF2B5EF4-FFF2-40B4-BE49-F238E27FC236}">
-                <a16:creationId xmlns:a16="http://schemas.microsoft.com/office/drawing/2014/main" id="{5F6EB70E-4453-4C5B-B90D-CECE0CACCF18}"/>
+                <a16:creationId xmlns:a16="http://schemas.microsoft.com/office/drawing/2014/main" id="{FED7A65F-2389-4038-9497-EBE6A14540F0}"/>
               </a:ext>
             </a:extLst>
           </p:cNvPr>
@@ -7359,7 +7359,7 @@
     </p:spTree>
     <p:extLst>
       <p:ext uri="{BB962C8B-B14F-4D97-AF65-F5344CB8AC3E}">
-        <p14:creationId xmlns:p14="http://schemas.microsoft.com/office/powerpoint/2010/main" val="502089213"/>
+        <p14:creationId xmlns:p14="http://schemas.microsoft.com/office/powerpoint/2010/main" val="2011855578"/>
       </p:ext>
     </p:extLst>
   </p:cSld>
@@ -7390,7 +7390,7 @@
           <p:cNvPr id="58" name="">
             <a:extLst xmlns:a="http://schemas.openxmlformats.org/drawingml/2006/main">
               <a:ext uri="{FF2B5EF4-FFF2-40B4-BE49-F238E27FC236}">
-                <a16:creationId xmlns:a16="http://schemas.microsoft.com/office/drawing/2014/main" id="{F555905A-EF96-4B45-84E8-2639C6B0613F}"/>
+                <a16:creationId xmlns:a16="http://schemas.microsoft.com/office/drawing/2014/main" id="{37CABEB5-1384-48BF-8540-26BB19FBD06C}"/>
               </a:ext>
             </a:extLst>
           </p:cNvPr>
@@ -7421,7 +7421,7 @@
           <p:cNvPr id="2" name="">
             <a:extLst xmlns:a="http://schemas.openxmlformats.org/drawingml/2006/main">
               <a:ext uri="{FF2B5EF4-FFF2-40B4-BE49-F238E27FC236}">
-                <a16:creationId xmlns:a16="http://schemas.microsoft.com/office/drawing/2014/main" id="{0E36EC25-5AA6-420B-B640-11A7EF586FF3}"/>
+                <a16:creationId xmlns:a16="http://schemas.microsoft.com/office/drawing/2014/main" id="{D13ED82D-EA36-4BC1-8A05-276B199A572D}"/>
               </a:ext>
             </a:extLst>
           </p:cNvPr>
@@ -7452,7 +7452,7 @@
           <p:cNvPr id="3" name="">
             <a:extLst xmlns:a="http://schemas.openxmlformats.org/drawingml/2006/main">
               <a:ext uri="{FF2B5EF4-FFF2-40B4-BE49-F238E27FC236}">
-                <a16:creationId xmlns:a16="http://schemas.microsoft.com/office/drawing/2014/main" id="{15585C92-B508-4B1E-98D1-C1A008E95927}"/>
+                <a16:creationId xmlns:a16="http://schemas.microsoft.com/office/drawing/2014/main" id="{EC029B44-8CCC-47DC-A526-603175EDC019}"/>
               </a:ext>
             </a:extLst>
           </p:cNvPr>
@@ -7483,7 +7483,7 @@
           <p:cNvPr id="4" name="">
             <a:extLst xmlns:a="http://schemas.openxmlformats.org/drawingml/2006/main">
               <a:ext uri="{FF2B5EF4-FFF2-40B4-BE49-F238E27FC236}">
-                <a16:creationId xmlns:a16="http://schemas.microsoft.com/office/drawing/2014/main" id="{51592E2F-48D8-4202-B071-B115F2CE9E69}"/>
+                <a16:creationId xmlns:a16="http://schemas.microsoft.com/office/drawing/2014/main" id="{40C1EAB5-6108-4539-8B7D-BEB5CDD9F7FC}"/>
               </a:ext>
             </a:extLst>
           </p:cNvPr>
@@ -7514,7 +7514,7 @@
           <p:cNvPr id="5" name="">
             <a:extLst xmlns:a="http://schemas.openxmlformats.org/drawingml/2006/main">
               <a:ext uri="{FF2B5EF4-FFF2-40B4-BE49-F238E27FC236}">
-                <a16:creationId xmlns:a16="http://schemas.microsoft.com/office/drawing/2014/main" id="{E1ED8837-24F1-4E17-A308-9C8CEC35D9C1}"/>
+                <a16:creationId xmlns:a16="http://schemas.microsoft.com/office/drawing/2014/main" id="{9DC44A34-CD7A-4D03-A200-3836AE501D47}"/>
               </a:ext>
             </a:extLst>
           </p:cNvPr>
@@ -7545,7 +7545,7 @@
           <p:cNvPr id="6" name="">
             <a:extLst xmlns:a="http://schemas.openxmlformats.org/drawingml/2006/main">
               <a:ext uri="{FF2B5EF4-FFF2-40B4-BE49-F238E27FC236}">
-                <a16:creationId xmlns:a16="http://schemas.microsoft.com/office/drawing/2014/main" id="{853C98F9-5843-484E-AC01-9F48E3F3DD66}"/>
+                <a16:creationId xmlns:a16="http://schemas.microsoft.com/office/drawing/2014/main" id="{1F6F76AC-C797-4136-8AF7-B925E6DC82CB}"/>
               </a:ext>
             </a:extLst>
           </p:cNvPr>
@@ -7576,7 +7576,7 @@
           <p:cNvPr id="7" name="">
             <a:extLst xmlns:a="http://schemas.openxmlformats.org/drawingml/2006/main">
               <a:ext uri="{FF2B5EF4-FFF2-40B4-BE49-F238E27FC236}">
-                <a16:creationId xmlns:a16="http://schemas.microsoft.com/office/drawing/2014/main" id="{C9603E30-0E44-4ACC-B943-699225F3BAC6}"/>
+                <a16:creationId xmlns:a16="http://schemas.microsoft.com/office/drawing/2014/main" id="{1C8AFC2E-348B-48C1-909A-C002BA9FEB75}"/>
               </a:ext>
             </a:extLst>
           </p:cNvPr>
@@ -7607,7 +7607,7 @@
           <p:cNvPr id="8" name="">
             <a:extLst xmlns:a="http://schemas.openxmlformats.org/drawingml/2006/main">
               <a:ext uri="{FF2B5EF4-FFF2-40B4-BE49-F238E27FC236}">
-                <a16:creationId xmlns:a16="http://schemas.microsoft.com/office/drawing/2014/main" id="{36E68BE0-8424-4BEE-9E45-094804B287DC}"/>
+                <a16:creationId xmlns:a16="http://schemas.microsoft.com/office/drawing/2014/main" id="{2E58A7F4-DC66-464A-8349-4283AFD85B2B}"/>
               </a:ext>
             </a:extLst>
           </p:cNvPr>
@@ -7638,7 +7638,7 @@
           <p:cNvPr id="9" name="">
             <a:extLst xmlns:a="http://schemas.openxmlformats.org/drawingml/2006/main">
               <a:ext uri="{FF2B5EF4-FFF2-40B4-BE49-F238E27FC236}">
-                <a16:creationId xmlns:a16="http://schemas.microsoft.com/office/drawing/2014/main" id="{A7C896DF-E37E-4D2D-87BD-0D9F48564907}"/>
+                <a16:creationId xmlns:a16="http://schemas.microsoft.com/office/drawing/2014/main" id="{1AB67BA0-CF07-42DE-89DD-EA318B7FEBB5}"/>
               </a:ext>
             </a:extLst>
           </p:cNvPr>
@@ -7669,7 +7669,7 @@
           <p:cNvPr id="10" name="">
             <a:extLst xmlns:a="http://schemas.openxmlformats.org/drawingml/2006/main">
               <a:ext uri="{FF2B5EF4-FFF2-40B4-BE49-F238E27FC236}">
-                <a16:creationId xmlns:a16="http://schemas.microsoft.com/office/drawing/2014/main" id="{DABAD899-F5F2-47A5-BB9D-5DBB19D6171F}"/>
+                <a16:creationId xmlns:a16="http://schemas.microsoft.com/office/drawing/2014/main" id="{CFAFD8BF-8A12-41B5-97FC-E5913A078323}"/>
               </a:ext>
             </a:extLst>
           </p:cNvPr>
@@ -7700,7 +7700,7 @@
           <p:cNvPr id="11" name="">
             <a:extLst xmlns:a="http://schemas.openxmlformats.org/drawingml/2006/main">
               <a:ext uri="{FF2B5EF4-FFF2-40B4-BE49-F238E27FC236}">
-                <a16:creationId xmlns:a16="http://schemas.microsoft.com/office/drawing/2014/main" id="{76CAF9DB-29BB-4225-9C0E-BFAAD7882862}"/>
+                <a16:creationId xmlns:a16="http://schemas.microsoft.com/office/drawing/2014/main" id="{E9237BBF-DCD0-4184-AF69-57868B42A6F5}"/>
               </a:ext>
             </a:extLst>
           </p:cNvPr>
@@ -7731,7 +7731,7 @@
           <p:cNvPr id="12" name="">
             <a:extLst xmlns:a="http://schemas.openxmlformats.org/drawingml/2006/main">
               <a:ext uri="{FF2B5EF4-FFF2-40B4-BE49-F238E27FC236}">
-                <a16:creationId xmlns:a16="http://schemas.microsoft.com/office/drawing/2014/main" id="{6A325F81-ADBB-417C-A0CC-D6C4DC216B7A}"/>
+                <a16:creationId xmlns:a16="http://schemas.microsoft.com/office/drawing/2014/main" id="{A1DEEA91-3594-4EBB-A1A6-9577C6EC22D3}"/>
               </a:ext>
             </a:extLst>
           </p:cNvPr>
@@ -7762,7 +7762,7 @@
           <p:cNvPr id="13" name="">
             <a:extLst xmlns:a="http://schemas.openxmlformats.org/drawingml/2006/main">
               <a:ext uri="{FF2B5EF4-FFF2-40B4-BE49-F238E27FC236}">
-                <a16:creationId xmlns:a16="http://schemas.microsoft.com/office/drawing/2014/main" id="{A9059B45-A895-45BC-B852-C2E6B875366E}"/>
+                <a16:creationId xmlns:a16="http://schemas.microsoft.com/office/drawing/2014/main" id="{0E04A40F-2641-4237-8629-02D7F5A2EAE7}"/>
               </a:ext>
             </a:extLst>
           </p:cNvPr>
@@ -7793,7 +7793,7 @@
           <p:cNvPr id="14" name="">
             <a:extLst xmlns:a="http://schemas.openxmlformats.org/drawingml/2006/main">
               <a:ext uri="{FF2B5EF4-FFF2-40B4-BE49-F238E27FC236}">
-                <a16:creationId xmlns:a16="http://schemas.microsoft.com/office/drawing/2014/main" id="{C2207C8E-D7CF-492E-85AE-5E263E3B62B7}"/>
+                <a16:creationId xmlns:a16="http://schemas.microsoft.com/office/drawing/2014/main" id="{A203C725-18F0-4B24-9639-2EAC9A173B16}"/>
               </a:ext>
             </a:extLst>
           </p:cNvPr>
@@ -7824,7 +7824,7 @@
           <p:cNvPr id="15" name="">
             <a:extLst xmlns:a="http://schemas.openxmlformats.org/drawingml/2006/main">
               <a:ext uri="{FF2B5EF4-FFF2-40B4-BE49-F238E27FC236}">
-                <a16:creationId xmlns:a16="http://schemas.microsoft.com/office/drawing/2014/main" id="{EE405D40-20A6-4AEE-A4FC-7F290CCC8F46}"/>
+                <a16:creationId xmlns:a16="http://schemas.microsoft.com/office/drawing/2014/main" id="{27645E34-C561-40C3-903E-3EEABEFB578D}"/>
               </a:ext>
             </a:extLst>
           </p:cNvPr>
@@ -7855,7 +7855,7 @@
           <p:cNvPr id="16" name="">
             <a:extLst xmlns:a="http://schemas.openxmlformats.org/drawingml/2006/main">
               <a:ext uri="{FF2B5EF4-FFF2-40B4-BE49-F238E27FC236}">
-                <a16:creationId xmlns:a16="http://schemas.microsoft.com/office/drawing/2014/main" id="{074BD5E1-0F5E-4385-A1A0-FBAF2D20E927}"/>
+                <a16:creationId xmlns:a16="http://schemas.microsoft.com/office/drawing/2014/main" id="{9B182E7D-590E-4024-BDC2-E855ACA69D74}"/>
               </a:ext>
             </a:extLst>
           </p:cNvPr>
@@ -7886,7 +7886,7 @@
           <p:cNvPr id="17" name="">
             <a:extLst xmlns:a="http://schemas.openxmlformats.org/drawingml/2006/main">
               <a:ext uri="{FF2B5EF4-FFF2-40B4-BE49-F238E27FC236}">
-                <a16:creationId xmlns:a16="http://schemas.microsoft.com/office/drawing/2014/main" id="{CA98EAF4-6C28-4665-BD22-73198EBB361F}"/>
+                <a16:creationId xmlns:a16="http://schemas.microsoft.com/office/drawing/2014/main" id="{F5A29724-78B7-4854-83F0-3F1EC1CF8A24}"/>
               </a:ext>
             </a:extLst>
           </p:cNvPr>
@@ -7917,7 +7917,7 @@
           <p:cNvPr id="18" name="">
             <a:extLst xmlns:a="http://schemas.openxmlformats.org/drawingml/2006/main">
               <a:ext uri="{FF2B5EF4-FFF2-40B4-BE49-F238E27FC236}">
-                <a16:creationId xmlns:a16="http://schemas.microsoft.com/office/drawing/2014/main" id="{B842DECE-0955-453B-896D-41AFFF17404A}"/>
+                <a16:creationId xmlns:a16="http://schemas.microsoft.com/office/drawing/2014/main" id="{1912F743-47CE-4ECB-9571-DBE775753427}"/>
               </a:ext>
             </a:extLst>
           </p:cNvPr>
@@ -7948,7 +7948,7 @@
           <p:cNvPr id="19" name="">
             <a:extLst xmlns:a="http://schemas.openxmlformats.org/drawingml/2006/main">
               <a:ext uri="{FF2B5EF4-FFF2-40B4-BE49-F238E27FC236}">
-                <a16:creationId xmlns:a16="http://schemas.microsoft.com/office/drawing/2014/main" id="{C4550D24-B05F-41E7-9BDF-85FAB8852211}"/>
+                <a16:creationId xmlns:a16="http://schemas.microsoft.com/office/drawing/2014/main" id="{542A452D-D45D-4FF4-BBCC-A11C2DA09EB8}"/>
               </a:ext>
             </a:extLst>
           </p:cNvPr>
@@ -7979,7 +7979,7 @@
           <p:cNvPr id="20" name="">
             <a:extLst xmlns:a="http://schemas.openxmlformats.org/drawingml/2006/main">
               <a:ext uri="{FF2B5EF4-FFF2-40B4-BE49-F238E27FC236}">
-                <a16:creationId xmlns:a16="http://schemas.microsoft.com/office/drawing/2014/main" id="{ED737006-6B85-45CA-9334-CEFB2E9F342E}"/>
+                <a16:creationId xmlns:a16="http://schemas.microsoft.com/office/drawing/2014/main" id="{B199CE8E-0063-4DF6-9D5E-03F2875B670D}"/>
               </a:ext>
             </a:extLst>
           </p:cNvPr>
@@ -8010,7 +8010,7 @@
           <p:cNvPr id="21" name="">
             <a:extLst xmlns:a="http://schemas.openxmlformats.org/drawingml/2006/main">
               <a:ext uri="{FF2B5EF4-FFF2-40B4-BE49-F238E27FC236}">
-                <a16:creationId xmlns:a16="http://schemas.microsoft.com/office/drawing/2014/main" id="{3B70E350-E281-46BC-8EA5-9B2E7640758C}"/>
+                <a16:creationId xmlns:a16="http://schemas.microsoft.com/office/drawing/2014/main" id="{AC7B3DE1-3A5E-45B8-9067-471CBB0984BC}"/>
               </a:ext>
             </a:extLst>
           </p:cNvPr>
@@ -8041,7 +8041,7 @@
           <p:cNvPr id="22" name="">
             <a:extLst xmlns:a="http://schemas.openxmlformats.org/drawingml/2006/main">
               <a:ext uri="{FF2B5EF4-FFF2-40B4-BE49-F238E27FC236}">
-                <a16:creationId xmlns:a16="http://schemas.microsoft.com/office/drawing/2014/main" id="{2949B4D8-8D31-40C7-AB15-C8F1D70A4AB4}"/>
+                <a16:creationId xmlns:a16="http://schemas.microsoft.com/office/drawing/2014/main" id="{F3709D70-7F81-4D66-83F7-141734EF8502}"/>
               </a:ext>
             </a:extLst>
           </p:cNvPr>
@@ -8072,7 +8072,7 @@
           <p:cNvPr id="23" name="">
             <a:extLst xmlns:a="http://schemas.openxmlformats.org/drawingml/2006/main">
               <a:ext uri="{FF2B5EF4-FFF2-40B4-BE49-F238E27FC236}">
-                <a16:creationId xmlns:a16="http://schemas.microsoft.com/office/drawing/2014/main" id="{83720C74-DDFE-43D8-A2EA-B51363426F93}"/>
+                <a16:creationId xmlns:a16="http://schemas.microsoft.com/office/drawing/2014/main" id="{2F267144-F523-4EE7-9395-F9ABBE19062E}"/>
               </a:ext>
             </a:extLst>
           </p:cNvPr>
@@ -8103,7 +8103,7 @@
           <p:cNvPr id="24" name="">
             <a:extLst xmlns:a="http://schemas.openxmlformats.org/drawingml/2006/main">
               <a:ext uri="{FF2B5EF4-FFF2-40B4-BE49-F238E27FC236}">
-                <a16:creationId xmlns:a16="http://schemas.microsoft.com/office/drawing/2014/main" id="{F7249ED4-76F8-44B7-A682-AEAB1911AD81}"/>
+                <a16:creationId xmlns:a16="http://schemas.microsoft.com/office/drawing/2014/main" id="{5EC09843-784B-4F03-9BF2-08679576AB33}"/>
               </a:ext>
             </a:extLst>
           </p:cNvPr>
@@ -8134,7 +8134,7 @@
           <p:cNvPr id="25" name="">
             <a:extLst xmlns:a="http://schemas.openxmlformats.org/drawingml/2006/main">
               <a:ext uri="{FF2B5EF4-FFF2-40B4-BE49-F238E27FC236}">
-                <a16:creationId xmlns:a16="http://schemas.microsoft.com/office/drawing/2014/main" id="{EAE29135-95FF-463B-94E1-87539B8E8B41}"/>
+                <a16:creationId xmlns:a16="http://schemas.microsoft.com/office/drawing/2014/main" id="{DBFCAD55-9963-491D-AE26-8DC69D5E58FF}"/>
               </a:ext>
             </a:extLst>
           </p:cNvPr>
@@ -8165,7 +8165,7 @@
           <p:cNvPr id="26" name="">
             <a:extLst xmlns:a="http://schemas.openxmlformats.org/drawingml/2006/main">
               <a:ext uri="{FF2B5EF4-FFF2-40B4-BE49-F238E27FC236}">
-                <a16:creationId xmlns:a16="http://schemas.microsoft.com/office/drawing/2014/main" id="{C5F078CC-3643-4183-903F-00CB26EA5C51}"/>
+                <a16:creationId xmlns:a16="http://schemas.microsoft.com/office/drawing/2014/main" id="{15F9EBEF-18BD-447D-A86D-C61B57F3249E}"/>
               </a:ext>
             </a:extLst>
           </p:cNvPr>
@@ -8196,7 +8196,7 @@
           <p:cNvPr id="27" name="">
             <a:extLst xmlns:a="http://schemas.openxmlformats.org/drawingml/2006/main">
               <a:ext uri="{FF2B5EF4-FFF2-40B4-BE49-F238E27FC236}">
-                <a16:creationId xmlns:a16="http://schemas.microsoft.com/office/drawing/2014/main" id="{0C208168-25FD-4BD3-B4A1-54ADBCC31E7E}"/>
+                <a16:creationId xmlns:a16="http://schemas.microsoft.com/office/drawing/2014/main" id="{D7D202F4-623B-4F2C-9F34-E16DC459AF06}"/>
               </a:ext>
             </a:extLst>
           </p:cNvPr>
@@ -8227,7 +8227,7 @@
           <p:cNvPr id="28" name="">
             <a:extLst xmlns:a="http://schemas.openxmlformats.org/drawingml/2006/main">
               <a:ext uri="{FF2B5EF4-FFF2-40B4-BE49-F238E27FC236}">
-                <a16:creationId xmlns:a16="http://schemas.microsoft.com/office/drawing/2014/main" id="{67C1FF62-0C77-45D7-BF02-7CF05C425012}"/>
+                <a16:creationId xmlns:a16="http://schemas.microsoft.com/office/drawing/2014/main" id="{82A93BC0-3FDD-445F-9F82-2CAB79F4FA60}"/>
               </a:ext>
             </a:extLst>
           </p:cNvPr>
@@ -8258,7 +8258,7 @@
           <p:cNvPr id="29" name="">
             <a:extLst xmlns:a="http://schemas.openxmlformats.org/drawingml/2006/main">
               <a:ext uri="{FF2B5EF4-FFF2-40B4-BE49-F238E27FC236}">
-                <a16:creationId xmlns:a16="http://schemas.microsoft.com/office/drawing/2014/main" id="{30FE6673-F55D-47F8-BC44-F0EB72D7D829}"/>
+                <a16:creationId xmlns:a16="http://schemas.microsoft.com/office/drawing/2014/main" id="{0B6C5D12-FBCA-48E7-BF2A-9F1A6F668DA9}"/>
               </a:ext>
             </a:extLst>
           </p:cNvPr>
@@ -8289,7 +8289,7 @@
           <p:cNvPr id="30" name="">
             <a:extLst xmlns:a="http://schemas.openxmlformats.org/drawingml/2006/main">
               <a:ext uri="{FF2B5EF4-FFF2-40B4-BE49-F238E27FC236}">
-                <a16:creationId xmlns:a16="http://schemas.microsoft.com/office/drawing/2014/main" id="{C89B7E23-85BB-44E7-B282-5779C7B64880}"/>
+                <a16:creationId xmlns:a16="http://schemas.microsoft.com/office/drawing/2014/main" id="{4FC5E14A-4942-4CD8-A86D-44F68EC6F795}"/>
               </a:ext>
             </a:extLst>
           </p:cNvPr>
@@ -8320,7 +8320,7 @@
           <p:cNvPr id="31" name="">
             <a:extLst xmlns:a="http://schemas.openxmlformats.org/drawingml/2006/main">
               <a:ext uri="{FF2B5EF4-FFF2-40B4-BE49-F238E27FC236}">
-                <a16:creationId xmlns:a16="http://schemas.microsoft.com/office/drawing/2014/main" id="{131897A2-558F-414F-A406-B9309E91117F}"/>
+                <a16:creationId xmlns:a16="http://schemas.microsoft.com/office/drawing/2014/main" id="{94706C08-01EC-4734-9372-3CEEC6865AD4}"/>
               </a:ext>
             </a:extLst>
           </p:cNvPr>
@@ -8351,7 +8351,7 @@
           <p:cNvPr id="32" name="">
             <a:extLst xmlns:a="http://schemas.openxmlformats.org/drawingml/2006/main">
               <a:ext uri="{FF2B5EF4-FFF2-40B4-BE49-F238E27FC236}">
-                <a16:creationId xmlns:a16="http://schemas.microsoft.com/office/drawing/2014/main" id="{72181DC3-F536-44F7-878B-67E90DA2A558}"/>
+                <a16:creationId xmlns:a16="http://schemas.microsoft.com/office/drawing/2014/main" id="{49F35BC4-87E3-4226-94E4-D7249DB7D271}"/>
               </a:ext>
             </a:extLst>
           </p:cNvPr>
@@ -8382,7 +8382,7 @@
           <p:cNvPr id="33" name="">
             <a:extLst xmlns:a="http://schemas.openxmlformats.org/drawingml/2006/main">
               <a:ext uri="{FF2B5EF4-FFF2-40B4-BE49-F238E27FC236}">
-                <a16:creationId xmlns:a16="http://schemas.microsoft.com/office/drawing/2014/main" id="{B659A320-9E55-4212-9604-424B2DBA4AF8}"/>
+                <a16:creationId xmlns:a16="http://schemas.microsoft.com/office/drawing/2014/main" id="{5481DFA4-CE14-48D9-A414-24866F14CCB1}"/>
               </a:ext>
             </a:extLst>
           </p:cNvPr>
@@ -8413,7 +8413,7 @@
           <p:cNvPr id="34" name="">
             <a:extLst xmlns:a="http://schemas.openxmlformats.org/drawingml/2006/main">
               <a:ext uri="{FF2B5EF4-FFF2-40B4-BE49-F238E27FC236}">
-                <a16:creationId xmlns:a16="http://schemas.microsoft.com/office/drawing/2014/main" id="{073ACE1E-4721-4C12-B41D-1B658B0889C6}"/>
+                <a16:creationId xmlns:a16="http://schemas.microsoft.com/office/drawing/2014/main" id="{72A0D488-FDA8-43EC-AFBF-D86950A2959C}"/>
               </a:ext>
             </a:extLst>
           </p:cNvPr>
@@ -8446,7 +8446,7 @@
           <p:cNvPr id="35" name="">
             <a:extLst xmlns:a="http://schemas.openxmlformats.org/drawingml/2006/main">
               <a:ext uri="{FF2B5EF4-FFF2-40B4-BE49-F238E27FC236}">
-                <a16:creationId xmlns:a16="http://schemas.microsoft.com/office/drawing/2014/main" id="{BA81F2FA-9909-4E85-9E6C-5B2B3EC0DE22}"/>
+                <a16:creationId xmlns:a16="http://schemas.microsoft.com/office/drawing/2014/main" id="{2687A190-FCC6-4CB1-9C6F-9D32548AFFE1}"/>
               </a:ext>
             </a:extLst>
           </p:cNvPr>
@@ -8508,7 +8508,7 @@
           <p:cNvPr id="36" name="">
             <a:extLst xmlns:a="http://schemas.openxmlformats.org/drawingml/2006/main">
               <a:ext uri="{FF2B5EF4-FFF2-40B4-BE49-F238E27FC236}">
-                <a16:creationId xmlns:a16="http://schemas.microsoft.com/office/drawing/2014/main" id="{1FF0C870-9912-4F97-8D07-75DB0374BFC3}"/>
+                <a16:creationId xmlns:a16="http://schemas.microsoft.com/office/drawing/2014/main" id="{1731D0BE-FB11-45CF-B5C4-F3F2C0045793}"/>
               </a:ext>
             </a:extLst>
           </p:cNvPr>
@@ -8570,7 +8570,7 @@
           <p:cNvPr id="37" name="">
             <a:extLst xmlns:a="http://schemas.openxmlformats.org/drawingml/2006/main">
               <a:ext uri="{FF2B5EF4-FFF2-40B4-BE49-F238E27FC236}">
-                <a16:creationId xmlns:a16="http://schemas.microsoft.com/office/drawing/2014/main" id="{FB61C3D4-6F81-4F1D-AAB8-18F991D7BEDA}"/>
+                <a16:creationId xmlns:a16="http://schemas.microsoft.com/office/drawing/2014/main" id="{7C4603FF-4E64-41C5-A40F-243EFE4F20FD}"/>
               </a:ext>
             </a:extLst>
           </p:cNvPr>
@@ -8632,7 +8632,7 @@
           <p:cNvPr id="38" name="">
             <a:extLst xmlns:a="http://schemas.openxmlformats.org/drawingml/2006/main">
               <a:ext uri="{FF2B5EF4-FFF2-40B4-BE49-F238E27FC236}">
-                <a16:creationId xmlns:a16="http://schemas.microsoft.com/office/drawing/2014/main" id="{4A46AE06-2965-40D9-9935-1F479A0F4323}"/>
+                <a16:creationId xmlns:a16="http://schemas.microsoft.com/office/drawing/2014/main" id="{6F14FD7C-30D0-483E-BA5B-C4D958204089}"/>
               </a:ext>
             </a:extLst>
           </p:cNvPr>
@@ -8694,7 +8694,7 @@
           <p:cNvPr id="39" name="">
             <a:extLst xmlns:a="http://schemas.openxmlformats.org/drawingml/2006/main">
               <a:ext uri="{FF2B5EF4-FFF2-40B4-BE49-F238E27FC236}">
-                <a16:creationId xmlns:a16="http://schemas.microsoft.com/office/drawing/2014/main" id="{485F2B21-5362-402D-9DED-EE6C615D70F7}"/>
+                <a16:creationId xmlns:a16="http://schemas.microsoft.com/office/drawing/2014/main" id="{DC18E4E2-3040-40CA-8E6C-0C2F98E1385A}"/>
               </a:ext>
             </a:extLst>
           </p:cNvPr>
@@ -8725,7 +8725,7 @@
           <p:cNvPr id="40" name="">
             <a:extLst xmlns:a="http://schemas.openxmlformats.org/drawingml/2006/main">
               <a:ext uri="{FF2B5EF4-FFF2-40B4-BE49-F238E27FC236}">
-                <a16:creationId xmlns:a16="http://schemas.microsoft.com/office/drawing/2014/main" id="{A96479CB-0E3E-4D1C-A9FE-D89222E3CFCD}"/>
+                <a16:creationId xmlns:a16="http://schemas.microsoft.com/office/drawing/2014/main" id="{18D81188-90D5-42C8-8DE3-7C45BBAABBC7}"/>
               </a:ext>
             </a:extLst>
           </p:cNvPr>
@@ -8756,7 +8756,7 @@
           <p:cNvPr id="41" name="">
             <a:extLst xmlns:a="http://schemas.openxmlformats.org/drawingml/2006/main">
               <a:ext uri="{FF2B5EF4-FFF2-40B4-BE49-F238E27FC236}">
-                <a16:creationId xmlns:a16="http://schemas.microsoft.com/office/drawing/2014/main" id="{61D0BD54-EF08-44B3-AC03-9D2F228E462C}"/>
+                <a16:creationId xmlns:a16="http://schemas.microsoft.com/office/drawing/2014/main" id="{F7F93130-E104-4645-B927-0E1C193EF4AE}"/>
               </a:ext>
             </a:extLst>
           </p:cNvPr>
@@ -8818,7 +8818,7 @@
           <p:cNvPr id="42" name="">
             <a:extLst xmlns:a="http://schemas.openxmlformats.org/drawingml/2006/main">
               <a:ext uri="{FF2B5EF4-FFF2-40B4-BE49-F238E27FC236}">
-                <a16:creationId xmlns:a16="http://schemas.microsoft.com/office/drawing/2014/main" id="{BD062366-01C1-43AE-84D1-1F61BAE8FDB8}"/>
+                <a16:creationId xmlns:a16="http://schemas.microsoft.com/office/drawing/2014/main" id="{E8971FE3-C714-42EE-9963-702FE8578CC0}"/>
               </a:ext>
             </a:extLst>
           </p:cNvPr>
@@ -8853,7 +8853,7 @@
           <p:cNvPr id="43" name="">
             <a:extLst xmlns:a="http://schemas.openxmlformats.org/drawingml/2006/main">
               <a:ext uri="{FF2B5EF4-FFF2-40B4-BE49-F238E27FC236}">
-                <a16:creationId xmlns:a16="http://schemas.microsoft.com/office/drawing/2014/main" id="{68D6A311-3ACF-497C-AEDE-F7B2B06495E7}"/>
+                <a16:creationId xmlns:a16="http://schemas.microsoft.com/office/drawing/2014/main" id="{2C8581CF-4529-4FBA-B60E-BC4E17352513}"/>
               </a:ext>
             </a:extLst>
           </p:cNvPr>
@@ -8915,7 +8915,7 @@
           <p:cNvPr id="44" name="">
             <a:extLst xmlns:a="http://schemas.openxmlformats.org/drawingml/2006/main">
               <a:ext uri="{FF2B5EF4-FFF2-40B4-BE49-F238E27FC236}">
-                <a16:creationId xmlns:a16="http://schemas.microsoft.com/office/drawing/2014/main" id="{69C60CB5-290D-4177-8A52-D9004CFA9279}"/>
+                <a16:creationId xmlns:a16="http://schemas.microsoft.com/office/drawing/2014/main" id="{F9FBE1DF-0E04-436D-8114-D2674F8C886F}"/>
               </a:ext>
             </a:extLst>
           </p:cNvPr>
@@ -8977,7 +8977,7 @@
           <p:cNvPr id="45" name="">
             <a:extLst xmlns:a="http://schemas.openxmlformats.org/drawingml/2006/main">
               <a:ext uri="{FF2B5EF4-FFF2-40B4-BE49-F238E27FC236}">
-                <a16:creationId xmlns:a16="http://schemas.microsoft.com/office/drawing/2014/main" id="{7B887D49-27D5-41C1-BDA5-C54DB6371075}"/>
+                <a16:creationId xmlns:a16="http://schemas.microsoft.com/office/drawing/2014/main" id="{18C8BCFB-018C-44C9-BBCE-37DB167B9BD9}"/>
               </a:ext>
             </a:extLst>
           </p:cNvPr>
@@ -9039,7 +9039,7 @@
           <p:cNvPr id="46" name="">
             <a:extLst xmlns:a="http://schemas.openxmlformats.org/drawingml/2006/main">
               <a:ext uri="{FF2B5EF4-FFF2-40B4-BE49-F238E27FC236}">
-                <a16:creationId xmlns:a16="http://schemas.microsoft.com/office/drawing/2014/main" id="{876C30F7-12B6-4C70-96D6-16B79D78E09B}"/>
+                <a16:creationId xmlns:a16="http://schemas.microsoft.com/office/drawing/2014/main" id="{452A8126-696D-4480-BC62-3A35DE098FDC}"/>
               </a:ext>
             </a:extLst>
           </p:cNvPr>
@@ -9074,7 +9074,7 @@
           <p:cNvPr id="47" name="">
             <a:extLst xmlns:a="http://schemas.openxmlformats.org/drawingml/2006/main">
               <a:ext uri="{FF2B5EF4-FFF2-40B4-BE49-F238E27FC236}">
-                <a16:creationId xmlns:a16="http://schemas.microsoft.com/office/drawing/2014/main" id="{A0F62433-9619-4D43-948E-B6BC8FC180E2}"/>
+                <a16:creationId xmlns:a16="http://schemas.microsoft.com/office/drawing/2014/main" id="{0D1B78EB-A864-4BC4-B289-C84EF5C6FB83}"/>
               </a:ext>
             </a:extLst>
           </p:cNvPr>
@@ -9136,7 +9136,7 @@
           <p:cNvPr id="48" name="">
             <a:extLst xmlns:a="http://schemas.openxmlformats.org/drawingml/2006/main">
               <a:ext uri="{FF2B5EF4-FFF2-40B4-BE49-F238E27FC236}">
-                <a16:creationId xmlns:a16="http://schemas.microsoft.com/office/drawing/2014/main" id="{FC41AF66-407C-4EF0-809B-D398EAD569BD}"/>
+                <a16:creationId xmlns:a16="http://schemas.microsoft.com/office/drawing/2014/main" id="{5E8DAC88-6E9D-4F21-B5A3-2330D6EAEBAF}"/>
               </a:ext>
             </a:extLst>
           </p:cNvPr>
@@ -9198,7 +9198,7 @@
           <p:cNvPr id="49" name="">
             <a:extLst xmlns:a="http://schemas.openxmlformats.org/drawingml/2006/main">
               <a:ext uri="{FF2B5EF4-FFF2-40B4-BE49-F238E27FC236}">
-                <a16:creationId xmlns:a16="http://schemas.microsoft.com/office/drawing/2014/main" id="{0A8E2F30-131E-43B7-BE22-39A41213A7FC}"/>
+                <a16:creationId xmlns:a16="http://schemas.microsoft.com/office/drawing/2014/main" id="{5981FF2F-830E-4941-B0C6-0B68560E14C2}"/>
               </a:ext>
             </a:extLst>
           </p:cNvPr>
@@ -9260,7 +9260,7 @@
           <p:cNvPr id="50" name="">
             <a:extLst xmlns:a="http://schemas.openxmlformats.org/drawingml/2006/main">
               <a:ext uri="{FF2B5EF4-FFF2-40B4-BE49-F238E27FC236}">
-                <a16:creationId xmlns:a16="http://schemas.microsoft.com/office/drawing/2014/main" id="{4EB8EFC9-4831-478E-B007-41026EBC0C64}"/>
+                <a16:creationId xmlns:a16="http://schemas.microsoft.com/office/drawing/2014/main" id="{F1D73D82-EA31-439C-ABE2-3D5556AB9852}"/>
               </a:ext>
             </a:extLst>
           </p:cNvPr>
@@ -9295,7 +9295,7 @@
           <p:cNvPr id="51" name="">
             <a:extLst xmlns:a="http://schemas.openxmlformats.org/drawingml/2006/main">
               <a:ext uri="{FF2B5EF4-FFF2-40B4-BE49-F238E27FC236}">
-                <a16:creationId xmlns:a16="http://schemas.microsoft.com/office/drawing/2014/main" id="{B2B316D9-8706-4D55-8F9C-2626980FF82A}"/>
+                <a16:creationId xmlns:a16="http://schemas.microsoft.com/office/drawing/2014/main" id="{59E1CBFF-2AEC-49D1-AC74-64685C516DCC}"/>
               </a:ext>
             </a:extLst>
           </p:cNvPr>
@@ -9357,7 +9357,7 @@
           <p:cNvPr id="52" name="">
             <a:extLst xmlns:a="http://schemas.openxmlformats.org/drawingml/2006/main">
               <a:ext uri="{FF2B5EF4-FFF2-40B4-BE49-F238E27FC236}">
-                <a16:creationId xmlns:a16="http://schemas.microsoft.com/office/drawing/2014/main" id="{0AA9510F-4C47-4544-B0E1-9E73BBA9EE1B}"/>
+                <a16:creationId xmlns:a16="http://schemas.microsoft.com/office/drawing/2014/main" id="{882E323A-0F57-4933-9233-F7E35873A4D6}"/>
               </a:ext>
             </a:extLst>
           </p:cNvPr>
@@ -9419,7 +9419,7 @@
           <p:cNvPr id="53" name="">
             <a:extLst xmlns:a="http://schemas.openxmlformats.org/drawingml/2006/main">
               <a:ext uri="{FF2B5EF4-FFF2-40B4-BE49-F238E27FC236}">
-                <a16:creationId xmlns:a16="http://schemas.microsoft.com/office/drawing/2014/main" id="{B9F0A213-F98C-4C67-AFEA-BE8018CDE952}"/>
+                <a16:creationId xmlns:a16="http://schemas.microsoft.com/office/drawing/2014/main" id="{055410DB-22A8-4CEA-A823-6DE2C3BA245A}"/>
               </a:ext>
             </a:extLst>
           </p:cNvPr>
@@ -9481,7 +9481,7 @@
           <p:cNvPr id="54" name="">
             <a:extLst xmlns:a="http://schemas.openxmlformats.org/drawingml/2006/main">
               <a:ext uri="{FF2B5EF4-FFF2-40B4-BE49-F238E27FC236}">
-                <a16:creationId xmlns:a16="http://schemas.microsoft.com/office/drawing/2014/main" id="{4F289AE3-378E-40DD-AA1E-DA864A0B6AAE}"/>
+                <a16:creationId xmlns:a16="http://schemas.microsoft.com/office/drawing/2014/main" id="{52D73AAB-053E-4A3B-A4DA-48ADAC00BCB0}"/>
               </a:ext>
             </a:extLst>
           </p:cNvPr>
@@ -9512,7 +9512,7 @@
           <p:cNvPr id="55" name="">
             <a:extLst xmlns:a="http://schemas.openxmlformats.org/drawingml/2006/main">
               <a:ext uri="{FF2B5EF4-FFF2-40B4-BE49-F238E27FC236}">
-                <a16:creationId xmlns:a16="http://schemas.microsoft.com/office/drawing/2014/main" id="{8852DBB0-A9D1-45CB-A855-9BC1FE030727}"/>
+                <a16:creationId xmlns:a16="http://schemas.microsoft.com/office/drawing/2014/main" id="{100716F9-9B64-4302-8816-BDA374A00B5A}"/>
               </a:ext>
             </a:extLst>
           </p:cNvPr>
@@ -9543,7 +9543,7 @@
           <p:cNvPr id="56" name="">
             <a:extLst xmlns:a="http://schemas.openxmlformats.org/drawingml/2006/main">
               <a:ext uri="{FF2B5EF4-FFF2-40B4-BE49-F238E27FC236}">
-                <a16:creationId xmlns:a16="http://schemas.microsoft.com/office/drawing/2014/main" id="{2FA747F2-89F0-4BC0-A978-BF22F2F87EA8}"/>
+                <a16:creationId xmlns:a16="http://schemas.microsoft.com/office/drawing/2014/main" id="{96E6B5B7-4928-4622-9E25-1C3311FC332F}"/>
               </a:ext>
             </a:extLst>
           </p:cNvPr>
@@ -9605,7 +9605,7 @@
           <p:cNvPr id="57" name="">
             <a:extLst xmlns:a="http://schemas.openxmlformats.org/drawingml/2006/main">
               <a:ext uri="{FF2B5EF4-FFF2-40B4-BE49-F238E27FC236}">
-                <a16:creationId xmlns:a16="http://schemas.microsoft.com/office/drawing/2014/main" id="{A0C892A5-4438-4938-9AB0-5DF3785AE1E5}"/>
+                <a16:creationId xmlns:a16="http://schemas.microsoft.com/office/drawing/2014/main" id="{513892C2-69FE-4E62-9EA6-8341B6C61D08}"/>
               </a:ext>
             </a:extLst>
           </p:cNvPr>
@@ -9665,7 +9665,7 @@
     </p:spTree>
     <p:extLst>
       <p:ext uri="{BB962C8B-B14F-4D97-AF65-F5344CB8AC3E}">
-        <p14:creationId xmlns:p14="http://schemas.microsoft.com/office/powerpoint/2010/main" val="1913275035"/>
+        <p14:creationId xmlns:p14="http://schemas.microsoft.com/office/powerpoint/2010/main" val="1239640079"/>
       </p:ext>
     </p:extLst>
   </p:cSld>
@@ -9696,7 +9696,7 @@
           <p:cNvPr id="49" name="">
             <a:extLst xmlns:a="http://schemas.openxmlformats.org/drawingml/2006/main">
               <a:ext uri="{FF2B5EF4-FFF2-40B4-BE49-F238E27FC236}">
-                <a16:creationId xmlns:a16="http://schemas.microsoft.com/office/drawing/2014/main" id="{B0F66A3D-D112-4B88-9BCB-861B6156F705}"/>
+                <a16:creationId xmlns:a16="http://schemas.microsoft.com/office/drawing/2014/main" id="{093BB243-24F3-4608-A4F4-C5867899E8F7}"/>
               </a:ext>
             </a:extLst>
           </p:cNvPr>
@@ -9727,7 +9727,7 @@
           <p:cNvPr id="2" name="">
             <a:extLst xmlns:a="http://schemas.openxmlformats.org/drawingml/2006/main">
               <a:ext uri="{FF2B5EF4-FFF2-40B4-BE49-F238E27FC236}">
-                <a16:creationId xmlns:a16="http://schemas.microsoft.com/office/drawing/2014/main" id="{1D2655D3-6004-40B3-90B1-BFDAA7A308F2}"/>
+                <a16:creationId xmlns:a16="http://schemas.microsoft.com/office/drawing/2014/main" id="{F7B0EC04-3812-4A73-AB37-D2FEDD1B3594}"/>
               </a:ext>
             </a:extLst>
           </p:cNvPr>
@@ -9758,7 +9758,7 @@
           <p:cNvPr id="3" name="">
             <a:extLst xmlns:a="http://schemas.openxmlformats.org/drawingml/2006/main">
               <a:ext uri="{FF2B5EF4-FFF2-40B4-BE49-F238E27FC236}">
-                <a16:creationId xmlns:a16="http://schemas.microsoft.com/office/drawing/2014/main" id="{89244438-3D1E-4E5F-9A7D-9BB800BE2189}"/>
+                <a16:creationId xmlns:a16="http://schemas.microsoft.com/office/drawing/2014/main" id="{5821441A-6433-40B9-B79F-6239DCA73F27}"/>
               </a:ext>
             </a:extLst>
           </p:cNvPr>
@@ -9789,7 +9789,7 @@
           <p:cNvPr id="4" name="">
             <a:extLst xmlns:a="http://schemas.openxmlformats.org/drawingml/2006/main">
               <a:ext uri="{FF2B5EF4-FFF2-40B4-BE49-F238E27FC236}">
-                <a16:creationId xmlns:a16="http://schemas.microsoft.com/office/drawing/2014/main" id="{65ECDFB6-D114-4CF3-BA30-CEF5D97F9F30}"/>
+                <a16:creationId xmlns:a16="http://schemas.microsoft.com/office/drawing/2014/main" id="{C51FAA45-F63A-4040-B022-76B9003E0E0B}"/>
               </a:ext>
             </a:extLst>
           </p:cNvPr>
@@ -9820,7 +9820,7 @@
           <p:cNvPr id="5" name="">
             <a:extLst xmlns:a="http://schemas.openxmlformats.org/drawingml/2006/main">
               <a:ext uri="{FF2B5EF4-FFF2-40B4-BE49-F238E27FC236}">
-                <a16:creationId xmlns:a16="http://schemas.microsoft.com/office/drawing/2014/main" id="{AB8F8464-ABAD-4DE8-B3E8-17699596A310}"/>
+                <a16:creationId xmlns:a16="http://schemas.microsoft.com/office/drawing/2014/main" id="{4397D6EA-539E-48E2-BAB7-1164077FDAFA}"/>
               </a:ext>
             </a:extLst>
           </p:cNvPr>
@@ -9851,7 +9851,7 @@
           <p:cNvPr id="6" name="">
             <a:extLst xmlns:a="http://schemas.openxmlformats.org/drawingml/2006/main">
               <a:ext uri="{FF2B5EF4-FFF2-40B4-BE49-F238E27FC236}">
-                <a16:creationId xmlns:a16="http://schemas.microsoft.com/office/drawing/2014/main" id="{5F9594C6-C7B1-41CB-AD1B-1AA95C16C5C4}"/>
+                <a16:creationId xmlns:a16="http://schemas.microsoft.com/office/drawing/2014/main" id="{A1828B72-F652-454F-BF2D-3FA086887F27}"/>
               </a:ext>
             </a:extLst>
           </p:cNvPr>
@@ -9882,7 +9882,7 @@
           <p:cNvPr id="7" name="">
             <a:extLst xmlns:a="http://schemas.openxmlformats.org/drawingml/2006/main">
               <a:ext uri="{FF2B5EF4-FFF2-40B4-BE49-F238E27FC236}">
-                <a16:creationId xmlns:a16="http://schemas.microsoft.com/office/drawing/2014/main" id="{AE211F24-BA35-45EC-A463-8FB9969740ED}"/>
+                <a16:creationId xmlns:a16="http://schemas.microsoft.com/office/drawing/2014/main" id="{21E20600-E9CA-4848-9CF1-69E8829BD566}"/>
               </a:ext>
             </a:extLst>
           </p:cNvPr>
@@ -9913,7 +9913,7 @@
           <p:cNvPr id="8" name="">
             <a:extLst xmlns:a="http://schemas.openxmlformats.org/drawingml/2006/main">
               <a:ext uri="{FF2B5EF4-FFF2-40B4-BE49-F238E27FC236}">
-                <a16:creationId xmlns:a16="http://schemas.microsoft.com/office/drawing/2014/main" id="{099F6B90-B543-400A-BAF3-DD66B2A00C82}"/>
+                <a16:creationId xmlns:a16="http://schemas.microsoft.com/office/drawing/2014/main" id="{AA728E26-C673-42C4-97C1-236D7CF7224E}"/>
               </a:ext>
             </a:extLst>
           </p:cNvPr>
@@ -9944,7 +9944,7 @@
           <p:cNvPr id="9" name="">
             <a:extLst xmlns:a="http://schemas.openxmlformats.org/drawingml/2006/main">
               <a:ext uri="{FF2B5EF4-FFF2-40B4-BE49-F238E27FC236}">
-                <a16:creationId xmlns:a16="http://schemas.microsoft.com/office/drawing/2014/main" id="{3CDE560C-BE0E-4902-A0FB-AD779FF398C9}"/>
+                <a16:creationId xmlns:a16="http://schemas.microsoft.com/office/drawing/2014/main" id="{FE900B8C-28AA-4D7B-BB9D-4AC3C0EA3E3C}"/>
               </a:ext>
             </a:extLst>
           </p:cNvPr>
@@ -9975,7 +9975,7 @@
           <p:cNvPr id="10" name="">
             <a:extLst xmlns:a="http://schemas.openxmlformats.org/drawingml/2006/main">
               <a:ext uri="{FF2B5EF4-FFF2-40B4-BE49-F238E27FC236}">
-                <a16:creationId xmlns:a16="http://schemas.microsoft.com/office/drawing/2014/main" id="{29048956-35CB-49B4-9FCC-25BC1C3F93B1}"/>
+                <a16:creationId xmlns:a16="http://schemas.microsoft.com/office/drawing/2014/main" id="{2ABBD115-9E8A-485A-8A04-75261A601304}"/>
               </a:ext>
             </a:extLst>
           </p:cNvPr>
@@ -10006,7 +10006,7 @@
           <p:cNvPr id="11" name="">
             <a:extLst xmlns:a="http://schemas.openxmlformats.org/drawingml/2006/main">
               <a:ext uri="{FF2B5EF4-FFF2-40B4-BE49-F238E27FC236}">
-                <a16:creationId xmlns:a16="http://schemas.microsoft.com/office/drawing/2014/main" id="{11E706F4-903C-4783-805F-A26A8161FFAE}"/>
+                <a16:creationId xmlns:a16="http://schemas.microsoft.com/office/drawing/2014/main" id="{E3AC6A44-B4CE-4BBD-ABD3-85745EDF6661}"/>
               </a:ext>
             </a:extLst>
           </p:cNvPr>
@@ -10037,7 +10037,7 @@
           <p:cNvPr id="12" name="">
             <a:extLst xmlns:a="http://schemas.openxmlformats.org/drawingml/2006/main">
               <a:ext uri="{FF2B5EF4-FFF2-40B4-BE49-F238E27FC236}">
-                <a16:creationId xmlns:a16="http://schemas.microsoft.com/office/drawing/2014/main" id="{AB191E66-4595-40F1-9A3F-22F823112043}"/>
+                <a16:creationId xmlns:a16="http://schemas.microsoft.com/office/drawing/2014/main" id="{4B0095FC-F111-483F-83D4-7DBB9367D466}"/>
               </a:ext>
             </a:extLst>
           </p:cNvPr>
@@ -10068,7 +10068,7 @@
           <p:cNvPr id="13" name="">
             <a:extLst xmlns:a="http://schemas.openxmlformats.org/drawingml/2006/main">
               <a:ext uri="{FF2B5EF4-FFF2-40B4-BE49-F238E27FC236}">
-                <a16:creationId xmlns:a16="http://schemas.microsoft.com/office/drawing/2014/main" id="{46D45592-7CB0-4805-A29E-1BA2689FEF7A}"/>
+                <a16:creationId xmlns:a16="http://schemas.microsoft.com/office/drawing/2014/main" id="{160C9932-6377-48DF-869C-67419DC87D3D}"/>
               </a:ext>
             </a:extLst>
           </p:cNvPr>
@@ -10099,7 +10099,7 @@
           <p:cNvPr id="14" name="">
             <a:extLst xmlns:a="http://schemas.openxmlformats.org/drawingml/2006/main">
               <a:ext uri="{FF2B5EF4-FFF2-40B4-BE49-F238E27FC236}">
-                <a16:creationId xmlns:a16="http://schemas.microsoft.com/office/drawing/2014/main" id="{5EA32399-E3D0-4696-A472-C909C994B7A2}"/>
+                <a16:creationId xmlns:a16="http://schemas.microsoft.com/office/drawing/2014/main" id="{D093D0D5-4806-4F29-8350-F1CAE72C859A}"/>
               </a:ext>
             </a:extLst>
           </p:cNvPr>
@@ -10130,7 +10130,7 @@
           <p:cNvPr id="15" name="">
             <a:extLst xmlns:a="http://schemas.openxmlformats.org/drawingml/2006/main">
               <a:ext uri="{FF2B5EF4-FFF2-40B4-BE49-F238E27FC236}">
-                <a16:creationId xmlns:a16="http://schemas.microsoft.com/office/drawing/2014/main" id="{4194B9BA-B13E-4D1A-B7A4-B1F8C1619292}"/>
+                <a16:creationId xmlns:a16="http://schemas.microsoft.com/office/drawing/2014/main" id="{E32E39D3-8E11-484E-A4AB-C58880436365}"/>
               </a:ext>
             </a:extLst>
           </p:cNvPr>
@@ -10161,7 +10161,7 @@
           <p:cNvPr id="16" name="">
             <a:extLst xmlns:a="http://schemas.openxmlformats.org/drawingml/2006/main">
               <a:ext uri="{FF2B5EF4-FFF2-40B4-BE49-F238E27FC236}">
-                <a16:creationId xmlns:a16="http://schemas.microsoft.com/office/drawing/2014/main" id="{A77EE360-8748-4CD7-8C63-A8D42BF9CEBD}"/>
+                <a16:creationId xmlns:a16="http://schemas.microsoft.com/office/drawing/2014/main" id="{BA790985-D0CB-4CA6-A201-9CD8CD2A15E9}"/>
               </a:ext>
             </a:extLst>
           </p:cNvPr>
@@ -10192,7 +10192,7 @@
           <p:cNvPr id="17" name="">
             <a:extLst xmlns:a="http://schemas.openxmlformats.org/drawingml/2006/main">
               <a:ext uri="{FF2B5EF4-FFF2-40B4-BE49-F238E27FC236}">
-                <a16:creationId xmlns:a16="http://schemas.microsoft.com/office/drawing/2014/main" id="{CEE5F837-E064-4A89-A05D-4FA4ED59DCDA}"/>
+                <a16:creationId xmlns:a16="http://schemas.microsoft.com/office/drawing/2014/main" id="{20BA62E2-076A-4962-B179-7B83EAD8F8C8}"/>
               </a:ext>
             </a:extLst>
           </p:cNvPr>
@@ -10223,7 +10223,7 @@
           <p:cNvPr id="18" name="">
             <a:extLst xmlns:a="http://schemas.openxmlformats.org/drawingml/2006/main">
               <a:ext uri="{FF2B5EF4-FFF2-40B4-BE49-F238E27FC236}">
-                <a16:creationId xmlns:a16="http://schemas.microsoft.com/office/drawing/2014/main" id="{63D91F5C-7A15-4339-800C-7003134F088B}"/>
+                <a16:creationId xmlns:a16="http://schemas.microsoft.com/office/drawing/2014/main" id="{A4D909FA-59D9-4B22-9156-A8B7902C383B}"/>
               </a:ext>
             </a:extLst>
           </p:cNvPr>
@@ -10254,7 +10254,7 @@
           <p:cNvPr id="19" name="">
             <a:extLst xmlns:a="http://schemas.openxmlformats.org/drawingml/2006/main">
               <a:ext uri="{FF2B5EF4-FFF2-40B4-BE49-F238E27FC236}">
-                <a16:creationId xmlns:a16="http://schemas.microsoft.com/office/drawing/2014/main" id="{0F314B94-8235-4407-82CC-23FCD72DCB3A}"/>
+                <a16:creationId xmlns:a16="http://schemas.microsoft.com/office/drawing/2014/main" id="{700EB0B6-55EB-44C1-B3CD-1174C4B64754}"/>
               </a:ext>
             </a:extLst>
           </p:cNvPr>
@@ -10285,7 +10285,7 @@
           <p:cNvPr id="20" name="">
             <a:extLst xmlns:a="http://schemas.openxmlformats.org/drawingml/2006/main">
               <a:ext uri="{FF2B5EF4-FFF2-40B4-BE49-F238E27FC236}">
-                <a16:creationId xmlns:a16="http://schemas.microsoft.com/office/drawing/2014/main" id="{5698BF7A-7EC7-47A3-98B1-C14B6275C499}"/>
+                <a16:creationId xmlns:a16="http://schemas.microsoft.com/office/drawing/2014/main" id="{49E2A92D-014D-4FE5-AFEC-B85013B8D1D4}"/>
               </a:ext>
             </a:extLst>
           </p:cNvPr>
@@ -10316,7 +10316,7 @@
           <p:cNvPr id="21" name="">
             <a:extLst xmlns:a="http://schemas.openxmlformats.org/drawingml/2006/main">
               <a:ext uri="{FF2B5EF4-FFF2-40B4-BE49-F238E27FC236}">
-                <a16:creationId xmlns:a16="http://schemas.microsoft.com/office/drawing/2014/main" id="{A488AD6C-0A34-418C-A812-2F9AF576EA8A}"/>
+                <a16:creationId xmlns:a16="http://schemas.microsoft.com/office/drawing/2014/main" id="{A6683C68-5A4D-4853-AB5D-33130C19B97A}"/>
               </a:ext>
             </a:extLst>
           </p:cNvPr>
@@ -10347,7 +10347,7 @@
           <p:cNvPr id="22" name="">
             <a:extLst xmlns:a="http://schemas.openxmlformats.org/drawingml/2006/main">
               <a:ext uri="{FF2B5EF4-FFF2-40B4-BE49-F238E27FC236}">
-                <a16:creationId xmlns:a16="http://schemas.microsoft.com/office/drawing/2014/main" id="{C4E0CFC4-CD8E-4452-AADB-F7A775DB80ED}"/>
+                <a16:creationId xmlns:a16="http://schemas.microsoft.com/office/drawing/2014/main" id="{8FD4FE98-63DD-4087-85D9-B63E34C6DDAA}"/>
               </a:ext>
             </a:extLst>
           </p:cNvPr>
@@ -10378,7 +10378,7 @@
           <p:cNvPr id="23" name="">
             <a:extLst xmlns:a="http://schemas.openxmlformats.org/drawingml/2006/main">
               <a:ext uri="{FF2B5EF4-FFF2-40B4-BE49-F238E27FC236}">
-                <a16:creationId xmlns:a16="http://schemas.microsoft.com/office/drawing/2014/main" id="{FD99F2F7-AC06-46B9-BD95-A3DD17D2C23D}"/>
+                <a16:creationId xmlns:a16="http://schemas.microsoft.com/office/drawing/2014/main" id="{F98125B8-7A9D-4DA1-B3F6-0B84AEC95767}"/>
               </a:ext>
             </a:extLst>
           </p:cNvPr>
@@ -10409,7 +10409,7 @@
           <p:cNvPr id="24" name="">
             <a:extLst xmlns:a="http://schemas.openxmlformats.org/drawingml/2006/main">
               <a:ext uri="{FF2B5EF4-FFF2-40B4-BE49-F238E27FC236}">
-                <a16:creationId xmlns:a16="http://schemas.microsoft.com/office/drawing/2014/main" id="{EF7CB9BA-1DDC-4CBC-9EA1-8505671D2058}"/>
+                <a16:creationId xmlns:a16="http://schemas.microsoft.com/office/drawing/2014/main" id="{B9B3D822-DCBD-4E60-851A-5A9A2EF08CDA}"/>
               </a:ext>
             </a:extLst>
           </p:cNvPr>
@@ -10440,7 +10440,7 @@
           <p:cNvPr id="25" name="">
             <a:extLst xmlns:a="http://schemas.openxmlformats.org/drawingml/2006/main">
               <a:ext uri="{FF2B5EF4-FFF2-40B4-BE49-F238E27FC236}">
-                <a16:creationId xmlns:a16="http://schemas.microsoft.com/office/drawing/2014/main" id="{B5331DA3-9FE5-4802-82EF-051B2F95370F}"/>
+                <a16:creationId xmlns:a16="http://schemas.microsoft.com/office/drawing/2014/main" id="{3670C2D4-4EAE-41D5-B2AE-01BE7C3C04C2}"/>
               </a:ext>
             </a:extLst>
           </p:cNvPr>
@@ -10471,7 +10471,7 @@
           <p:cNvPr id="26" name="">
             <a:extLst xmlns:a="http://schemas.openxmlformats.org/drawingml/2006/main">
               <a:ext uri="{FF2B5EF4-FFF2-40B4-BE49-F238E27FC236}">
-                <a16:creationId xmlns:a16="http://schemas.microsoft.com/office/drawing/2014/main" id="{CE4FDE2C-E4C6-4DC0-88C3-B7338BEC34B7}"/>
+                <a16:creationId xmlns:a16="http://schemas.microsoft.com/office/drawing/2014/main" id="{9373C65E-9801-4C57-8B5C-968F1561C1C3}"/>
               </a:ext>
             </a:extLst>
           </p:cNvPr>
@@ -10502,7 +10502,7 @@
           <p:cNvPr id="27" name="">
             <a:extLst xmlns:a="http://schemas.openxmlformats.org/drawingml/2006/main">
               <a:ext uri="{FF2B5EF4-FFF2-40B4-BE49-F238E27FC236}">
-                <a16:creationId xmlns:a16="http://schemas.microsoft.com/office/drawing/2014/main" id="{FAF2C45C-53F2-4394-87A3-41D79968591A}"/>
+                <a16:creationId xmlns:a16="http://schemas.microsoft.com/office/drawing/2014/main" id="{30E393B7-04D2-41F6-B9E7-FD2FE5AEEF46}"/>
               </a:ext>
             </a:extLst>
           </p:cNvPr>
@@ -10533,7 +10533,7 @@
           <p:cNvPr id="28" name="">
             <a:extLst xmlns:a="http://schemas.openxmlformats.org/drawingml/2006/main">
               <a:ext uri="{FF2B5EF4-FFF2-40B4-BE49-F238E27FC236}">
-                <a16:creationId xmlns:a16="http://schemas.microsoft.com/office/drawing/2014/main" id="{D2852B9F-9CD5-48C1-BCDC-94879127BE2A}"/>
+                <a16:creationId xmlns:a16="http://schemas.microsoft.com/office/drawing/2014/main" id="{879BBBCA-1199-4A7F-A8F4-F2C01E43B455}"/>
               </a:ext>
             </a:extLst>
           </p:cNvPr>
@@ -10564,7 +10564,7 @@
           <p:cNvPr id="29" name="">
             <a:extLst xmlns:a="http://schemas.openxmlformats.org/drawingml/2006/main">
               <a:ext uri="{FF2B5EF4-FFF2-40B4-BE49-F238E27FC236}">
-                <a16:creationId xmlns:a16="http://schemas.microsoft.com/office/drawing/2014/main" id="{D146E5C6-B837-4988-A98A-23551B73480C}"/>
+                <a16:creationId xmlns:a16="http://schemas.microsoft.com/office/drawing/2014/main" id="{E9B59AFD-EDE4-4F6E-95C7-4DE5F2700385}"/>
               </a:ext>
             </a:extLst>
           </p:cNvPr>
@@ -10595,7 +10595,7 @@
           <p:cNvPr id="30" name="">
             <a:extLst xmlns:a="http://schemas.openxmlformats.org/drawingml/2006/main">
               <a:ext uri="{FF2B5EF4-FFF2-40B4-BE49-F238E27FC236}">
-                <a16:creationId xmlns:a16="http://schemas.microsoft.com/office/drawing/2014/main" id="{B800DE5C-1E91-43DD-914E-8395C90CBE5D}"/>
+                <a16:creationId xmlns:a16="http://schemas.microsoft.com/office/drawing/2014/main" id="{488E9F04-2824-42EF-991E-1BFC696F642B}"/>
               </a:ext>
             </a:extLst>
           </p:cNvPr>
@@ -10626,7 +10626,7 @@
           <p:cNvPr id="31" name="">
             <a:extLst xmlns:a="http://schemas.openxmlformats.org/drawingml/2006/main">
               <a:ext uri="{FF2B5EF4-FFF2-40B4-BE49-F238E27FC236}">
-                <a16:creationId xmlns:a16="http://schemas.microsoft.com/office/drawing/2014/main" id="{1ED84EF0-33DB-4BA0-82AD-32DDCBD054E6}"/>
+                <a16:creationId xmlns:a16="http://schemas.microsoft.com/office/drawing/2014/main" id="{7F4277E2-4896-4EE7-9847-92F501DB91C0}"/>
               </a:ext>
             </a:extLst>
           </p:cNvPr>
@@ -10657,7 +10657,7 @@
           <p:cNvPr id="32" name="">
             <a:extLst xmlns:a="http://schemas.openxmlformats.org/drawingml/2006/main">
               <a:ext uri="{FF2B5EF4-FFF2-40B4-BE49-F238E27FC236}">
-                <a16:creationId xmlns:a16="http://schemas.microsoft.com/office/drawing/2014/main" id="{CF7DBAEA-108F-4BC3-9C53-253A2743561F}"/>
+                <a16:creationId xmlns:a16="http://schemas.microsoft.com/office/drawing/2014/main" id="{86FDD446-42ED-406A-A974-ADBC3EBA3B2F}"/>
               </a:ext>
             </a:extLst>
           </p:cNvPr>
@@ -10688,7 +10688,7 @@
           <p:cNvPr id="33" name="">
             <a:extLst xmlns:a="http://schemas.openxmlformats.org/drawingml/2006/main">
               <a:ext uri="{FF2B5EF4-FFF2-40B4-BE49-F238E27FC236}">
-                <a16:creationId xmlns:a16="http://schemas.microsoft.com/office/drawing/2014/main" id="{057343E9-39AE-40DA-BF16-892BCAE3A988}"/>
+                <a16:creationId xmlns:a16="http://schemas.microsoft.com/office/drawing/2014/main" id="{D71D992B-A667-4B20-8A9A-284271534D14}"/>
               </a:ext>
             </a:extLst>
           </p:cNvPr>
@@ -10719,7 +10719,7 @@
           <p:cNvPr id="34" name="">
             <a:extLst xmlns:a="http://schemas.openxmlformats.org/drawingml/2006/main">
               <a:ext uri="{FF2B5EF4-FFF2-40B4-BE49-F238E27FC236}">
-                <a16:creationId xmlns:a16="http://schemas.microsoft.com/office/drawing/2014/main" id="{1BA2F38B-C12C-47B6-B042-E8951765C3CC}"/>
+                <a16:creationId xmlns:a16="http://schemas.microsoft.com/office/drawing/2014/main" id="{B636F393-AC91-4025-B9A1-C20A230F7755}"/>
               </a:ext>
             </a:extLst>
           </p:cNvPr>
@@ -10752,7 +10752,7 @@
           <p:cNvPr id="35" name="">
             <a:extLst xmlns:a="http://schemas.openxmlformats.org/drawingml/2006/main">
               <a:ext uri="{FF2B5EF4-FFF2-40B4-BE49-F238E27FC236}">
-                <a16:creationId xmlns:a16="http://schemas.microsoft.com/office/drawing/2014/main" id="{89D94351-9D24-4116-B659-A6AC4A656605}"/>
+                <a16:creationId xmlns:a16="http://schemas.microsoft.com/office/drawing/2014/main" id="{39233BF6-9BE9-4D4E-8F97-ED3643FDACFA}"/>
               </a:ext>
             </a:extLst>
           </p:cNvPr>
@@ -10814,7 +10814,7 @@
           <p:cNvPr id="36" name="">
             <a:extLst xmlns:a="http://schemas.openxmlformats.org/drawingml/2006/main">
               <a:ext uri="{FF2B5EF4-FFF2-40B4-BE49-F238E27FC236}">
-                <a16:creationId xmlns:a16="http://schemas.microsoft.com/office/drawing/2014/main" id="{1C24B9B1-D9B2-4820-B9DE-8847DE324725}"/>
+                <a16:creationId xmlns:a16="http://schemas.microsoft.com/office/drawing/2014/main" id="{5BE14107-0F0F-4202-848F-7AECF1249134}"/>
               </a:ext>
             </a:extLst>
           </p:cNvPr>
@@ -10876,7 +10876,7 @@
           <p:cNvPr id="37" name="">
             <a:extLst xmlns:a="http://schemas.openxmlformats.org/drawingml/2006/main">
               <a:ext uri="{FF2B5EF4-FFF2-40B4-BE49-F238E27FC236}">
-                <a16:creationId xmlns:a16="http://schemas.microsoft.com/office/drawing/2014/main" id="{08323F8D-C918-44B5-AD98-757157102BF3}"/>
+                <a16:creationId xmlns:a16="http://schemas.microsoft.com/office/drawing/2014/main" id="{9ED59279-2D10-4B49-BFEA-646516B3EA69}"/>
               </a:ext>
             </a:extLst>
           </p:cNvPr>
@@ -10938,7 +10938,7 @@
           <p:cNvPr id="38" name="">
             <a:extLst xmlns:a="http://schemas.openxmlformats.org/drawingml/2006/main">
               <a:ext uri="{FF2B5EF4-FFF2-40B4-BE49-F238E27FC236}">
-                <a16:creationId xmlns:a16="http://schemas.microsoft.com/office/drawing/2014/main" id="{BEC35A4F-0B85-4C20-A8D3-C3D0D9E53A26}"/>
+                <a16:creationId xmlns:a16="http://schemas.microsoft.com/office/drawing/2014/main" id="{8595158E-1552-42CE-83E9-C01699BAE852}"/>
               </a:ext>
             </a:extLst>
           </p:cNvPr>
@@ -11000,7 +11000,7 @@
           <p:cNvPr id="39" name="">
             <a:extLst xmlns:a="http://schemas.openxmlformats.org/drawingml/2006/main">
               <a:ext uri="{FF2B5EF4-FFF2-40B4-BE49-F238E27FC236}">
-                <a16:creationId xmlns:a16="http://schemas.microsoft.com/office/drawing/2014/main" id="{C0A85ECD-0AC2-4055-BF9E-17B0A3F74DE3}"/>
+                <a16:creationId xmlns:a16="http://schemas.microsoft.com/office/drawing/2014/main" id="{639FC611-A4A2-4EE6-A091-9A077C874CE0}"/>
               </a:ext>
             </a:extLst>
           </p:cNvPr>
@@ -11031,7 +11031,7 @@
           <p:cNvPr id="40" name="">
             <a:extLst xmlns:a="http://schemas.openxmlformats.org/drawingml/2006/main">
               <a:ext uri="{FF2B5EF4-FFF2-40B4-BE49-F238E27FC236}">
-                <a16:creationId xmlns:a16="http://schemas.microsoft.com/office/drawing/2014/main" id="{1023513E-817A-4F46-BC32-F03840BDC908}"/>
+                <a16:creationId xmlns:a16="http://schemas.microsoft.com/office/drawing/2014/main" id="{E9FD1712-90A9-4C1C-9C3F-226B7946B96D}"/>
               </a:ext>
             </a:extLst>
           </p:cNvPr>
@@ -11062,7 +11062,7 @@
           <p:cNvPr id="41" name="">
             <a:extLst xmlns:a="http://schemas.openxmlformats.org/drawingml/2006/main">
               <a:ext uri="{FF2B5EF4-FFF2-40B4-BE49-F238E27FC236}">
-                <a16:creationId xmlns:a16="http://schemas.microsoft.com/office/drawing/2014/main" id="{2AFE5C7D-5A61-4C84-A848-DDF31F1445FA}"/>
+                <a16:creationId xmlns:a16="http://schemas.microsoft.com/office/drawing/2014/main" id="{4FF507C2-5102-4925-BD45-5FBE59A129DD}"/>
               </a:ext>
             </a:extLst>
           </p:cNvPr>
@@ -11124,7 +11124,7 @@
           <p:cNvPr id="42" name="">
             <a:extLst xmlns:a="http://schemas.openxmlformats.org/drawingml/2006/main">
               <a:ext uri="{FF2B5EF4-FFF2-40B4-BE49-F238E27FC236}">
-                <a16:creationId xmlns:a16="http://schemas.microsoft.com/office/drawing/2014/main" id="{BA91FA2B-64F4-4C6C-BE39-C5AC18E568C6}"/>
+                <a16:creationId xmlns:a16="http://schemas.microsoft.com/office/drawing/2014/main" id="{CE0061D4-2E8E-4075-9C64-165CC873DCA8}"/>
               </a:ext>
             </a:extLst>
           </p:cNvPr>
@@ -11155,7 +11155,7 @@
           <p:cNvPr id="43" name="">
             <a:extLst xmlns:a="http://schemas.openxmlformats.org/drawingml/2006/main">
               <a:ext uri="{FF2B5EF4-FFF2-40B4-BE49-F238E27FC236}">
-                <a16:creationId xmlns:a16="http://schemas.microsoft.com/office/drawing/2014/main" id="{1DAA5BE5-1998-41C1-B613-5E4C6D19A845}"/>
+                <a16:creationId xmlns:a16="http://schemas.microsoft.com/office/drawing/2014/main" id="{B57CB46E-B691-477D-810C-19BB96067CC2}"/>
               </a:ext>
             </a:extLst>
           </p:cNvPr>
@@ -11217,7 +11217,7 @@
           <p:cNvPr id="44" name="">
             <a:extLst xmlns:a="http://schemas.openxmlformats.org/drawingml/2006/main">
               <a:ext uri="{FF2B5EF4-FFF2-40B4-BE49-F238E27FC236}">
-                <a16:creationId xmlns:a16="http://schemas.microsoft.com/office/drawing/2014/main" id="{BAC5CC0D-AAD0-4CC0-B836-2229E2A591F4}"/>
+                <a16:creationId xmlns:a16="http://schemas.microsoft.com/office/drawing/2014/main" id="{39AF3F02-60EE-48F1-93A6-8E4FBA33AFAD}"/>
               </a:ext>
             </a:extLst>
           </p:cNvPr>
@@ -11360,7 +11360,7 @@
           <p:cNvPr id="45" name="">
             <a:extLst xmlns:a="http://schemas.openxmlformats.org/drawingml/2006/main">
               <a:ext uri="{FF2B5EF4-FFF2-40B4-BE49-F238E27FC236}">
-                <a16:creationId xmlns:a16="http://schemas.microsoft.com/office/drawing/2014/main" id="{DAC2239C-9E5D-435A-BE6E-C32FCA6CA0EE}"/>
+                <a16:creationId xmlns:a16="http://schemas.microsoft.com/office/drawing/2014/main" id="{9D390C7F-8312-411A-B7AA-52665A0F5BCD}"/>
               </a:ext>
             </a:extLst>
           </p:cNvPr>
@@ -11422,7 +11422,7 @@
           <p:cNvPr id="46" name="">
             <a:extLst xmlns:a="http://schemas.openxmlformats.org/drawingml/2006/main">
               <a:ext uri="{FF2B5EF4-FFF2-40B4-BE49-F238E27FC236}">
-                <a16:creationId xmlns:a16="http://schemas.microsoft.com/office/drawing/2014/main" id="{0D284AB0-B28E-4F41-805D-D02B52F28E95}"/>
+                <a16:creationId xmlns:a16="http://schemas.microsoft.com/office/drawing/2014/main" id="{9B8E8DD3-EE28-41E0-8696-F8AC9D7D7859}"/>
               </a:ext>
             </a:extLst>
           </p:cNvPr>
@@ -11565,7 +11565,7 @@
           <p:cNvPr id="47" name="">
             <a:extLst xmlns:a="http://schemas.openxmlformats.org/drawingml/2006/main">
               <a:ext uri="{FF2B5EF4-FFF2-40B4-BE49-F238E27FC236}">
-                <a16:creationId xmlns:a16="http://schemas.microsoft.com/office/drawing/2014/main" id="{64108FB8-48D2-4888-B649-4264D66F014D}"/>
+                <a16:creationId xmlns:a16="http://schemas.microsoft.com/office/drawing/2014/main" id="{C4756484-D2CA-45B5-BDAB-E60583889419}"/>
               </a:ext>
             </a:extLst>
           </p:cNvPr>
@@ -11627,7 +11627,7 @@
           <p:cNvPr id="48" name="">
             <a:extLst xmlns:a="http://schemas.openxmlformats.org/drawingml/2006/main">
               <a:ext uri="{FF2B5EF4-FFF2-40B4-BE49-F238E27FC236}">
-                <a16:creationId xmlns:a16="http://schemas.microsoft.com/office/drawing/2014/main" id="{616FC37D-AF95-4B9C-A9A0-73310A1B53C4}"/>
+                <a16:creationId xmlns:a16="http://schemas.microsoft.com/office/drawing/2014/main" id="{4A311B84-F41A-44E8-B85A-071C692E51D3}"/>
               </a:ext>
             </a:extLst>
           </p:cNvPr>
@@ -11687,7 +11687,7 @@
     </p:spTree>
     <p:extLst>
       <p:ext uri="{BB962C8B-B14F-4D97-AF65-F5344CB8AC3E}">
-        <p14:creationId xmlns:p14="http://schemas.microsoft.com/office/powerpoint/2010/main" val="1629076765"/>
+        <p14:creationId xmlns:p14="http://schemas.microsoft.com/office/powerpoint/2010/main" val="2091354500"/>
       </p:ext>
     </p:extLst>
   </p:cSld>
@@ -11718,7 +11718,7 @@
           <p:cNvPr id="67" name="">
             <a:extLst xmlns:a="http://schemas.openxmlformats.org/drawingml/2006/main">
               <a:ext uri="{FF2B5EF4-FFF2-40B4-BE49-F238E27FC236}">
-                <a16:creationId xmlns:a16="http://schemas.microsoft.com/office/drawing/2014/main" id="{9BFF2D92-4B9D-498D-AED3-FA75949DB7D3}"/>
+                <a16:creationId xmlns:a16="http://schemas.microsoft.com/office/drawing/2014/main" id="{E1A4F390-E4C6-4D18-BF33-73C3E7D9CE44}"/>
               </a:ext>
             </a:extLst>
           </p:cNvPr>
@@ -11749,7 +11749,7 @@
           <p:cNvPr id="2" name="">
             <a:extLst xmlns:a="http://schemas.openxmlformats.org/drawingml/2006/main">
               <a:ext uri="{FF2B5EF4-FFF2-40B4-BE49-F238E27FC236}">
-                <a16:creationId xmlns:a16="http://schemas.microsoft.com/office/drawing/2014/main" id="{AA51B1F5-D063-4A9E-81E2-A609490B537D}"/>
+                <a16:creationId xmlns:a16="http://schemas.microsoft.com/office/drawing/2014/main" id="{B4D952B0-1B9E-4481-A95B-468B9FDFF88A}"/>
               </a:ext>
             </a:extLst>
           </p:cNvPr>
@@ -11780,7 +11780,7 @@
           <p:cNvPr id="3" name="">
             <a:extLst xmlns:a="http://schemas.openxmlformats.org/drawingml/2006/main">
               <a:ext uri="{FF2B5EF4-FFF2-40B4-BE49-F238E27FC236}">
-                <a16:creationId xmlns:a16="http://schemas.microsoft.com/office/drawing/2014/main" id="{EA63DB02-CDF3-45FF-A14D-424AF0DDE905}"/>
+                <a16:creationId xmlns:a16="http://schemas.microsoft.com/office/drawing/2014/main" id="{60098BFC-D5FE-4C5D-BB78-FC8788E4F5AE}"/>
               </a:ext>
             </a:extLst>
           </p:cNvPr>
@@ -11811,7 +11811,7 @@
           <p:cNvPr id="4" name="">
             <a:extLst xmlns:a="http://schemas.openxmlformats.org/drawingml/2006/main">
               <a:ext uri="{FF2B5EF4-FFF2-40B4-BE49-F238E27FC236}">
-                <a16:creationId xmlns:a16="http://schemas.microsoft.com/office/drawing/2014/main" id="{E11B7A86-C92B-47F7-811F-90031285E752}"/>
+                <a16:creationId xmlns:a16="http://schemas.microsoft.com/office/drawing/2014/main" id="{54E5C559-4E6D-41B8-9DD8-19E2B8875D01}"/>
               </a:ext>
             </a:extLst>
           </p:cNvPr>
@@ -11842,7 +11842,7 @@
           <p:cNvPr id="5" name="">
             <a:extLst xmlns:a="http://schemas.openxmlformats.org/drawingml/2006/main">
               <a:ext uri="{FF2B5EF4-FFF2-40B4-BE49-F238E27FC236}">
-                <a16:creationId xmlns:a16="http://schemas.microsoft.com/office/drawing/2014/main" id="{F48666D4-458C-4FEE-BAEC-708AFA20122D}"/>
+                <a16:creationId xmlns:a16="http://schemas.microsoft.com/office/drawing/2014/main" id="{F6C71E3B-03C6-4187-865D-DC81A8863C2F}"/>
               </a:ext>
             </a:extLst>
           </p:cNvPr>
@@ -11873,7 +11873,7 @@
           <p:cNvPr id="6" name="">
             <a:extLst xmlns:a="http://schemas.openxmlformats.org/drawingml/2006/main">
               <a:ext uri="{FF2B5EF4-FFF2-40B4-BE49-F238E27FC236}">
-                <a16:creationId xmlns:a16="http://schemas.microsoft.com/office/drawing/2014/main" id="{B7A02A7F-6928-4D93-91E6-02E3FE3FAD89}"/>
+                <a16:creationId xmlns:a16="http://schemas.microsoft.com/office/drawing/2014/main" id="{005159C0-9FA7-4662-9E50-EE094A5B7B75}"/>
               </a:ext>
             </a:extLst>
           </p:cNvPr>
@@ -11904,7 +11904,7 @@
           <p:cNvPr id="7" name="">
             <a:extLst xmlns:a="http://schemas.openxmlformats.org/drawingml/2006/main">
               <a:ext uri="{FF2B5EF4-FFF2-40B4-BE49-F238E27FC236}">
-                <a16:creationId xmlns:a16="http://schemas.microsoft.com/office/drawing/2014/main" id="{D1D2BFE5-5DC4-421F-B87E-1356B0C5CABC}"/>
+                <a16:creationId xmlns:a16="http://schemas.microsoft.com/office/drawing/2014/main" id="{08E2602A-2619-4C1C-A0DE-8DD610E57DC0}"/>
               </a:ext>
             </a:extLst>
           </p:cNvPr>
@@ -11935,7 +11935,7 @@
           <p:cNvPr id="8" name="">
             <a:extLst xmlns:a="http://schemas.openxmlformats.org/drawingml/2006/main">
               <a:ext uri="{FF2B5EF4-FFF2-40B4-BE49-F238E27FC236}">
-                <a16:creationId xmlns:a16="http://schemas.microsoft.com/office/drawing/2014/main" id="{4154778D-DE02-46E5-A72B-DB54C641C1D3}"/>
+                <a16:creationId xmlns:a16="http://schemas.microsoft.com/office/drawing/2014/main" id="{2027AD51-F270-4673-9E04-88EAD809C0C4}"/>
               </a:ext>
             </a:extLst>
           </p:cNvPr>
@@ -11966,7 +11966,7 @@
           <p:cNvPr id="9" name="">
             <a:extLst xmlns:a="http://schemas.openxmlformats.org/drawingml/2006/main">
               <a:ext uri="{FF2B5EF4-FFF2-40B4-BE49-F238E27FC236}">
-                <a16:creationId xmlns:a16="http://schemas.microsoft.com/office/drawing/2014/main" id="{3B0B9F32-09ED-47C8-A36B-A26AC5C6E77F}"/>
+                <a16:creationId xmlns:a16="http://schemas.microsoft.com/office/drawing/2014/main" id="{5B429842-B04B-4ACF-8673-9B676B86939F}"/>
               </a:ext>
             </a:extLst>
           </p:cNvPr>
@@ -11997,7 +11997,7 @@
           <p:cNvPr id="10" name="">
             <a:extLst xmlns:a="http://schemas.openxmlformats.org/drawingml/2006/main">
               <a:ext uri="{FF2B5EF4-FFF2-40B4-BE49-F238E27FC236}">
-                <a16:creationId xmlns:a16="http://schemas.microsoft.com/office/drawing/2014/main" id="{93DB55BB-D97C-4D4B-B531-D596B667AD16}"/>
+                <a16:creationId xmlns:a16="http://schemas.microsoft.com/office/drawing/2014/main" id="{A0876D88-2FA7-406D-9256-04447FE30EB2}"/>
               </a:ext>
             </a:extLst>
           </p:cNvPr>
@@ -12028,7 +12028,7 @@
           <p:cNvPr id="11" name="">
             <a:extLst xmlns:a="http://schemas.openxmlformats.org/drawingml/2006/main">
               <a:ext uri="{FF2B5EF4-FFF2-40B4-BE49-F238E27FC236}">
-                <a16:creationId xmlns:a16="http://schemas.microsoft.com/office/drawing/2014/main" id="{8A54F5CA-34FE-4A06-8664-A0F0812064AB}"/>
+                <a16:creationId xmlns:a16="http://schemas.microsoft.com/office/drawing/2014/main" id="{51431563-D72B-4A80-AF17-DCD319BB5490}"/>
               </a:ext>
             </a:extLst>
           </p:cNvPr>
@@ -12059,7 +12059,7 @@
           <p:cNvPr id="12" name="">
             <a:extLst xmlns:a="http://schemas.openxmlformats.org/drawingml/2006/main">
               <a:ext uri="{FF2B5EF4-FFF2-40B4-BE49-F238E27FC236}">
-                <a16:creationId xmlns:a16="http://schemas.microsoft.com/office/drawing/2014/main" id="{DD6289FB-0E3C-4156-9710-10438B3725D2}"/>
+                <a16:creationId xmlns:a16="http://schemas.microsoft.com/office/drawing/2014/main" id="{07A0E653-04F3-4B26-8DC0-628940CBDA0E}"/>
               </a:ext>
             </a:extLst>
           </p:cNvPr>
@@ -12090,7 +12090,7 @@
           <p:cNvPr id="13" name="">
             <a:extLst xmlns:a="http://schemas.openxmlformats.org/drawingml/2006/main">
               <a:ext uri="{FF2B5EF4-FFF2-40B4-BE49-F238E27FC236}">
-                <a16:creationId xmlns:a16="http://schemas.microsoft.com/office/drawing/2014/main" id="{03BC4F76-BCD8-43C8-9C5A-DA70A9DE59FD}"/>
+                <a16:creationId xmlns:a16="http://schemas.microsoft.com/office/drawing/2014/main" id="{29DC248E-C0B1-451E-929F-AA2BD90A7BCC}"/>
               </a:ext>
             </a:extLst>
           </p:cNvPr>
@@ -12121,7 +12121,7 @@
           <p:cNvPr id="14" name="">
             <a:extLst xmlns:a="http://schemas.openxmlformats.org/drawingml/2006/main">
               <a:ext uri="{FF2B5EF4-FFF2-40B4-BE49-F238E27FC236}">
-                <a16:creationId xmlns:a16="http://schemas.microsoft.com/office/drawing/2014/main" id="{88DD9967-4F86-4038-BF72-3B2571B3FB85}"/>
+                <a16:creationId xmlns:a16="http://schemas.microsoft.com/office/drawing/2014/main" id="{B594D4C5-D465-4D25-9643-836FE35233A1}"/>
               </a:ext>
             </a:extLst>
           </p:cNvPr>
@@ -12152,7 +12152,7 @@
           <p:cNvPr id="15" name="">
             <a:extLst xmlns:a="http://schemas.openxmlformats.org/drawingml/2006/main">
               <a:ext uri="{FF2B5EF4-FFF2-40B4-BE49-F238E27FC236}">
-                <a16:creationId xmlns:a16="http://schemas.microsoft.com/office/drawing/2014/main" id="{E413B9FC-2188-4755-9363-F7F10E1508F9}"/>
+                <a16:creationId xmlns:a16="http://schemas.microsoft.com/office/drawing/2014/main" id="{A8322425-D182-4EBB-80AF-FED8BE8635E4}"/>
               </a:ext>
             </a:extLst>
           </p:cNvPr>
@@ -12183,7 +12183,7 @@
           <p:cNvPr id="16" name="">
             <a:extLst xmlns:a="http://schemas.openxmlformats.org/drawingml/2006/main">
               <a:ext uri="{FF2B5EF4-FFF2-40B4-BE49-F238E27FC236}">
-                <a16:creationId xmlns:a16="http://schemas.microsoft.com/office/drawing/2014/main" id="{346E0AC4-22A2-4AAE-AE54-B4F035D8F2FA}"/>
+                <a16:creationId xmlns:a16="http://schemas.microsoft.com/office/drawing/2014/main" id="{DBE9603F-3587-407E-A978-788E36DFABA2}"/>
               </a:ext>
             </a:extLst>
           </p:cNvPr>
@@ -12214,7 +12214,7 @@
           <p:cNvPr id="17" name="">
             <a:extLst xmlns:a="http://schemas.openxmlformats.org/drawingml/2006/main">
               <a:ext uri="{FF2B5EF4-FFF2-40B4-BE49-F238E27FC236}">
-                <a16:creationId xmlns:a16="http://schemas.microsoft.com/office/drawing/2014/main" id="{D557B66D-02CC-4AC7-B917-E53C5DB33F14}"/>
+                <a16:creationId xmlns:a16="http://schemas.microsoft.com/office/drawing/2014/main" id="{2B187ADE-795D-48EB-8849-204CE860AC2D}"/>
               </a:ext>
             </a:extLst>
           </p:cNvPr>
@@ -12245,7 +12245,7 @@
           <p:cNvPr id="18" name="">
             <a:extLst xmlns:a="http://schemas.openxmlformats.org/drawingml/2006/main">
               <a:ext uri="{FF2B5EF4-FFF2-40B4-BE49-F238E27FC236}">
-                <a16:creationId xmlns:a16="http://schemas.microsoft.com/office/drawing/2014/main" id="{905427E6-0E04-4297-BFCF-47706F0FEA6F}"/>
+                <a16:creationId xmlns:a16="http://schemas.microsoft.com/office/drawing/2014/main" id="{68B7E725-3B01-43CF-9798-CED86698B8AF}"/>
               </a:ext>
             </a:extLst>
           </p:cNvPr>
@@ -12276,7 +12276,7 @@
           <p:cNvPr id="19" name="">
             <a:extLst xmlns:a="http://schemas.openxmlformats.org/drawingml/2006/main">
               <a:ext uri="{FF2B5EF4-FFF2-40B4-BE49-F238E27FC236}">
-                <a16:creationId xmlns:a16="http://schemas.microsoft.com/office/drawing/2014/main" id="{F6DBF3CA-9756-4BD8-AC04-C48E578C1A71}"/>
+                <a16:creationId xmlns:a16="http://schemas.microsoft.com/office/drawing/2014/main" id="{E25C4820-26E9-476F-B1F3-7D52E670B93D}"/>
               </a:ext>
             </a:extLst>
           </p:cNvPr>
@@ -12307,7 +12307,7 @@
           <p:cNvPr id="20" name="">
             <a:extLst xmlns:a="http://schemas.openxmlformats.org/drawingml/2006/main">
               <a:ext uri="{FF2B5EF4-FFF2-40B4-BE49-F238E27FC236}">
-                <a16:creationId xmlns:a16="http://schemas.microsoft.com/office/drawing/2014/main" id="{148C9807-C193-4C0B-9D37-CAE82DA77930}"/>
+                <a16:creationId xmlns:a16="http://schemas.microsoft.com/office/drawing/2014/main" id="{812B3892-B896-455B-82FC-B59449B51BF2}"/>
               </a:ext>
             </a:extLst>
           </p:cNvPr>
@@ -12338,7 +12338,7 @@
           <p:cNvPr id="21" name="">
             <a:extLst xmlns:a="http://schemas.openxmlformats.org/drawingml/2006/main">
               <a:ext uri="{FF2B5EF4-FFF2-40B4-BE49-F238E27FC236}">
-                <a16:creationId xmlns:a16="http://schemas.microsoft.com/office/drawing/2014/main" id="{8B82D2DC-AFFB-44EE-AD0F-95DF1002ED49}"/>
+                <a16:creationId xmlns:a16="http://schemas.microsoft.com/office/drawing/2014/main" id="{470CED2E-254E-4947-99C9-BC59A5584DC6}"/>
               </a:ext>
             </a:extLst>
           </p:cNvPr>
@@ -12369,7 +12369,7 @@
           <p:cNvPr id="22" name="">
             <a:extLst xmlns:a="http://schemas.openxmlformats.org/drawingml/2006/main">
               <a:ext uri="{FF2B5EF4-FFF2-40B4-BE49-F238E27FC236}">
-                <a16:creationId xmlns:a16="http://schemas.microsoft.com/office/drawing/2014/main" id="{A231CCD7-E796-49D6-99F6-90DC608893F3}"/>
+                <a16:creationId xmlns:a16="http://schemas.microsoft.com/office/drawing/2014/main" id="{24D096B1-8774-4831-8754-4A267721065A}"/>
               </a:ext>
             </a:extLst>
           </p:cNvPr>
@@ -12400,7 +12400,7 @@
           <p:cNvPr id="23" name="">
             <a:extLst xmlns:a="http://schemas.openxmlformats.org/drawingml/2006/main">
               <a:ext uri="{FF2B5EF4-FFF2-40B4-BE49-F238E27FC236}">
-                <a16:creationId xmlns:a16="http://schemas.microsoft.com/office/drawing/2014/main" id="{7049FDF4-6CE9-419B-892F-15A72FBF3C97}"/>
+                <a16:creationId xmlns:a16="http://schemas.microsoft.com/office/drawing/2014/main" id="{682CD68F-B42B-4B07-960A-5A1C6994CB2D}"/>
               </a:ext>
             </a:extLst>
           </p:cNvPr>
@@ -12431,7 +12431,7 @@
           <p:cNvPr id="24" name="">
             <a:extLst xmlns:a="http://schemas.openxmlformats.org/drawingml/2006/main">
               <a:ext uri="{FF2B5EF4-FFF2-40B4-BE49-F238E27FC236}">
-                <a16:creationId xmlns:a16="http://schemas.microsoft.com/office/drawing/2014/main" id="{DEA99AB1-9868-4193-A153-3D312D77B73B}"/>
+                <a16:creationId xmlns:a16="http://schemas.microsoft.com/office/drawing/2014/main" id="{29711533-BF85-4C4B-9BA6-794DD2742D69}"/>
               </a:ext>
             </a:extLst>
           </p:cNvPr>
@@ -12462,7 +12462,7 @@
           <p:cNvPr id="25" name="">
             <a:extLst xmlns:a="http://schemas.openxmlformats.org/drawingml/2006/main">
               <a:ext uri="{FF2B5EF4-FFF2-40B4-BE49-F238E27FC236}">
-                <a16:creationId xmlns:a16="http://schemas.microsoft.com/office/drawing/2014/main" id="{D6E578B7-AEF1-466E-A5D1-E78E2DE014B7}"/>
+                <a16:creationId xmlns:a16="http://schemas.microsoft.com/office/drawing/2014/main" id="{DBE7E893-5003-43E7-9999-766C827449DA}"/>
               </a:ext>
             </a:extLst>
           </p:cNvPr>
@@ -12493,7 +12493,7 @@
           <p:cNvPr id="26" name="">
             <a:extLst xmlns:a="http://schemas.openxmlformats.org/drawingml/2006/main">
               <a:ext uri="{FF2B5EF4-FFF2-40B4-BE49-F238E27FC236}">
-                <a16:creationId xmlns:a16="http://schemas.microsoft.com/office/drawing/2014/main" id="{DEF9DDA6-6387-43DB-9BA9-E911AD0559CB}"/>
+                <a16:creationId xmlns:a16="http://schemas.microsoft.com/office/drawing/2014/main" id="{AD3EF9DE-DCC5-49D2-818F-232C455A3FB9}"/>
               </a:ext>
             </a:extLst>
           </p:cNvPr>
@@ -12524,7 +12524,7 @@
           <p:cNvPr id="27" name="">
             <a:extLst xmlns:a="http://schemas.openxmlformats.org/drawingml/2006/main">
               <a:ext uri="{FF2B5EF4-FFF2-40B4-BE49-F238E27FC236}">
-                <a16:creationId xmlns:a16="http://schemas.microsoft.com/office/drawing/2014/main" id="{7996168F-05DD-4AB2-B153-B6F872B428D0}"/>
+                <a16:creationId xmlns:a16="http://schemas.microsoft.com/office/drawing/2014/main" id="{CAA1B84C-F83C-4313-A6A2-D6DD1784AB26}"/>
               </a:ext>
             </a:extLst>
           </p:cNvPr>
@@ -12555,7 +12555,7 @@
           <p:cNvPr id="28" name="">
             <a:extLst xmlns:a="http://schemas.openxmlformats.org/drawingml/2006/main">
               <a:ext uri="{FF2B5EF4-FFF2-40B4-BE49-F238E27FC236}">
-                <a16:creationId xmlns:a16="http://schemas.microsoft.com/office/drawing/2014/main" id="{97DF5FB1-0F71-4919-876C-3EFA336E5D1E}"/>
+                <a16:creationId xmlns:a16="http://schemas.microsoft.com/office/drawing/2014/main" id="{38936479-446F-4D54-9E01-4FDA66DC644A}"/>
               </a:ext>
             </a:extLst>
           </p:cNvPr>
@@ -12586,7 +12586,7 @@
           <p:cNvPr id="29" name="">
             <a:extLst xmlns:a="http://schemas.openxmlformats.org/drawingml/2006/main">
               <a:ext uri="{FF2B5EF4-FFF2-40B4-BE49-F238E27FC236}">
-                <a16:creationId xmlns:a16="http://schemas.microsoft.com/office/drawing/2014/main" id="{4E1CCC32-74CE-4FDA-AB36-B6186D8A2D54}"/>
+                <a16:creationId xmlns:a16="http://schemas.microsoft.com/office/drawing/2014/main" id="{E82961E4-6055-4FD0-BADC-5D7CF36C0A2F}"/>
               </a:ext>
             </a:extLst>
           </p:cNvPr>
@@ -12617,7 +12617,7 @@
           <p:cNvPr id="30" name="">
             <a:extLst xmlns:a="http://schemas.openxmlformats.org/drawingml/2006/main">
               <a:ext uri="{FF2B5EF4-FFF2-40B4-BE49-F238E27FC236}">
-                <a16:creationId xmlns:a16="http://schemas.microsoft.com/office/drawing/2014/main" id="{57DD1F7F-728B-4D5F-A12A-FDFB2164AAFF}"/>
+                <a16:creationId xmlns:a16="http://schemas.microsoft.com/office/drawing/2014/main" id="{C752F1F2-336A-4E7D-AB66-5D602DBCB9E5}"/>
               </a:ext>
             </a:extLst>
           </p:cNvPr>
@@ -12648,7 +12648,7 @@
           <p:cNvPr id="31" name="">
             <a:extLst xmlns:a="http://schemas.openxmlformats.org/drawingml/2006/main">
               <a:ext uri="{FF2B5EF4-FFF2-40B4-BE49-F238E27FC236}">
-                <a16:creationId xmlns:a16="http://schemas.microsoft.com/office/drawing/2014/main" id="{EBA87EAE-B175-45E1-8CB8-77FBC6CE314D}"/>
+                <a16:creationId xmlns:a16="http://schemas.microsoft.com/office/drawing/2014/main" id="{FE5281CC-2AE1-4DC9-8B86-3E8BC0605E44}"/>
               </a:ext>
             </a:extLst>
           </p:cNvPr>
@@ -12679,7 +12679,7 @@
           <p:cNvPr id="32" name="">
             <a:extLst xmlns:a="http://schemas.openxmlformats.org/drawingml/2006/main">
               <a:ext uri="{FF2B5EF4-FFF2-40B4-BE49-F238E27FC236}">
-                <a16:creationId xmlns:a16="http://schemas.microsoft.com/office/drawing/2014/main" id="{FEE24DBD-830A-4239-A2FB-98C5AC9AB444}"/>
+                <a16:creationId xmlns:a16="http://schemas.microsoft.com/office/drawing/2014/main" id="{3290BA8F-6DE8-4F33-88F8-ACC6C9B38439}"/>
               </a:ext>
             </a:extLst>
           </p:cNvPr>
@@ -12710,7 +12710,7 @@
           <p:cNvPr id="33" name="">
             <a:extLst xmlns:a="http://schemas.openxmlformats.org/drawingml/2006/main">
               <a:ext uri="{FF2B5EF4-FFF2-40B4-BE49-F238E27FC236}">
-                <a16:creationId xmlns:a16="http://schemas.microsoft.com/office/drawing/2014/main" id="{96247FEE-1890-426C-BFF2-49592FA72AEE}"/>
+                <a16:creationId xmlns:a16="http://schemas.microsoft.com/office/drawing/2014/main" id="{E3EF0B39-7C9E-4310-BC20-24D76BE46533}"/>
               </a:ext>
             </a:extLst>
           </p:cNvPr>
@@ -12741,7 +12741,7 @@
           <p:cNvPr id="34" name="">
             <a:extLst xmlns:a="http://schemas.openxmlformats.org/drawingml/2006/main">
               <a:ext uri="{FF2B5EF4-FFF2-40B4-BE49-F238E27FC236}">
-                <a16:creationId xmlns:a16="http://schemas.microsoft.com/office/drawing/2014/main" id="{7B867EAD-E6AF-44CE-92A8-806963335FFD}"/>
+                <a16:creationId xmlns:a16="http://schemas.microsoft.com/office/drawing/2014/main" id="{54287B5D-A4AA-405F-B55D-2ED6AE9E60AD}"/>
               </a:ext>
             </a:extLst>
           </p:cNvPr>
@@ -12774,7 +12774,7 @@
           <p:cNvPr id="35" name="">
             <a:extLst xmlns:a="http://schemas.openxmlformats.org/drawingml/2006/main">
               <a:ext uri="{FF2B5EF4-FFF2-40B4-BE49-F238E27FC236}">
-                <a16:creationId xmlns:a16="http://schemas.microsoft.com/office/drawing/2014/main" id="{2D56C2BF-554D-4991-BCF5-147D77D866F4}"/>
+                <a16:creationId xmlns:a16="http://schemas.microsoft.com/office/drawing/2014/main" id="{5023604E-FE4B-41F4-AFCD-8100BFB774CC}"/>
               </a:ext>
             </a:extLst>
           </p:cNvPr>
@@ -12836,7 +12836,7 @@
           <p:cNvPr id="36" name="">
             <a:extLst xmlns:a="http://schemas.openxmlformats.org/drawingml/2006/main">
               <a:ext uri="{FF2B5EF4-FFF2-40B4-BE49-F238E27FC236}">
-                <a16:creationId xmlns:a16="http://schemas.microsoft.com/office/drawing/2014/main" id="{6D02E7C0-BB28-4980-8912-BFD830570000}"/>
+                <a16:creationId xmlns:a16="http://schemas.microsoft.com/office/drawing/2014/main" id="{6AC5C865-75CC-4291-B03A-F85076F8513D}"/>
               </a:ext>
             </a:extLst>
           </p:cNvPr>
@@ -12898,7 +12898,7 @@
           <p:cNvPr id="37" name="">
             <a:extLst xmlns:a="http://schemas.openxmlformats.org/drawingml/2006/main">
               <a:ext uri="{FF2B5EF4-FFF2-40B4-BE49-F238E27FC236}">
-                <a16:creationId xmlns:a16="http://schemas.microsoft.com/office/drawing/2014/main" id="{4234CF73-191B-4CCC-A325-82D3E194565F}"/>
+                <a16:creationId xmlns:a16="http://schemas.microsoft.com/office/drawing/2014/main" id="{8CB6BB59-8801-4DAB-BC53-F0C694464A8D}"/>
               </a:ext>
             </a:extLst>
           </p:cNvPr>
@@ -12960,7 +12960,7 @@
           <p:cNvPr id="38" name="">
             <a:extLst xmlns:a="http://schemas.openxmlformats.org/drawingml/2006/main">
               <a:ext uri="{FF2B5EF4-FFF2-40B4-BE49-F238E27FC236}">
-                <a16:creationId xmlns:a16="http://schemas.microsoft.com/office/drawing/2014/main" id="{A71ACB85-19F7-4229-832C-81419D98052E}"/>
+                <a16:creationId xmlns:a16="http://schemas.microsoft.com/office/drawing/2014/main" id="{CF3400D6-FFDB-40BF-9A6F-415F29E1CD6D}"/>
               </a:ext>
             </a:extLst>
           </p:cNvPr>
@@ -13022,7 +13022,7 @@
           <p:cNvPr id="39" name="">
             <a:extLst xmlns:a="http://schemas.openxmlformats.org/drawingml/2006/main">
               <a:ext uri="{FF2B5EF4-FFF2-40B4-BE49-F238E27FC236}">
-                <a16:creationId xmlns:a16="http://schemas.microsoft.com/office/drawing/2014/main" id="{CBF62E39-6EB1-4FEF-B7BD-4FB0600C9867}"/>
+                <a16:creationId xmlns:a16="http://schemas.microsoft.com/office/drawing/2014/main" id="{E7AAE18B-ABDC-4A0D-9A1E-2D9B999C331E}"/>
               </a:ext>
             </a:extLst>
           </p:cNvPr>
@@ -13053,7 +13053,7 @@
           <p:cNvPr id="40" name="">
             <a:extLst xmlns:a="http://schemas.openxmlformats.org/drawingml/2006/main">
               <a:ext uri="{FF2B5EF4-FFF2-40B4-BE49-F238E27FC236}">
-                <a16:creationId xmlns:a16="http://schemas.microsoft.com/office/drawing/2014/main" id="{716E079E-ED0E-4D59-A2D8-59E9E881F88C}"/>
+                <a16:creationId xmlns:a16="http://schemas.microsoft.com/office/drawing/2014/main" id="{711412EB-DFE0-4424-935E-7002CA5489A9}"/>
               </a:ext>
             </a:extLst>
           </p:cNvPr>
@@ -13084,7 +13084,7 @@
           <p:cNvPr id="41" name="">
             <a:extLst xmlns:a="http://schemas.openxmlformats.org/drawingml/2006/main">
               <a:ext uri="{FF2B5EF4-FFF2-40B4-BE49-F238E27FC236}">
-                <a16:creationId xmlns:a16="http://schemas.microsoft.com/office/drawing/2014/main" id="{0E8B3B5B-8D6C-4B1C-BC8A-E9380B9310FE}"/>
+                <a16:creationId xmlns:a16="http://schemas.microsoft.com/office/drawing/2014/main" id="{AFC94551-F771-48C9-BA2D-2ABF27BF1375}"/>
               </a:ext>
             </a:extLst>
           </p:cNvPr>
@@ -13146,7 +13146,7 @@
           <p:cNvPr id="42" name="">
             <a:extLst xmlns:a="http://schemas.openxmlformats.org/drawingml/2006/main">
               <a:ext uri="{FF2B5EF4-FFF2-40B4-BE49-F238E27FC236}">
-                <a16:creationId xmlns:a16="http://schemas.microsoft.com/office/drawing/2014/main" id="{AE60D627-D1B1-449A-8648-09D43192FF72}"/>
+                <a16:creationId xmlns:a16="http://schemas.microsoft.com/office/drawing/2014/main" id="{DC111F3B-173E-4831-9910-634666773BCF}"/>
               </a:ext>
             </a:extLst>
           </p:cNvPr>
@@ -13179,7 +13179,7 @@
           <p:cNvPr id="43" name="">
             <a:extLst xmlns:a="http://schemas.openxmlformats.org/drawingml/2006/main">
               <a:ext uri="{FF2B5EF4-FFF2-40B4-BE49-F238E27FC236}">
-                <a16:creationId xmlns:a16="http://schemas.microsoft.com/office/drawing/2014/main" id="{A9A07F73-843E-4C37-9A3A-5BE2C5491A44}"/>
+                <a16:creationId xmlns:a16="http://schemas.microsoft.com/office/drawing/2014/main" id="{C6F51959-0F18-4DE1-A1C9-DF16C65EB6BA}"/>
               </a:ext>
             </a:extLst>
           </p:cNvPr>
@@ -13241,7 +13241,7 @@
           <p:cNvPr id="44" name="">
             <a:extLst xmlns:a="http://schemas.openxmlformats.org/drawingml/2006/main">
               <a:ext uri="{FF2B5EF4-FFF2-40B4-BE49-F238E27FC236}">
-                <a16:creationId xmlns:a16="http://schemas.microsoft.com/office/drawing/2014/main" id="{863856B0-5FCE-4E3A-82E0-171F63CC5DEE}"/>
+                <a16:creationId xmlns:a16="http://schemas.microsoft.com/office/drawing/2014/main" id="{FFDBCF1C-A852-41C1-97AE-24F57C7F064A}"/>
               </a:ext>
             </a:extLst>
           </p:cNvPr>
@@ -13303,7 +13303,7 @@
           <p:cNvPr id="45" name="">
             <a:extLst xmlns:a="http://schemas.openxmlformats.org/drawingml/2006/main">
               <a:ext uri="{FF2B5EF4-FFF2-40B4-BE49-F238E27FC236}">
-                <a16:creationId xmlns:a16="http://schemas.microsoft.com/office/drawing/2014/main" id="{E1C288E5-B12A-43A1-8192-872BE2140539}"/>
+                <a16:creationId xmlns:a16="http://schemas.microsoft.com/office/drawing/2014/main" id="{D170B6E9-1CD5-4D42-825C-6AFEF87A0741}"/>
               </a:ext>
             </a:extLst>
           </p:cNvPr>
@@ -13338,7 +13338,7 @@
           <p:cNvPr id="46" name="">
             <a:extLst xmlns:a="http://schemas.openxmlformats.org/drawingml/2006/main">
               <a:ext uri="{FF2B5EF4-FFF2-40B4-BE49-F238E27FC236}">
-                <a16:creationId xmlns:a16="http://schemas.microsoft.com/office/drawing/2014/main" id="{7C683981-998C-4544-8746-4C4BC04C3543}"/>
+                <a16:creationId xmlns:a16="http://schemas.microsoft.com/office/drawing/2014/main" id="{6B00522A-C5EF-46F1-8710-D9C89EB8066A}"/>
               </a:ext>
             </a:extLst>
           </p:cNvPr>
@@ -13400,7 +13400,7 @@
           <p:cNvPr id="47" name="">
             <a:extLst xmlns:a="http://schemas.openxmlformats.org/drawingml/2006/main">
               <a:ext uri="{FF2B5EF4-FFF2-40B4-BE49-F238E27FC236}">
-                <a16:creationId xmlns:a16="http://schemas.microsoft.com/office/drawing/2014/main" id="{F1F2B120-0D84-431F-B044-11316DBEE544}"/>
+                <a16:creationId xmlns:a16="http://schemas.microsoft.com/office/drawing/2014/main" id="{B149F49E-83A7-452C-B3A7-E88DB6592C61}"/>
               </a:ext>
             </a:extLst>
           </p:cNvPr>
@@ -13462,7 +13462,7 @@
           <p:cNvPr id="48" name="">
             <a:extLst xmlns:a="http://schemas.openxmlformats.org/drawingml/2006/main">
               <a:ext uri="{FF2B5EF4-FFF2-40B4-BE49-F238E27FC236}">
-                <a16:creationId xmlns:a16="http://schemas.microsoft.com/office/drawing/2014/main" id="{75C5A554-643D-40A6-97FA-74B8B85E28F3}"/>
+                <a16:creationId xmlns:a16="http://schemas.microsoft.com/office/drawing/2014/main" id="{98B7A509-5373-404F-941B-F3AACD1F7922}"/>
               </a:ext>
             </a:extLst>
           </p:cNvPr>
@@ -13524,7 +13524,7 @@
           <p:cNvPr id="49" name="">
             <a:extLst xmlns:a="http://schemas.openxmlformats.org/drawingml/2006/main">
               <a:ext uri="{FF2B5EF4-FFF2-40B4-BE49-F238E27FC236}">
-                <a16:creationId xmlns:a16="http://schemas.microsoft.com/office/drawing/2014/main" id="{9981D508-F827-4249-B71B-15B7C493D745}"/>
+                <a16:creationId xmlns:a16="http://schemas.microsoft.com/office/drawing/2014/main" id="{90AD9DD7-5814-4334-9996-CEDD3CE930AA}"/>
               </a:ext>
             </a:extLst>
           </p:cNvPr>
@@ -13555,7 +13555,7 @@
           <p:cNvPr id="50" name="">
             <a:extLst xmlns:a="http://schemas.openxmlformats.org/drawingml/2006/main">
               <a:ext uri="{FF2B5EF4-FFF2-40B4-BE49-F238E27FC236}">
-                <a16:creationId xmlns:a16="http://schemas.microsoft.com/office/drawing/2014/main" id="{50957338-D2F5-432A-9847-1FDA025FD8D3}"/>
+                <a16:creationId xmlns:a16="http://schemas.microsoft.com/office/drawing/2014/main" id="{AB65C4F2-E6C7-4C80-9BCC-1E8274E62F7A}"/>
               </a:ext>
             </a:extLst>
           </p:cNvPr>
@@ -13590,7 +13590,7 @@
           <p:cNvPr id="51" name="">
             <a:extLst xmlns:a="http://schemas.openxmlformats.org/drawingml/2006/main">
               <a:ext uri="{FF2B5EF4-FFF2-40B4-BE49-F238E27FC236}">
-                <a16:creationId xmlns:a16="http://schemas.microsoft.com/office/drawing/2014/main" id="{7EC46EE8-CD48-4A8E-95D9-458F17B011C6}"/>
+                <a16:creationId xmlns:a16="http://schemas.microsoft.com/office/drawing/2014/main" id="{119D80F5-AF54-43D8-8E08-7AB4F5DC50FD}"/>
               </a:ext>
             </a:extLst>
           </p:cNvPr>
@@ -13652,7 +13652,7 @@
           <p:cNvPr id="52" name="">
             <a:extLst xmlns:a="http://schemas.openxmlformats.org/drawingml/2006/main">
               <a:ext uri="{FF2B5EF4-FFF2-40B4-BE49-F238E27FC236}">
-                <a16:creationId xmlns:a16="http://schemas.microsoft.com/office/drawing/2014/main" id="{02576216-3F70-44C6-8C15-0D5C9BF3C5E7}"/>
+                <a16:creationId xmlns:a16="http://schemas.microsoft.com/office/drawing/2014/main" id="{22277DB4-A6E4-4432-944B-07765507FCE7}"/>
               </a:ext>
             </a:extLst>
           </p:cNvPr>
@@ -13714,7 +13714,7 @@
           <p:cNvPr id="53" name="">
             <a:extLst xmlns:a="http://schemas.openxmlformats.org/drawingml/2006/main">
               <a:ext uri="{FF2B5EF4-FFF2-40B4-BE49-F238E27FC236}">
-                <a16:creationId xmlns:a16="http://schemas.microsoft.com/office/drawing/2014/main" id="{9E42BE57-F165-40A1-8560-B03C3AE4C79F}"/>
+                <a16:creationId xmlns:a16="http://schemas.microsoft.com/office/drawing/2014/main" id="{C9AD8C8C-B796-4587-A650-E70A18176095}"/>
               </a:ext>
             </a:extLst>
           </p:cNvPr>
@@ -13776,7 +13776,7 @@
           <p:cNvPr id="54" name="">
             <a:extLst xmlns:a="http://schemas.openxmlformats.org/drawingml/2006/main">
               <a:ext uri="{FF2B5EF4-FFF2-40B4-BE49-F238E27FC236}">
-                <a16:creationId xmlns:a16="http://schemas.microsoft.com/office/drawing/2014/main" id="{2A028517-D971-45A5-A824-99C624C18C8E}"/>
+                <a16:creationId xmlns:a16="http://schemas.microsoft.com/office/drawing/2014/main" id="{361A0481-75E3-45AA-8F74-607CEC7EBF44}"/>
               </a:ext>
             </a:extLst>
           </p:cNvPr>
@@ -13807,7 +13807,7 @@
           <p:cNvPr id="55" name="">
             <a:extLst xmlns:a="http://schemas.openxmlformats.org/drawingml/2006/main">
               <a:ext uri="{FF2B5EF4-FFF2-40B4-BE49-F238E27FC236}">
-                <a16:creationId xmlns:a16="http://schemas.microsoft.com/office/drawing/2014/main" id="{F85F1128-B67A-4C62-8218-69FCB0D69EDD}"/>
+                <a16:creationId xmlns:a16="http://schemas.microsoft.com/office/drawing/2014/main" id="{42CBDB91-A55B-4832-9FED-BCB693A02B45}"/>
               </a:ext>
             </a:extLst>
           </p:cNvPr>
@@ -13842,7 +13842,7 @@
           <p:cNvPr id="56" name="">
             <a:extLst xmlns:a="http://schemas.openxmlformats.org/drawingml/2006/main">
               <a:ext uri="{FF2B5EF4-FFF2-40B4-BE49-F238E27FC236}">
-                <a16:creationId xmlns:a16="http://schemas.microsoft.com/office/drawing/2014/main" id="{F5655991-A068-4182-8D49-8DAC63E9F516}"/>
+                <a16:creationId xmlns:a16="http://schemas.microsoft.com/office/drawing/2014/main" id="{187530C8-68A3-45EF-8241-F69C8E0C5BC9}"/>
               </a:ext>
             </a:extLst>
           </p:cNvPr>
@@ -13904,7 +13904,7 @@
           <p:cNvPr id="57" name="">
             <a:extLst xmlns:a="http://schemas.openxmlformats.org/drawingml/2006/main">
               <a:ext uri="{FF2B5EF4-FFF2-40B4-BE49-F238E27FC236}">
-                <a16:creationId xmlns:a16="http://schemas.microsoft.com/office/drawing/2014/main" id="{4921667E-974D-4B96-8FD7-336D4056CFA5}"/>
+                <a16:creationId xmlns:a16="http://schemas.microsoft.com/office/drawing/2014/main" id="{27DFBF7E-B7D8-4CDE-A116-487B62D5FFC7}"/>
               </a:ext>
             </a:extLst>
           </p:cNvPr>
@@ -13966,7 +13966,7 @@
           <p:cNvPr id="58" name="">
             <a:extLst xmlns:a="http://schemas.openxmlformats.org/drawingml/2006/main">
               <a:ext uri="{FF2B5EF4-FFF2-40B4-BE49-F238E27FC236}">
-                <a16:creationId xmlns:a16="http://schemas.microsoft.com/office/drawing/2014/main" id="{16FB81D2-F36E-4DC3-982C-BABB7A1E849F}"/>
+                <a16:creationId xmlns:a16="http://schemas.microsoft.com/office/drawing/2014/main" id="{2B9AE96D-489A-441A-A187-1DBDB8F4B4AC}"/>
               </a:ext>
             </a:extLst>
           </p:cNvPr>
@@ -14028,7 +14028,7 @@
           <p:cNvPr id="59" name="">
             <a:extLst xmlns:a="http://schemas.openxmlformats.org/drawingml/2006/main">
               <a:ext uri="{FF2B5EF4-FFF2-40B4-BE49-F238E27FC236}">
-                <a16:creationId xmlns:a16="http://schemas.microsoft.com/office/drawing/2014/main" id="{483085E0-1198-4248-8B94-1023AA1BFB62}"/>
+                <a16:creationId xmlns:a16="http://schemas.microsoft.com/office/drawing/2014/main" id="{EB059197-917F-435A-AFD9-C4B2F45D7A44}"/>
               </a:ext>
             </a:extLst>
           </p:cNvPr>
@@ -14059,7 +14059,7 @@
           <p:cNvPr id="60" name="">
             <a:extLst xmlns:a="http://schemas.openxmlformats.org/drawingml/2006/main">
               <a:ext uri="{FF2B5EF4-FFF2-40B4-BE49-F238E27FC236}">
-                <a16:creationId xmlns:a16="http://schemas.microsoft.com/office/drawing/2014/main" id="{AE5F70AA-97EB-4CA3-8893-5670791433B8}"/>
+                <a16:creationId xmlns:a16="http://schemas.microsoft.com/office/drawing/2014/main" id="{23512B0E-5554-486F-A5F6-EF98E90B78A3}"/>
               </a:ext>
             </a:extLst>
           </p:cNvPr>
@@ -14094,7 +14094,7 @@
           <p:cNvPr id="61" name="">
             <a:extLst xmlns:a="http://schemas.openxmlformats.org/drawingml/2006/main">
               <a:ext uri="{FF2B5EF4-FFF2-40B4-BE49-F238E27FC236}">
-                <a16:creationId xmlns:a16="http://schemas.microsoft.com/office/drawing/2014/main" id="{C9B3ADEE-6FB4-4E24-A175-06866EA17035}"/>
+                <a16:creationId xmlns:a16="http://schemas.microsoft.com/office/drawing/2014/main" id="{637D02B7-4C69-49DD-B701-D2283A630DEA}"/>
               </a:ext>
             </a:extLst>
           </p:cNvPr>
@@ -14156,7 +14156,7 @@
           <p:cNvPr id="62" name="">
             <a:extLst xmlns:a="http://schemas.openxmlformats.org/drawingml/2006/main">
               <a:ext uri="{FF2B5EF4-FFF2-40B4-BE49-F238E27FC236}">
-                <a16:creationId xmlns:a16="http://schemas.microsoft.com/office/drawing/2014/main" id="{01AD7368-4D22-4271-8AC5-55CF701DFD86}"/>
+                <a16:creationId xmlns:a16="http://schemas.microsoft.com/office/drawing/2014/main" id="{1EA5C6FC-B97D-499C-A4C4-3B54C83BDD3B}"/>
               </a:ext>
             </a:extLst>
           </p:cNvPr>
@@ -14218,7 +14218,7 @@
           <p:cNvPr id="63" name="">
             <a:extLst xmlns:a="http://schemas.openxmlformats.org/drawingml/2006/main">
               <a:ext uri="{FF2B5EF4-FFF2-40B4-BE49-F238E27FC236}">
-                <a16:creationId xmlns:a16="http://schemas.microsoft.com/office/drawing/2014/main" id="{4B9D5923-06DA-415B-9253-AEC4A5DDAEAE}"/>
+                <a16:creationId xmlns:a16="http://schemas.microsoft.com/office/drawing/2014/main" id="{6D18E845-131B-4037-9837-33BF455B9B1A}"/>
               </a:ext>
             </a:extLst>
           </p:cNvPr>
@@ -14280,7 +14280,7 @@
           <p:cNvPr id="64" name="">
             <a:extLst xmlns:a="http://schemas.openxmlformats.org/drawingml/2006/main">
               <a:ext uri="{FF2B5EF4-FFF2-40B4-BE49-F238E27FC236}">
-                <a16:creationId xmlns:a16="http://schemas.microsoft.com/office/drawing/2014/main" id="{415A009F-9FF2-4C22-A45A-D12A7D02188A}"/>
+                <a16:creationId xmlns:a16="http://schemas.microsoft.com/office/drawing/2014/main" id="{DB8A8424-324E-4A32-8291-069E4C6D30C1}"/>
               </a:ext>
             </a:extLst>
           </p:cNvPr>
@@ -14311,7 +14311,7 @@
           <p:cNvPr id="65" name="">
             <a:extLst xmlns:a="http://schemas.openxmlformats.org/drawingml/2006/main">
               <a:ext uri="{FF2B5EF4-FFF2-40B4-BE49-F238E27FC236}">
-                <a16:creationId xmlns:a16="http://schemas.microsoft.com/office/drawing/2014/main" id="{0D648205-6108-4E30-8EAB-B7E4D1D55341}"/>
+                <a16:creationId xmlns:a16="http://schemas.microsoft.com/office/drawing/2014/main" id="{40F5F717-5737-4EDA-A1FD-84FF10B12212}"/>
               </a:ext>
             </a:extLst>
           </p:cNvPr>
@@ -14373,7 +14373,7 @@
           <p:cNvPr id="66" name="">
             <a:extLst xmlns:a="http://schemas.openxmlformats.org/drawingml/2006/main">
               <a:ext uri="{FF2B5EF4-FFF2-40B4-BE49-F238E27FC236}">
-                <a16:creationId xmlns:a16="http://schemas.microsoft.com/office/drawing/2014/main" id="{9A798A32-1CAC-454A-B1A0-8CD31934C28D}"/>
+                <a16:creationId xmlns:a16="http://schemas.microsoft.com/office/drawing/2014/main" id="{7366C279-91BD-40B6-9FB7-15E8C9514BD6}"/>
               </a:ext>
             </a:extLst>
           </p:cNvPr>
@@ -14433,7 +14433,7 @@
     </p:spTree>
     <p:extLst>
       <p:ext uri="{BB962C8B-B14F-4D97-AF65-F5344CB8AC3E}">
-        <p14:creationId xmlns:p14="http://schemas.microsoft.com/office/powerpoint/2010/main" val="2104223195"/>
+        <p14:creationId xmlns:p14="http://schemas.microsoft.com/office/powerpoint/2010/main" val="570323241"/>
       </p:ext>
     </p:extLst>
   </p:cSld>
@@ -14464,7 +14464,7 @@
           <p:cNvPr id="58" name="">
             <a:extLst xmlns:a="http://schemas.openxmlformats.org/drawingml/2006/main">
               <a:ext uri="{FF2B5EF4-FFF2-40B4-BE49-F238E27FC236}">
-                <a16:creationId xmlns:a16="http://schemas.microsoft.com/office/drawing/2014/main" id="{5B8CB707-7DF2-4EFD-814D-8CB78DA8FE71}"/>
+                <a16:creationId xmlns:a16="http://schemas.microsoft.com/office/drawing/2014/main" id="{05855EC6-F22E-4B97-BFE9-F4EF1F451EBF}"/>
               </a:ext>
             </a:extLst>
           </p:cNvPr>
@@ -14495,7 +14495,7 @@
           <p:cNvPr id="2" name="">
             <a:extLst xmlns:a="http://schemas.openxmlformats.org/drawingml/2006/main">
               <a:ext uri="{FF2B5EF4-FFF2-40B4-BE49-F238E27FC236}">
-                <a16:creationId xmlns:a16="http://schemas.microsoft.com/office/drawing/2014/main" id="{40777A18-5BC6-428D-A02F-8EEA77DB5788}"/>
+                <a16:creationId xmlns:a16="http://schemas.microsoft.com/office/drawing/2014/main" id="{E2268CCF-5196-4C3B-88FE-4E23AC576243}"/>
               </a:ext>
             </a:extLst>
           </p:cNvPr>
@@ -14526,7 +14526,7 @@
           <p:cNvPr id="3" name="">
             <a:extLst xmlns:a="http://schemas.openxmlformats.org/drawingml/2006/main">
               <a:ext uri="{FF2B5EF4-FFF2-40B4-BE49-F238E27FC236}">
-                <a16:creationId xmlns:a16="http://schemas.microsoft.com/office/drawing/2014/main" id="{4B39996F-9B91-473E-AB51-B7BAC499BE41}"/>
+                <a16:creationId xmlns:a16="http://schemas.microsoft.com/office/drawing/2014/main" id="{7BF4BA59-ED9B-473A-99EE-3F82ED87CF30}"/>
               </a:ext>
             </a:extLst>
           </p:cNvPr>
@@ -14557,7 +14557,7 @@
           <p:cNvPr id="4" name="">
             <a:extLst xmlns:a="http://schemas.openxmlformats.org/drawingml/2006/main">
               <a:ext uri="{FF2B5EF4-FFF2-40B4-BE49-F238E27FC236}">
-                <a16:creationId xmlns:a16="http://schemas.microsoft.com/office/drawing/2014/main" id="{5E73C6E9-290B-4A8D-98E0-A97BA65A6B52}"/>
+                <a16:creationId xmlns:a16="http://schemas.microsoft.com/office/drawing/2014/main" id="{1DADF871-3272-4729-AE95-B5CC4A6BDF91}"/>
               </a:ext>
             </a:extLst>
           </p:cNvPr>
@@ -14588,7 +14588,7 @@
           <p:cNvPr id="5" name="">
             <a:extLst xmlns:a="http://schemas.openxmlformats.org/drawingml/2006/main">
               <a:ext uri="{FF2B5EF4-FFF2-40B4-BE49-F238E27FC236}">
-                <a16:creationId xmlns:a16="http://schemas.microsoft.com/office/drawing/2014/main" id="{86048381-47B8-4915-AF6B-E7761D120D98}"/>
+                <a16:creationId xmlns:a16="http://schemas.microsoft.com/office/drawing/2014/main" id="{8C9DBFFE-7BC9-4989-B010-DC1285C0871A}"/>
               </a:ext>
             </a:extLst>
           </p:cNvPr>
@@ -14619,7 +14619,7 @@
           <p:cNvPr id="6" name="">
             <a:extLst xmlns:a="http://schemas.openxmlformats.org/drawingml/2006/main">
               <a:ext uri="{FF2B5EF4-FFF2-40B4-BE49-F238E27FC236}">
-                <a16:creationId xmlns:a16="http://schemas.microsoft.com/office/drawing/2014/main" id="{580DA4B1-2C36-44E2-96AD-1CFB88BC6AC7}"/>
+                <a16:creationId xmlns:a16="http://schemas.microsoft.com/office/drawing/2014/main" id="{F54E3A03-8C31-4EE5-866B-B46A0295165F}"/>
               </a:ext>
             </a:extLst>
           </p:cNvPr>
@@ -14650,7 +14650,7 @@
           <p:cNvPr id="7" name="">
             <a:extLst xmlns:a="http://schemas.openxmlformats.org/drawingml/2006/main">
               <a:ext uri="{FF2B5EF4-FFF2-40B4-BE49-F238E27FC236}">
-                <a16:creationId xmlns:a16="http://schemas.microsoft.com/office/drawing/2014/main" id="{BAFD2ADF-5B6F-4B04-A701-77356B156894}"/>
+                <a16:creationId xmlns:a16="http://schemas.microsoft.com/office/drawing/2014/main" id="{96BC0C69-3F3F-43D3-8009-9A7689675D26}"/>
               </a:ext>
             </a:extLst>
           </p:cNvPr>
@@ -14681,7 +14681,7 @@
           <p:cNvPr id="8" name="">
             <a:extLst xmlns:a="http://schemas.openxmlformats.org/drawingml/2006/main">
               <a:ext uri="{FF2B5EF4-FFF2-40B4-BE49-F238E27FC236}">
-                <a16:creationId xmlns:a16="http://schemas.microsoft.com/office/drawing/2014/main" id="{787C1E0A-5698-4A8F-99DA-048E9B7A04CA}"/>
+                <a16:creationId xmlns:a16="http://schemas.microsoft.com/office/drawing/2014/main" id="{E78B63FE-479A-4A86-9285-9EF212AB3554}"/>
               </a:ext>
             </a:extLst>
           </p:cNvPr>
@@ -14712,7 +14712,7 @@
           <p:cNvPr id="9" name="">
             <a:extLst xmlns:a="http://schemas.openxmlformats.org/drawingml/2006/main">
               <a:ext uri="{FF2B5EF4-FFF2-40B4-BE49-F238E27FC236}">
-                <a16:creationId xmlns:a16="http://schemas.microsoft.com/office/drawing/2014/main" id="{897C7DEE-5318-4DA6-A961-628F2C08295D}"/>
+                <a16:creationId xmlns:a16="http://schemas.microsoft.com/office/drawing/2014/main" id="{61D8D0E7-ECD1-4458-B289-38CC438040C0}"/>
               </a:ext>
             </a:extLst>
           </p:cNvPr>
@@ -14743,7 +14743,7 @@
           <p:cNvPr id="10" name="">
             <a:extLst xmlns:a="http://schemas.openxmlformats.org/drawingml/2006/main">
               <a:ext uri="{FF2B5EF4-FFF2-40B4-BE49-F238E27FC236}">
-                <a16:creationId xmlns:a16="http://schemas.microsoft.com/office/drawing/2014/main" id="{A12C5D26-9850-42C4-AE77-2AF143232C9D}"/>
+                <a16:creationId xmlns:a16="http://schemas.microsoft.com/office/drawing/2014/main" id="{4DAE7E14-A4C1-4499-B6FD-B26FB6A09E3B}"/>
               </a:ext>
             </a:extLst>
           </p:cNvPr>
@@ -14774,7 +14774,7 @@
           <p:cNvPr id="11" name="">
             <a:extLst xmlns:a="http://schemas.openxmlformats.org/drawingml/2006/main">
               <a:ext uri="{FF2B5EF4-FFF2-40B4-BE49-F238E27FC236}">
-                <a16:creationId xmlns:a16="http://schemas.microsoft.com/office/drawing/2014/main" id="{8363B448-C055-4B41-9DA4-F4A5D8AE5418}"/>
+                <a16:creationId xmlns:a16="http://schemas.microsoft.com/office/drawing/2014/main" id="{62A008A5-6898-4785-AA62-1B9076F92150}"/>
               </a:ext>
             </a:extLst>
           </p:cNvPr>
@@ -14805,7 +14805,7 @@
           <p:cNvPr id="12" name="">
             <a:extLst xmlns:a="http://schemas.openxmlformats.org/drawingml/2006/main">
               <a:ext uri="{FF2B5EF4-FFF2-40B4-BE49-F238E27FC236}">
-                <a16:creationId xmlns:a16="http://schemas.microsoft.com/office/drawing/2014/main" id="{25039355-3B22-4B43-9BFE-13012D91BED2}"/>
+                <a16:creationId xmlns:a16="http://schemas.microsoft.com/office/drawing/2014/main" id="{4728CD1D-360D-4236-AF45-9060FB098975}"/>
               </a:ext>
             </a:extLst>
           </p:cNvPr>
@@ -14836,7 +14836,7 @@
           <p:cNvPr id="13" name="">
             <a:extLst xmlns:a="http://schemas.openxmlformats.org/drawingml/2006/main">
               <a:ext uri="{FF2B5EF4-FFF2-40B4-BE49-F238E27FC236}">
-                <a16:creationId xmlns:a16="http://schemas.microsoft.com/office/drawing/2014/main" id="{5610240B-1770-484F-BECC-147D16C2D23F}"/>
+                <a16:creationId xmlns:a16="http://schemas.microsoft.com/office/drawing/2014/main" id="{C097290B-C759-4D9C-B934-EDFC97DA7857}"/>
               </a:ext>
             </a:extLst>
           </p:cNvPr>
@@ -14867,7 +14867,7 @@
           <p:cNvPr id="14" name="">
             <a:extLst xmlns:a="http://schemas.openxmlformats.org/drawingml/2006/main">
               <a:ext uri="{FF2B5EF4-FFF2-40B4-BE49-F238E27FC236}">
-                <a16:creationId xmlns:a16="http://schemas.microsoft.com/office/drawing/2014/main" id="{A8542A36-6002-4B42-8B0E-2C15AA288947}"/>
+                <a16:creationId xmlns:a16="http://schemas.microsoft.com/office/drawing/2014/main" id="{1AA59102-40C3-4441-B039-27C3BCFFD15D}"/>
               </a:ext>
             </a:extLst>
           </p:cNvPr>
@@ -14898,7 +14898,7 @@
           <p:cNvPr id="15" name="">
             <a:extLst xmlns:a="http://schemas.openxmlformats.org/drawingml/2006/main">
               <a:ext uri="{FF2B5EF4-FFF2-40B4-BE49-F238E27FC236}">
-                <a16:creationId xmlns:a16="http://schemas.microsoft.com/office/drawing/2014/main" id="{E4849552-46EE-44F8-8218-4395B007304E}"/>
+                <a16:creationId xmlns:a16="http://schemas.microsoft.com/office/drawing/2014/main" id="{D0294376-34FA-4182-8C7B-568ECE9F25D1}"/>
               </a:ext>
             </a:extLst>
           </p:cNvPr>
@@ -14929,7 +14929,7 @@
           <p:cNvPr id="16" name="">
             <a:extLst xmlns:a="http://schemas.openxmlformats.org/drawingml/2006/main">
               <a:ext uri="{FF2B5EF4-FFF2-40B4-BE49-F238E27FC236}">
-                <a16:creationId xmlns:a16="http://schemas.microsoft.com/office/drawing/2014/main" id="{D9E4CBEB-3108-400B-B780-A569CAB19583}"/>
+                <a16:creationId xmlns:a16="http://schemas.microsoft.com/office/drawing/2014/main" id="{F8720033-DD64-4DD5-AED1-7649758D032C}"/>
               </a:ext>
             </a:extLst>
           </p:cNvPr>
@@ -14960,7 +14960,7 @@
           <p:cNvPr id="17" name="">
             <a:extLst xmlns:a="http://schemas.openxmlformats.org/drawingml/2006/main">
               <a:ext uri="{FF2B5EF4-FFF2-40B4-BE49-F238E27FC236}">
-                <a16:creationId xmlns:a16="http://schemas.microsoft.com/office/drawing/2014/main" id="{2CF9DEBA-6C19-4732-AFAB-45AF33DF034E}"/>
+                <a16:creationId xmlns:a16="http://schemas.microsoft.com/office/drawing/2014/main" id="{65F01713-1EE3-47FE-A21B-CA1870330420}"/>
               </a:ext>
             </a:extLst>
           </p:cNvPr>
@@ -14991,7 +14991,7 @@
           <p:cNvPr id="18" name="">
             <a:extLst xmlns:a="http://schemas.openxmlformats.org/drawingml/2006/main">
               <a:ext uri="{FF2B5EF4-FFF2-40B4-BE49-F238E27FC236}">
-                <a16:creationId xmlns:a16="http://schemas.microsoft.com/office/drawing/2014/main" id="{C02FF58B-91F1-4CC7-889E-C21DA3FAB455}"/>
+                <a16:creationId xmlns:a16="http://schemas.microsoft.com/office/drawing/2014/main" id="{1C1C0FD2-BDD6-4DD1-BBF9-B9AB52FCC4C7}"/>
               </a:ext>
             </a:extLst>
           </p:cNvPr>
@@ -15022,7 +15022,7 @@
           <p:cNvPr id="19" name="">
             <a:extLst xmlns:a="http://schemas.openxmlformats.org/drawingml/2006/main">
               <a:ext uri="{FF2B5EF4-FFF2-40B4-BE49-F238E27FC236}">
-                <a16:creationId xmlns:a16="http://schemas.microsoft.com/office/drawing/2014/main" id="{7D3D5280-DEBA-4832-A516-615541CB4E26}"/>
+                <a16:creationId xmlns:a16="http://schemas.microsoft.com/office/drawing/2014/main" id="{72D7E81C-24C1-40F1-9576-72CFAA1B7270}"/>
               </a:ext>
             </a:extLst>
           </p:cNvPr>
@@ -15053,7 +15053,7 @@
           <p:cNvPr id="20" name="">
             <a:extLst xmlns:a="http://schemas.openxmlformats.org/drawingml/2006/main">
               <a:ext uri="{FF2B5EF4-FFF2-40B4-BE49-F238E27FC236}">
-                <a16:creationId xmlns:a16="http://schemas.microsoft.com/office/drawing/2014/main" id="{006BDC30-38D5-41D4-BE9A-CA1916722239}"/>
+                <a16:creationId xmlns:a16="http://schemas.microsoft.com/office/drawing/2014/main" id="{6E9EC0AE-5968-46C9-80F6-D295F6D48019}"/>
               </a:ext>
             </a:extLst>
           </p:cNvPr>
@@ -15084,7 +15084,7 @@
           <p:cNvPr id="21" name="">
             <a:extLst xmlns:a="http://schemas.openxmlformats.org/drawingml/2006/main">
               <a:ext uri="{FF2B5EF4-FFF2-40B4-BE49-F238E27FC236}">
-                <a16:creationId xmlns:a16="http://schemas.microsoft.com/office/drawing/2014/main" id="{8B2B1B51-700C-4BE3-9B0F-E30EB2E18B3E}"/>
+                <a16:creationId xmlns:a16="http://schemas.microsoft.com/office/drawing/2014/main" id="{2F06B187-0C94-4812-AA63-2B75B9685CEE}"/>
               </a:ext>
             </a:extLst>
           </p:cNvPr>
@@ -15115,7 +15115,7 @@
           <p:cNvPr id="22" name="">
             <a:extLst xmlns:a="http://schemas.openxmlformats.org/drawingml/2006/main">
               <a:ext uri="{FF2B5EF4-FFF2-40B4-BE49-F238E27FC236}">
-                <a16:creationId xmlns:a16="http://schemas.microsoft.com/office/drawing/2014/main" id="{73CDFA45-2782-4A4E-8017-399BD3127B3B}"/>
+                <a16:creationId xmlns:a16="http://schemas.microsoft.com/office/drawing/2014/main" id="{5218FF0A-96C2-447F-8ACC-84F56E846606}"/>
               </a:ext>
             </a:extLst>
           </p:cNvPr>
@@ -15146,7 +15146,7 @@
           <p:cNvPr id="23" name="">
             <a:extLst xmlns:a="http://schemas.openxmlformats.org/drawingml/2006/main">
               <a:ext uri="{FF2B5EF4-FFF2-40B4-BE49-F238E27FC236}">
-                <a16:creationId xmlns:a16="http://schemas.microsoft.com/office/drawing/2014/main" id="{88652612-1277-46F6-86F8-6FBAF3AE9117}"/>
+                <a16:creationId xmlns:a16="http://schemas.microsoft.com/office/drawing/2014/main" id="{3B2E631C-E53C-48D1-81EC-6C1C7F8A14CA}"/>
               </a:ext>
             </a:extLst>
           </p:cNvPr>
@@ -15177,7 +15177,7 @@
           <p:cNvPr id="24" name="">
             <a:extLst xmlns:a="http://schemas.openxmlformats.org/drawingml/2006/main">
               <a:ext uri="{FF2B5EF4-FFF2-40B4-BE49-F238E27FC236}">
-                <a16:creationId xmlns:a16="http://schemas.microsoft.com/office/drawing/2014/main" id="{B71343D3-4D00-4AB0-AD12-147DB9909594}"/>
+                <a16:creationId xmlns:a16="http://schemas.microsoft.com/office/drawing/2014/main" id="{2D434AB1-34FD-4346-A251-FB3D4EE95C7E}"/>
               </a:ext>
             </a:extLst>
           </p:cNvPr>
@@ -15208,7 +15208,7 @@
           <p:cNvPr id="25" name="">
             <a:extLst xmlns:a="http://schemas.openxmlformats.org/drawingml/2006/main">
               <a:ext uri="{FF2B5EF4-FFF2-40B4-BE49-F238E27FC236}">
-                <a16:creationId xmlns:a16="http://schemas.microsoft.com/office/drawing/2014/main" id="{C921F66E-039C-4D12-85C1-CF2D4A8C700C}"/>
+                <a16:creationId xmlns:a16="http://schemas.microsoft.com/office/drawing/2014/main" id="{5042C89F-65D6-4167-A95C-987C1AFCBAA6}"/>
               </a:ext>
             </a:extLst>
           </p:cNvPr>
@@ -15239,7 +15239,7 @@
           <p:cNvPr id="26" name="">
             <a:extLst xmlns:a="http://schemas.openxmlformats.org/drawingml/2006/main">
               <a:ext uri="{FF2B5EF4-FFF2-40B4-BE49-F238E27FC236}">
-                <a16:creationId xmlns:a16="http://schemas.microsoft.com/office/drawing/2014/main" id="{84E81878-513B-4C88-9B58-7E03F6DC027E}"/>
+                <a16:creationId xmlns:a16="http://schemas.microsoft.com/office/drawing/2014/main" id="{D3DDBFA8-7FFD-4778-89F6-2F933ABC2523}"/>
               </a:ext>
             </a:extLst>
           </p:cNvPr>
@@ -15270,7 +15270,7 @@
           <p:cNvPr id="27" name="">
             <a:extLst xmlns:a="http://schemas.openxmlformats.org/drawingml/2006/main">
               <a:ext uri="{FF2B5EF4-FFF2-40B4-BE49-F238E27FC236}">
-                <a16:creationId xmlns:a16="http://schemas.microsoft.com/office/drawing/2014/main" id="{A9DF329B-C2FF-41B3-867D-A205509C1440}"/>
+                <a16:creationId xmlns:a16="http://schemas.microsoft.com/office/drawing/2014/main" id="{22958BD0-A631-4570-92EC-C05CB1E05915}"/>
               </a:ext>
             </a:extLst>
           </p:cNvPr>
@@ -15301,7 +15301,7 @@
           <p:cNvPr id="28" name="">
             <a:extLst xmlns:a="http://schemas.openxmlformats.org/drawingml/2006/main">
               <a:ext uri="{FF2B5EF4-FFF2-40B4-BE49-F238E27FC236}">
-                <a16:creationId xmlns:a16="http://schemas.microsoft.com/office/drawing/2014/main" id="{9F733C10-86E7-4C34-B5C3-3A49E360D59F}"/>
+                <a16:creationId xmlns:a16="http://schemas.microsoft.com/office/drawing/2014/main" id="{6617A024-96E8-4011-BEFA-E9FDF55EF146}"/>
               </a:ext>
             </a:extLst>
           </p:cNvPr>
@@ -15332,7 +15332,7 @@
           <p:cNvPr id="29" name="">
             <a:extLst xmlns:a="http://schemas.openxmlformats.org/drawingml/2006/main">
               <a:ext uri="{FF2B5EF4-FFF2-40B4-BE49-F238E27FC236}">
-                <a16:creationId xmlns:a16="http://schemas.microsoft.com/office/drawing/2014/main" id="{1F0EAD93-4B8C-4C94-BED4-712B82A15311}"/>
+                <a16:creationId xmlns:a16="http://schemas.microsoft.com/office/drawing/2014/main" id="{6D7D4B66-4AED-4A31-BEBA-0CE19B018DED}"/>
               </a:ext>
             </a:extLst>
           </p:cNvPr>
@@ -15363,7 +15363,7 @@
           <p:cNvPr id="30" name="">
             <a:extLst xmlns:a="http://schemas.openxmlformats.org/drawingml/2006/main">
               <a:ext uri="{FF2B5EF4-FFF2-40B4-BE49-F238E27FC236}">
-                <a16:creationId xmlns:a16="http://schemas.microsoft.com/office/drawing/2014/main" id="{29716506-E2FE-4D41-B74D-49D29742DBD1}"/>
+                <a16:creationId xmlns:a16="http://schemas.microsoft.com/office/drawing/2014/main" id="{E3ADAB11-F501-473A-8430-8B89BA65EBAC}"/>
               </a:ext>
             </a:extLst>
           </p:cNvPr>
@@ -15394,7 +15394,7 @@
           <p:cNvPr id="31" name="">
             <a:extLst xmlns:a="http://schemas.openxmlformats.org/drawingml/2006/main">
               <a:ext uri="{FF2B5EF4-FFF2-40B4-BE49-F238E27FC236}">
-                <a16:creationId xmlns:a16="http://schemas.microsoft.com/office/drawing/2014/main" id="{469273A9-20EC-447F-91F2-CBC4D06F063C}"/>
+                <a16:creationId xmlns:a16="http://schemas.microsoft.com/office/drawing/2014/main" id="{4C8D7613-F014-453B-8A94-BCF2C63B427F}"/>
               </a:ext>
             </a:extLst>
           </p:cNvPr>
@@ -15425,7 +15425,7 @@
           <p:cNvPr id="32" name="">
             <a:extLst xmlns:a="http://schemas.openxmlformats.org/drawingml/2006/main">
               <a:ext uri="{FF2B5EF4-FFF2-40B4-BE49-F238E27FC236}">
-                <a16:creationId xmlns:a16="http://schemas.microsoft.com/office/drawing/2014/main" id="{014AFC88-83F5-4E2F-B6CE-F44D2065E814}"/>
+                <a16:creationId xmlns:a16="http://schemas.microsoft.com/office/drawing/2014/main" id="{039F2661-5004-4A3E-BAF8-DFF3FAA5F34C}"/>
               </a:ext>
             </a:extLst>
           </p:cNvPr>
@@ -15456,7 +15456,7 @@
           <p:cNvPr id="33" name="">
             <a:extLst xmlns:a="http://schemas.openxmlformats.org/drawingml/2006/main">
               <a:ext uri="{FF2B5EF4-FFF2-40B4-BE49-F238E27FC236}">
-                <a16:creationId xmlns:a16="http://schemas.microsoft.com/office/drawing/2014/main" id="{3DF98E2B-CC8C-4B9A-8E16-C45E19935215}"/>
+                <a16:creationId xmlns:a16="http://schemas.microsoft.com/office/drawing/2014/main" id="{DA41F1A4-AC54-40C9-9D44-B51A47BDB394}"/>
               </a:ext>
             </a:extLst>
           </p:cNvPr>
@@ -15487,7 +15487,7 @@
           <p:cNvPr id="34" name="">
             <a:extLst xmlns:a="http://schemas.openxmlformats.org/drawingml/2006/main">
               <a:ext uri="{FF2B5EF4-FFF2-40B4-BE49-F238E27FC236}">
-                <a16:creationId xmlns:a16="http://schemas.microsoft.com/office/drawing/2014/main" id="{173F8270-99A0-4F55-A6B3-9DD8CA5B70DF}"/>
+                <a16:creationId xmlns:a16="http://schemas.microsoft.com/office/drawing/2014/main" id="{5A8BEA96-5E7E-4077-9319-4A5A2C31E854}"/>
               </a:ext>
             </a:extLst>
           </p:cNvPr>
@@ -15520,7 +15520,7 @@
           <p:cNvPr id="35" name="">
             <a:extLst xmlns:a="http://schemas.openxmlformats.org/drawingml/2006/main">
               <a:ext uri="{FF2B5EF4-FFF2-40B4-BE49-F238E27FC236}">
-                <a16:creationId xmlns:a16="http://schemas.microsoft.com/office/drawing/2014/main" id="{C745E3A9-7AA2-491C-9909-3DD2E907175A}"/>
+                <a16:creationId xmlns:a16="http://schemas.microsoft.com/office/drawing/2014/main" id="{45EEB423-C76D-4026-9CE5-5B3AA9C83D61}"/>
               </a:ext>
             </a:extLst>
           </p:cNvPr>
@@ -15582,7 +15582,7 @@
           <p:cNvPr id="36" name="">
             <a:extLst xmlns:a="http://schemas.openxmlformats.org/drawingml/2006/main">
               <a:ext uri="{FF2B5EF4-FFF2-40B4-BE49-F238E27FC236}">
-                <a16:creationId xmlns:a16="http://schemas.microsoft.com/office/drawing/2014/main" id="{39FFAD24-5D1B-489D-8C59-1C78A6C718D4}"/>
+                <a16:creationId xmlns:a16="http://schemas.microsoft.com/office/drawing/2014/main" id="{7AA41939-DBB6-4CA1-ADAA-F7CD084CA311}"/>
               </a:ext>
             </a:extLst>
           </p:cNvPr>
@@ -15644,7 +15644,7 @@
           <p:cNvPr id="37" name="">
             <a:extLst xmlns:a="http://schemas.openxmlformats.org/drawingml/2006/main">
               <a:ext uri="{FF2B5EF4-FFF2-40B4-BE49-F238E27FC236}">
-                <a16:creationId xmlns:a16="http://schemas.microsoft.com/office/drawing/2014/main" id="{9F9C66E7-6925-4DA4-825F-7F078E307817}"/>
+                <a16:creationId xmlns:a16="http://schemas.microsoft.com/office/drawing/2014/main" id="{8DEB1BFC-5F93-4E80-8413-3DAC93C6E9B7}"/>
               </a:ext>
             </a:extLst>
           </p:cNvPr>
@@ -15706,7 +15706,7 @@
           <p:cNvPr id="38" name="">
             <a:extLst xmlns:a="http://schemas.openxmlformats.org/drawingml/2006/main">
               <a:ext uri="{FF2B5EF4-FFF2-40B4-BE49-F238E27FC236}">
-                <a16:creationId xmlns:a16="http://schemas.microsoft.com/office/drawing/2014/main" id="{F80BE009-9D28-4B28-9C09-0B8FAC4CD79C}"/>
+                <a16:creationId xmlns:a16="http://schemas.microsoft.com/office/drawing/2014/main" id="{FCC655CC-9E93-433E-BDE4-7A9702D33715}"/>
               </a:ext>
             </a:extLst>
           </p:cNvPr>
@@ -15768,7 +15768,7 @@
           <p:cNvPr id="39" name="">
             <a:extLst xmlns:a="http://schemas.openxmlformats.org/drawingml/2006/main">
               <a:ext uri="{FF2B5EF4-FFF2-40B4-BE49-F238E27FC236}">
-                <a16:creationId xmlns:a16="http://schemas.microsoft.com/office/drawing/2014/main" id="{FE341911-49DE-4B7B-A44A-E8B6C4DA1808}"/>
+                <a16:creationId xmlns:a16="http://schemas.microsoft.com/office/drawing/2014/main" id="{82824C9A-9112-46D2-BCF2-0B838CF9BD5A}"/>
               </a:ext>
             </a:extLst>
           </p:cNvPr>
@@ -15799,7 +15799,7 @@
           <p:cNvPr id="40" name="">
             <a:extLst xmlns:a="http://schemas.openxmlformats.org/drawingml/2006/main">
               <a:ext uri="{FF2B5EF4-FFF2-40B4-BE49-F238E27FC236}">
-                <a16:creationId xmlns:a16="http://schemas.microsoft.com/office/drawing/2014/main" id="{EF30F334-B3DE-4908-BFBE-3871A8DF7D56}"/>
+                <a16:creationId xmlns:a16="http://schemas.microsoft.com/office/drawing/2014/main" id="{C141C7A4-D100-4AD7-947E-D1F05063A38C}"/>
               </a:ext>
             </a:extLst>
           </p:cNvPr>
@@ -15830,7 +15830,7 @@
           <p:cNvPr id="41" name="">
             <a:extLst xmlns:a="http://schemas.openxmlformats.org/drawingml/2006/main">
               <a:ext uri="{FF2B5EF4-FFF2-40B4-BE49-F238E27FC236}">
-                <a16:creationId xmlns:a16="http://schemas.microsoft.com/office/drawing/2014/main" id="{9B1D96C1-9C00-4287-8C3B-F86ECE335930}"/>
+                <a16:creationId xmlns:a16="http://schemas.microsoft.com/office/drawing/2014/main" id="{B2FBF46F-370E-4A6A-A49D-090BB1733269}"/>
               </a:ext>
             </a:extLst>
           </p:cNvPr>
@@ -15892,7 +15892,7 @@
           <p:cNvPr id="42" name="">
             <a:extLst xmlns:a="http://schemas.openxmlformats.org/drawingml/2006/main">
               <a:ext uri="{FF2B5EF4-FFF2-40B4-BE49-F238E27FC236}">
-                <a16:creationId xmlns:a16="http://schemas.microsoft.com/office/drawing/2014/main" id="{B000889F-843D-460D-945B-ABAB81113694}"/>
+                <a16:creationId xmlns:a16="http://schemas.microsoft.com/office/drawing/2014/main" id="{133F7DB5-8C63-40C6-AEDF-16907643DF7E}"/>
               </a:ext>
             </a:extLst>
           </p:cNvPr>
@@ -15927,7 +15927,7 @@
           <p:cNvPr id="43" name="">
             <a:extLst xmlns:a="http://schemas.openxmlformats.org/drawingml/2006/main">
               <a:ext uri="{FF2B5EF4-FFF2-40B4-BE49-F238E27FC236}">
-                <a16:creationId xmlns:a16="http://schemas.microsoft.com/office/drawing/2014/main" id="{57895D3C-7402-4304-9086-C042CBEF1B5C}"/>
+                <a16:creationId xmlns:a16="http://schemas.microsoft.com/office/drawing/2014/main" id="{EE99F537-5544-4D9C-ADF3-5F8AEB29AF87}"/>
               </a:ext>
             </a:extLst>
           </p:cNvPr>
@@ -15989,7 +15989,7 @@
           <p:cNvPr id="44" name="">
             <a:extLst xmlns:a="http://schemas.openxmlformats.org/drawingml/2006/main">
               <a:ext uri="{FF2B5EF4-FFF2-40B4-BE49-F238E27FC236}">
-                <a16:creationId xmlns:a16="http://schemas.microsoft.com/office/drawing/2014/main" id="{1FC84E68-B056-4AD1-9C8E-100025930DCA}"/>
+                <a16:creationId xmlns:a16="http://schemas.microsoft.com/office/drawing/2014/main" id="{5478504A-ED4A-493A-8244-BF331F590B97}"/>
               </a:ext>
             </a:extLst>
           </p:cNvPr>
@@ -16051,7 +16051,7 @@
           <p:cNvPr id="45" name="">
             <a:extLst xmlns:a="http://schemas.openxmlformats.org/drawingml/2006/main">
               <a:ext uri="{FF2B5EF4-FFF2-40B4-BE49-F238E27FC236}">
-                <a16:creationId xmlns:a16="http://schemas.microsoft.com/office/drawing/2014/main" id="{C2379C10-B5E1-44B4-BE6F-25A3C1BE43AE}"/>
+                <a16:creationId xmlns:a16="http://schemas.microsoft.com/office/drawing/2014/main" id="{FAA2F0BE-FFC1-47A4-8BF7-521FAAAFA645}"/>
               </a:ext>
             </a:extLst>
           </p:cNvPr>
@@ -16113,7 +16113,7 @@
           <p:cNvPr id="46" name="">
             <a:extLst xmlns:a="http://schemas.openxmlformats.org/drawingml/2006/main">
               <a:ext uri="{FF2B5EF4-FFF2-40B4-BE49-F238E27FC236}">
-                <a16:creationId xmlns:a16="http://schemas.microsoft.com/office/drawing/2014/main" id="{B9A160BC-1B73-4500-BAEA-F0AF933F0F6C}"/>
+                <a16:creationId xmlns:a16="http://schemas.microsoft.com/office/drawing/2014/main" id="{C92D20E0-989D-484F-8172-0CAD04680A06}"/>
               </a:ext>
             </a:extLst>
           </p:cNvPr>
@@ -16148,7 +16148,7 @@
           <p:cNvPr id="47" name="">
             <a:extLst xmlns:a="http://schemas.openxmlformats.org/drawingml/2006/main">
               <a:ext uri="{FF2B5EF4-FFF2-40B4-BE49-F238E27FC236}">
-                <a16:creationId xmlns:a16="http://schemas.microsoft.com/office/drawing/2014/main" id="{0E25FA25-26B6-4A86-AC72-FC52959D71DF}"/>
+                <a16:creationId xmlns:a16="http://schemas.microsoft.com/office/drawing/2014/main" id="{AB26E4A1-3FCD-4CD8-AB14-75267C6CC5BC}"/>
               </a:ext>
             </a:extLst>
           </p:cNvPr>
@@ -16210,7 +16210,7 @@
           <p:cNvPr id="48" name="">
             <a:extLst xmlns:a="http://schemas.openxmlformats.org/drawingml/2006/main">
               <a:ext uri="{FF2B5EF4-FFF2-40B4-BE49-F238E27FC236}">
-                <a16:creationId xmlns:a16="http://schemas.microsoft.com/office/drawing/2014/main" id="{09F28A79-6BAA-4DEC-AB0B-89E0B0A202F8}"/>
+                <a16:creationId xmlns:a16="http://schemas.microsoft.com/office/drawing/2014/main" id="{76729474-8EC1-4805-BD8D-2B382AE435C5}"/>
               </a:ext>
             </a:extLst>
           </p:cNvPr>
@@ -16272,7 +16272,7 @@
           <p:cNvPr id="49" name="">
             <a:extLst xmlns:a="http://schemas.openxmlformats.org/drawingml/2006/main">
               <a:ext uri="{FF2B5EF4-FFF2-40B4-BE49-F238E27FC236}">
-                <a16:creationId xmlns:a16="http://schemas.microsoft.com/office/drawing/2014/main" id="{5B2914F6-B7C6-4187-8081-DF5D2325A000}"/>
+                <a16:creationId xmlns:a16="http://schemas.microsoft.com/office/drawing/2014/main" id="{058038CA-09EB-4593-B866-0E7C6EB6B220}"/>
               </a:ext>
             </a:extLst>
           </p:cNvPr>
@@ -16334,7 +16334,7 @@
           <p:cNvPr id="50" name="">
             <a:extLst xmlns:a="http://schemas.openxmlformats.org/drawingml/2006/main">
               <a:ext uri="{FF2B5EF4-FFF2-40B4-BE49-F238E27FC236}">
-                <a16:creationId xmlns:a16="http://schemas.microsoft.com/office/drawing/2014/main" id="{0CEFCE2B-407F-4864-AAC9-F572F6380044}"/>
+                <a16:creationId xmlns:a16="http://schemas.microsoft.com/office/drawing/2014/main" id="{02A38A79-FCEC-4A72-9186-3E32A0CB83D7}"/>
               </a:ext>
             </a:extLst>
           </p:cNvPr>
@@ -16369,7 +16369,7 @@
           <p:cNvPr id="51" name="">
             <a:extLst xmlns:a="http://schemas.openxmlformats.org/drawingml/2006/main">
               <a:ext uri="{FF2B5EF4-FFF2-40B4-BE49-F238E27FC236}">
-                <a16:creationId xmlns:a16="http://schemas.microsoft.com/office/drawing/2014/main" id="{3EB2B61A-D0AE-4658-9360-7DCBA039F9D8}"/>
+                <a16:creationId xmlns:a16="http://schemas.microsoft.com/office/drawing/2014/main" id="{B39DBD2B-B8E4-4A3A-9309-E9D2A9E545A5}"/>
               </a:ext>
             </a:extLst>
           </p:cNvPr>
@@ -16431,7 +16431,7 @@
           <p:cNvPr id="52" name="">
             <a:extLst xmlns:a="http://schemas.openxmlformats.org/drawingml/2006/main">
               <a:ext uri="{FF2B5EF4-FFF2-40B4-BE49-F238E27FC236}">
-                <a16:creationId xmlns:a16="http://schemas.microsoft.com/office/drawing/2014/main" id="{E9F176B7-6F0F-4489-9141-AD5FA61A7AF4}"/>
+                <a16:creationId xmlns:a16="http://schemas.microsoft.com/office/drawing/2014/main" id="{D6038F3B-56D8-4024-BA28-398B863C1389}"/>
               </a:ext>
             </a:extLst>
           </p:cNvPr>
@@ -16493,7 +16493,7 @@
           <p:cNvPr id="53" name="">
             <a:extLst xmlns:a="http://schemas.openxmlformats.org/drawingml/2006/main">
               <a:ext uri="{FF2B5EF4-FFF2-40B4-BE49-F238E27FC236}">
-                <a16:creationId xmlns:a16="http://schemas.microsoft.com/office/drawing/2014/main" id="{2C76DCF4-8C08-4C5B-9042-A5469088B639}"/>
+                <a16:creationId xmlns:a16="http://schemas.microsoft.com/office/drawing/2014/main" id="{747C95B7-14E1-4A51-8C1D-55042BE4B484}"/>
               </a:ext>
             </a:extLst>
           </p:cNvPr>
@@ -16555,7 +16555,7 @@
           <p:cNvPr id="54" name="">
             <a:extLst xmlns:a="http://schemas.openxmlformats.org/drawingml/2006/main">
               <a:ext uri="{FF2B5EF4-FFF2-40B4-BE49-F238E27FC236}">
-                <a16:creationId xmlns:a16="http://schemas.microsoft.com/office/drawing/2014/main" id="{5DCFC0A6-E08A-432B-B5EA-C2B4F7D77ED3}"/>
+                <a16:creationId xmlns:a16="http://schemas.microsoft.com/office/drawing/2014/main" id="{8A050EBE-2A33-4485-8938-B6E0ACAF94C8}"/>
               </a:ext>
             </a:extLst>
           </p:cNvPr>
@@ -16586,7 +16586,7 @@
           <p:cNvPr id="55" name="">
             <a:extLst xmlns:a="http://schemas.openxmlformats.org/drawingml/2006/main">
               <a:ext uri="{FF2B5EF4-FFF2-40B4-BE49-F238E27FC236}">
-                <a16:creationId xmlns:a16="http://schemas.microsoft.com/office/drawing/2014/main" id="{0F4638E9-422F-4A2C-911E-A166AEEB581C}"/>
+                <a16:creationId xmlns:a16="http://schemas.microsoft.com/office/drawing/2014/main" id="{FE87C747-5B0C-4166-B26D-E0C045CEBBAE}"/>
               </a:ext>
             </a:extLst>
           </p:cNvPr>
@@ -16617,7 +16617,7 @@
           <p:cNvPr id="56" name="">
             <a:extLst xmlns:a="http://schemas.openxmlformats.org/drawingml/2006/main">
               <a:ext uri="{FF2B5EF4-FFF2-40B4-BE49-F238E27FC236}">
-                <a16:creationId xmlns:a16="http://schemas.microsoft.com/office/drawing/2014/main" id="{BE47C7F4-E887-4A1E-BAC0-29312C83E900}"/>
+                <a16:creationId xmlns:a16="http://schemas.microsoft.com/office/drawing/2014/main" id="{3105444A-5357-493B-B381-FD0739003AF2}"/>
               </a:ext>
             </a:extLst>
           </p:cNvPr>
@@ -16679,7 +16679,7 @@
           <p:cNvPr id="57" name="">
             <a:extLst xmlns:a="http://schemas.openxmlformats.org/drawingml/2006/main">
               <a:ext uri="{FF2B5EF4-FFF2-40B4-BE49-F238E27FC236}">
-                <a16:creationId xmlns:a16="http://schemas.microsoft.com/office/drawing/2014/main" id="{9DC9B289-85EF-4CF3-AE22-7CE4F0D1FA16}"/>
+                <a16:creationId xmlns:a16="http://schemas.microsoft.com/office/drawing/2014/main" id="{23FECD30-EF6E-41ED-B4DD-5346A0277935}"/>
               </a:ext>
             </a:extLst>
           </p:cNvPr>
@@ -16739,7 +16739,7 @@
     </p:spTree>
     <p:extLst>
       <p:ext uri="{BB962C8B-B14F-4D97-AF65-F5344CB8AC3E}">
-        <p14:creationId xmlns:p14="http://schemas.microsoft.com/office/powerpoint/2010/main" val="1918520795"/>
+        <p14:creationId xmlns:p14="http://schemas.microsoft.com/office/powerpoint/2010/main" val="1895617626"/>
       </p:ext>
     </p:extLst>
   </p:cSld>
@@ -16770,7 +16770,7 @@
           <p:cNvPr id="50" name="">
             <a:extLst xmlns:a="http://schemas.openxmlformats.org/drawingml/2006/main">
               <a:ext uri="{FF2B5EF4-FFF2-40B4-BE49-F238E27FC236}">
-                <a16:creationId xmlns:a16="http://schemas.microsoft.com/office/drawing/2014/main" id="{00DA665C-5E47-4D38-878F-6E84EB26EE9E}"/>
+                <a16:creationId xmlns:a16="http://schemas.microsoft.com/office/drawing/2014/main" id="{C37E10AB-57DC-4CB9-B2DF-EC677821B25A}"/>
               </a:ext>
             </a:extLst>
           </p:cNvPr>
@@ -16801,7 +16801,7 @@
           <p:cNvPr id="2" name="">
             <a:extLst xmlns:a="http://schemas.openxmlformats.org/drawingml/2006/main">
               <a:ext uri="{FF2B5EF4-FFF2-40B4-BE49-F238E27FC236}">
-                <a16:creationId xmlns:a16="http://schemas.microsoft.com/office/drawing/2014/main" id="{B3F366F2-0DB4-4A42-A480-D6BF3AA1403F}"/>
+                <a16:creationId xmlns:a16="http://schemas.microsoft.com/office/drawing/2014/main" id="{C3AB3C4C-2583-4D8E-BE0E-EB2F18D70A17}"/>
               </a:ext>
             </a:extLst>
           </p:cNvPr>
@@ -16832,7 +16832,7 @@
           <p:cNvPr id="3" name="">
             <a:extLst xmlns:a="http://schemas.openxmlformats.org/drawingml/2006/main">
               <a:ext uri="{FF2B5EF4-FFF2-40B4-BE49-F238E27FC236}">
-                <a16:creationId xmlns:a16="http://schemas.microsoft.com/office/drawing/2014/main" id="{A127FF48-608B-4CD0-B2D5-F38617CE445F}"/>
+                <a16:creationId xmlns:a16="http://schemas.microsoft.com/office/drawing/2014/main" id="{3C6F974F-2889-4D72-BD29-31AED5D5D933}"/>
               </a:ext>
             </a:extLst>
           </p:cNvPr>
@@ -16863,7 +16863,7 @@
           <p:cNvPr id="4" name="">
             <a:extLst xmlns:a="http://schemas.openxmlformats.org/drawingml/2006/main">
               <a:ext uri="{FF2B5EF4-FFF2-40B4-BE49-F238E27FC236}">
-                <a16:creationId xmlns:a16="http://schemas.microsoft.com/office/drawing/2014/main" id="{4DD57B59-5AE9-4E7B-9C82-36782EFB92EB}"/>
+                <a16:creationId xmlns:a16="http://schemas.microsoft.com/office/drawing/2014/main" id="{15E6F917-8C42-4A37-A5F9-AE68DC3536F8}"/>
               </a:ext>
             </a:extLst>
           </p:cNvPr>
@@ -16894,7 +16894,7 @@
           <p:cNvPr id="5" name="">
             <a:extLst xmlns:a="http://schemas.openxmlformats.org/drawingml/2006/main">
               <a:ext uri="{FF2B5EF4-FFF2-40B4-BE49-F238E27FC236}">
-                <a16:creationId xmlns:a16="http://schemas.microsoft.com/office/drawing/2014/main" id="{A2F77641-5F8A-424F-8FEC-C8086203FEF1}"/>
+                <a16:creationId xmlns:a16="http://schemas.microsoft.com/office/drawing/2014/main" id="{EB5A7945-D1C4-45FC-A055-4E825E3BAC1B}"/>
               </a:ext>
             </a:extLst>
           </p:cNvPr>
@@ -16925,7 +16925,7 @@
           <p:cNvPr id="6" name="">
             <a:extLst xmlns:a="http://schemas.openxmlformats.org/drawingml/2006/main">
               <a:ext uri="{FF2B5EF4-FFF2-40B4-BE49-F238E27FC236}">
-                <a16:creationId xmlns:a16="http://schemas.microsoft.com/office/drawing/2014/main" id="{7313902E-23A2-409B-A1D5-EA52CFFFB208}"/>
+                <a16:creationId xmlns:a16="http://schemas.microsoft.com/office/drawing/2014/main" id="{90783B38-B0C3-494D-B209-0F31CBA3B21E}"/>
               </a:ext>
             </a:extLst>
           </p:cNvPr>
@@ -16956,7 +16956,7 @@
           <p:cNvPr id="7" name="">
             <a:extLst xmlns:a="http://schemas.openxmlformats.org/drawingml/2006/main">
               <a:ext uri="{FF2B5EF4-FFF2-40B4-BE49-F238E27FC236}">
-                <a16:creationId xmlns:a16="http://schemas.microsoft.com/office/drawing/2014/main" id="{5B9026A3-EF9E-47DD-952E-3C2A3DA00BBC}"/>
+                <a16:creationId xmlns:a16="http://schemas.microsoft.com/office/drawing/2014/main" id="{923E7DEA-1F79-46E1-B236-CC0B1B7832F5}"/>
               </a:ext>
             </a:extLst>
           </p:cNvPr>
@@ -16987,7 +16987,7 @@
           <p:cNvPr id="8" name="">
             <a:extLst xmlns:a="http://schemas.openxmlformats.org/drawingml/2006/main">
               <a:ext uri="{FF2B5EF4-FFF2-40B4-BE49-F238E27FC236}">
-                <a16:creationId xmlns:a16="http://schemas.microsoft.com/office/drawing/2014/main" id="{73DCD574-CC63-46A9-A5E5-2169F6118689}"/>
+                <a16:creationId xmlns:a16="http://schemas.microsoft.com/office/drawing/2014/main" id="{37717175-BD3C-49B6-A692-E920797BEFBA}"/>
               </a:ext>
             </a:extLst>
           </p:cNvPr>
@@ -17018,7 +17018,7 @@
           <p:cNvPr id="9" name="">
             <a:extLst xmlns:a="http://schemas.openxmlformats.org/drawingml/2006/main">
               <a:ext uri="{FF2B5EF4-FFF2-40B4-BE49-F238E27FC236}">
-                <a16:creationId xmlns:a16="http://schemas.microsoft.com/office/drawing/2014/main" id="{B24A81B0-B6E2-4E60-99DD-97BE2DC7DFA6}"/>
+                <a16:creationId xmlns:a16="http://schemas.microsoft.com/office/drawing/2014/main" id="{BC3A1F7B-6048-4681-B1E1-2BCC93E4E9C7}"/>
               </a:ext>
             </a:extLst>
           </p:cNvPr>
@@ -17049,7 +17049,7 @@
           <p:cNvPr id="10" name="">
             <a:extLst xmlns:a="http://schemas.openxmlformats.org/drawingml/2006/main">
               <a:ext uri="{FF2B5EF4-FFF2-40B4-BE49-F238E27FC236}">
-                <a16:creationId xmlns:a16="http://schemas.microsoft.com/office/drawing/2014/main" id="{52C3EF8C-DA0B-4CDD-A8B7-ADE69BECCD5A}"/>
+                <a16:creationId xmlns:a16="http://schemas.microsoft.com/office/drawing/2014/main" id="{0349C0F8-825B-403A-805E-9FB75FD6E1E8}"/>
               </a:ext>
             </a:extLst>
           </p:cNvPr>
@@ -17080,7 +17080,7 @@
           <p:cNvPr id="11" name="">
             <a:extLst xmlns:a="http://schemas.openxmlformats.org/drawingml/2006/main">
               <a:ext uri="{FF2B5EF4-FFF2-40B4-BE49-F238E27FC236}">
-                <a16:creationId xmlns:a16="http://schemas.microsoft.com/office/drawing/2014/main" id="{43882C11-6FFB-45E1-845F-FBCC976432FB}"/>
+                <a16:creationId xmlns:a16="http://schemas.microsoft.com/office/drawing/2014/main" id="{84E4B562-FF43-4D4F-860D-A2DE6F99F287}"/>
               </a:ext>
             </a:extLst>
           </p:cNvPr>
@@ -17111,7 +17111,7 @@
           <p:cNvPr id="12" name="">
             <a:extLst xmlns:a="http://schemas.openxmlformats.org/drawingml/2006/main">
               <a:ext uri="{FF2B5EF4-FFF2-40B4-BE49-F238E27FC236}">
-                <a16:creationId xmlns:a16="http://schemas.microsoft.com/office/drawing/2014/main" id="{5628B663-CE0B-4006-A174-FD518FD9A47E}"/>
+                <a16:creationId xmlns:a16="http://schemas.microsoft.com/office/drawing/2014/main" id="{1165A39A-4427-4A06-81CB-77792FE1A3A3}"/>
               </a:ext>
             </a:extLst>
           </p:cNvPr>
@@ -17142,7 +17142,7 @@
           <p:cNvPr id="13" name="">
             <a:extLst xmlns:a="http://schemas.openxmlformats.org/drawingml/2006/main">
               <a:ext uri="{FF2B5EF4-FFF2-40B4-BE49-F238E27FC236}">
-                <a16:creationId xmlns:a16="http://schemas.microsoft.com/office/drawing/2014/main" id="{7F7C1AF8-88EA-42D3-9919-AB6A4FCF8C03}"/>
+                <a16:creationId xmlns:a16="http://schemas.microsoft.com/office/drawing/2014/main" id="{AE4B1AFD-CDB5-4DD1-A5E0-BEB5A6CAB17B}"/>
               </a:ext>
             </a:extLst>
           </p:cNvPr>
@@ -17173,7 +17173,7 @@
           <p:cNvPr id="14" name="">
             <a:extLst xmlns:a="http://schemas.openxmlformats.org/drawingml/2006/main">
               <a:ext uri="{FF2B5EF4-FFF2-40B4-BE49-F238E27FC236}">
-                <a16:creationId xmlns:a16="http://schemas.microsoft.com/office/drawing/2014/main" id="{C14452C3-8176-41D8-8B97-9F441FE1AA26}"/>
+                <a16:creationId xmlns:a16="http://schemas.microsoft.com/office/drawing/2014/main" id="{44199D5A-C0DB-4D08-B831-E459ADA52969}"/>
               </a:ext>
             </a:extLst>
           </p:cNvPr>
@@ -17204,7 +17204,7 @@
           <p:cNvPr id="15" name="">
             <a:extLst xmlns:a="http://schemas.openxmlformats.org/drawingml/2006/main">
               <a:ext uri="{FF2B5EF4-FFF2-40B4-BE49-F238E27FC236}">
-                <a16:creationId xmlns:a16="http://schemas.microsoft.com/office/drawing/2014/main" id="{2F7A1AE3-0ABB-4768-AD33-C6CC7C7A13AD}"/>
+                <a16:creationId xmlns:a16="http://schemas.microsoft.com/office/drawing/2014/main" id="{F54DBA31-A422-48AA-A038-F6724F4BD1A3}"/>
               </a:ext>
             </a:extLst>
           </p:cNvPr>
@@ -17235,7 +17235,7 @@
           <p:cNvPr id="16" name="">
             <a:extLst xmlns:a="http://schemas.openxmlformats.org/drawingml/2006/main">
               <a:ext uri="{FF2B5EF4-FFF2-40B4-BE49-F238E27FC236}">
-                <a16:creationId xmlns:a16="http://schemas.microsoft.com/office/drawing/2014/main" id="{96E30DB6-6E8F-4EE3-8010-9E35BD37B2D5}"/>
+                <a16:creationId xmlns:a16="http://schemas.microsoft.com/office/drawing/2014/main" id="{4C3EB01A-212F-4776-A86F-9B07B22F7CDB}"/>
               </a:ext>
             </a:extLst>
           </p:cNvPr>
@@ -17266,7 +17266,7 @@
           <p:cNvPr id="17" name="">
             <a:extLst xmlns:a="http://schemas.openxmlformats.org/drawingml/2006/main">
               <a:ext uri="{FF2B5EF4-FFF2-40B4-BE49-F238E27FC236}">
-                <a16:creationId xmlns:a16="http://schemas.microsoft.com/office/drawing/2014/main" id="{E85584E1-8AA6-4EB1-A87A-767C9DE00634}"/>
+                <a16:creationId xmlns:a16="http://schemas.microsoft.com/office/drawing/2014/main" id="{6BB7EB63-580E-4E93-8C9B-AE67273289E5}"/>
               </a:ext>
             </a:extLst>
           </p:cNvPr>
@@ -17297,7 +17297,7 @@
           <p:cNvPr id="18" name="">
             <a:extLst xmlns:a="http://schemas.openxmlformats.org/drawingml/2006/main">
               <a:ext uri="{FF2B5EF4-FFF2-40B4-BE49-F238E27FC236}">
-                <a16:creationId xmlns:a16="http://schemas.microsoft.com/office/drawing/2014/main" id="{5CC1F05B-CD1F-477D-8907-9D99E754B4D6}"/>
+                <a16:creationId xmlns:a16="http://schemas.microsoft.com/office/drawing/2014/main" id="{808DE7C4-7FE8-43F0-8E24-6934DC3E0C04}"/>
               </a:ext>
             </a:extLst>
           </p:cNvPr>
@@ -17328,7 +17328,7 @@
           <p:cNvPr id="19" name="">
             <a:extLst xmlns:a="http://schemas.openxmlformats.org/drawingml/2006/main">
               <a:ext uri="{FF2B5EF4-FFF2-40B4-BE49-F238E27FC236}">
-                <a16:creationId xmlns:a16="http://schemas.microsoft.com/office/drawing/2014/main" id="{558F7EF5-4332-4AC1-B8F3-4074E728B514}"/>
+                <a16:creationId xmlns:a16="http://schemas.microsoft.com/office/drawing/2014/main" id="{A752C395-C353-4FDC-AC16-AD6EE974F06F}"/>
               </a:ext>
             </a:extLst>
           </p:cNvPr>
@@ -17359,7 +17359,7 @@
           <p:cNvPr id="20" name="">
             <a:extLst xmlns:a="http://schemas.openxmlformats.org/drawingml/2006/main">
               <a:ext uri="{FF2B5EF4-FFF2-40B4-BE49-F238E27FC236}">
-                <a16:creationId xmlns:a16="http://schemas.microsoft.com/office/drawing/2014/main" id="{36A01F1F-AAF7-4987-817C-BE48914DA399}"/>
+                <a16:creationId xmlns:a16="http://schemas.microsoft.com/office/drawing/2014/main" id="{3D8D8B0E-3981-4450-8D31-6882BCB721A5}"/>
               </a:ext>
             </a:extLst>
           </p:cNvPr>
@@ -17390,7 +17390,7 @@
           <p:cNvPr id="21" name="">
             <a:extLst xmlns:a="http://schemas.openxmlformats.org/drawingml/2006/main">
               <a:ext uri="{FF2B5EF4-FFF2-40B4-BE49-F238E27FC236}">
-                <a16:creationId xmlns:a16="http://schemas.microsoft.com/office/drawing/2014/main" id="{69DEA8E2-2A3C-47D8-853F-386840B71FCE}"/>
+                <a16:creationId xmlns:a16="http://schemas.microsoft.com/office/drawing/2014/main" id="{AA01E73E-46A9-4094-BC21-A8E03FB04438}"/>
               </a:ext>
             </a:extLst>
           </p:cNvPr>
@@ -17421,7 +17421,7 @@
           <p:cNvPr id="22" name="">
             <a:extLst xmlns:a="http://schemas.openxmlformats.org/drawingml/2006/main">
               <a:ext uri="{FF2B5EF4-FFF2-40B4-BE49-F238E27FC236}">
-                <a16:creationId xmlns:a16="http://schemas.microsoft.com/office/drawing/2014/main" id="{7A9F46B1-9C5E-40BB-97FD-D075100D6B01}"/>
+                <a16:creationId xmlns:a16="http://schemas.microsoft.com/office/drawing/2014/main" id="{71479A15-1175-415B-86DB-2611131BE150}"/>
               </a:ext>
             </a:extLst>
           </p:cNvPr>
@@ -17452,7 +17452,7 @@
           <p:cNvPr id="23" name="">
             <a:extLst xmlns:a="http://schemas.openxmlformats.org/drawingml/2006/main">
               <a:ext uri="{FF2B5EF4-FFF2-40B4-BE49-F238E27FC236}">
-                <a16:creationId xmlns:a16="http://schemas.microsoft.com/office/drawing/2014/main" id="{6CD4ACCF-0CEF-4270-9E6B-2B166B19BBD8}"/>
+                <a16:creationId xmlns:a16="http://schemas.microsoft.com/office/drawing/2014/main" id="{74290577-16E9-432B-9D73-40930FF4991D}"/>
               </a:ext>
             </a:extLst>
           </p:cNvPr>
@@ -17483,7 +17483,7 @@
           <p:cNvPr id="24" name="">
             <a:extLst xmlns:a="http://schemas.openxmlformats.org/drawingml/2006/main">
               <a:ext uri="{FF2B5EF4-FFF2-40B4-BE49-F238E27FC236}">
-                <a16:creationId xmlns:a16="http://schemas.microsoft.com/office/drawing/2014/main" id="{C0DEED91-C4D8-4064-B48F-1BDB7264B1B2}"/>
+                <a16:creationId xmlns:a16="http://schemas.microsoft.com/office/drawing/2014/main" id="{5BCD2164-6C1B-4CEB-B852-FF4BED00B546}"/>
               </a:ext>
             </a:extLst>
           </p:cNvPr>
@@ -17514,7 +17514,7 @@
           <p:cNvPr id="25" name="">
             <a:extLst xmlns:a="http://schemas.openxmlformats.org/drawingml/2006/main">
               <a:ext uri="{FF2B5EF4-FFF2-40B4-BE49-F238E27FC236}">
-                <a16:creationId xmlns:a16="http://schemas.microsoft.com/office/drawing/2014/main" id="{651C3A78-70EF-4A71-8584-245C5F8AC350}"/>
+                <a16:creationId xmlns:a16="http://schemas.microsoft.com/office/drawing/2014/main" id="{404BF872-F0A7-4511-99C0-95A996AE91CB}"/>
               </a:ext>
             </a:extLst>
           </p:cNvPr>
@@ -17545,7 +17545,7 @@
           <p:cNvPr id="26" name="">
             <a:extLst xmlns:a="http://schemas.openxmlformats.org/drawingml/2006/main">
               <a:ext uri="{FF2B5EF4-FFF2-40B4-BE49-F238E27FC236}">
-                <a16:creationId xmlns:a16="http://schemas.microsoft.com/office/drawing/2014/main" id="{0462808F-B167-4D22-B9F0-18C30F3C013E}"/>
+                <a16:creationId xmlns:a16="http://schemas.microsoft.com/office/drawing/2014/main" id="{B4B660EA-BE4D-44E0-AAF6-DBACF5DDAEFA}"/>
               </a:ext>
             </a:extLst>
           </p:cNvPr>
@@ -17576,7 +17576,7 @@
           <p:cNvPr id="27" name="">
             <a:extLst xmlns:a="http://schemas.openxmlformats.org/drawingml/2006/main">
               <a:ext uri="{FF2B5EF4-FFF2-40B4-BE49-F238E27FC236}">
-                <a16:creationId xmlns:a16="http://schemas.microsoft.com/office/drawing/2014/main" id="{BFEDF9F1-1386-4175-AEC1-C44F0736AE6E}"/>
+                <a16:creationId xmlns:a16="http://schemas.microsoft.com/office/drawing/2014/main" id="{2377B71B-8758-4E98-A709-3997279FFBA2}"/>
               </a:ext>
             </a:extLst>
           </p:cNvPr>
@@ -17607,7 +17607,7 @@
           <p:cNvPr id="28" name="">
             <a:extLst xmlns:a="http://schemas.openxmlformats.org/drawingml/2006/main">
               <a:ext uri="{FF2B5EF4-FFF2-40B4-BE49-F238E27FC236}">
-                <a16:creationId xmlns:a16="http://schemas.microsoft.com/office/drawing/2014/main" id="{CD79D152-78A6-474C-BA01-C4D610731D7A}"/>
+                <a16:creationId xmlns:a16="http://schemas.microsoft.com/office/drawing/2014/main" id="{A5ABB31F-77FD-49F7-A928-A3E2C8E06958}"/>
               </a:ext>
             </a:extLst>
           </p:cNvPr>
@@ -17638,7 +17638,7 @@
           <p:cNvPr id="29" name="">
             <a:extLst xmlns:a="http://schemas.openxmlformats.org/drawingml/2006/main">
               <a:ext uri="{FF2B5EF4-FFF2-40B4-BE49-F238E27FC236}">
-                <a16:creationId xmlns:a16="http://schemas.microsoft.com/office/drawing/2014/main" id="{72B790AF-A27A-42E6-8E37-2B0643752EF5}"/>
+                <a16:creationId xmlns:a16="http://schemas.microsoft.com/office/drawing/2014/main" id="{C4F4616C-FC2A-4535-B56F-691C4DC66F19}"/>
               </a:ext>
             </a:extLst>
           </p:cNvPr>
@@ -17669,7 +17669,7 @@
           <p:cNvPr id="30" name="">
             <a:extLst xmlns:a="http://schemas.openxmlformats.org/drawingml/2006/main">
               <a:ext uri="{FF2B5EF4-FFF2-40B4-BE49-F238E27FC236}">
-                <a16:creationId xmlns:a16="http://schemas.microsoft.com/office/drawing/2014/main" id="{CF9197A8-7FB3-4585-96E5-73EE410A9076}"/>
+                <a16:creationId xmlns:a16="http://schemas.microsoft.com/office/drawing/2014/main" id="{CC05CCDD-D84F-4A1E-945E-B988857CE607}"/>
               </a:ext>
             </a:extLst>
           </p:cNvPr>
@@ -17700,7 +17700,7 @@
           <p:cNvPr id="31" name="">
             <a:extLst xmlns:a="http://schemas.openxmlformats.org/drawingml/2006/main">
               <a:ext uri="{FF2B5EF4-FFF2-40B4-BE49-F238E27FC236}">
-                <a16:creationId xmlns:a16="http://schemas.microsoft.com/office/drawing/2014/main" id="{89A84795-9D70-48DC-BCFE-3FB34A6F3EB3}"/>
+                <a16:creationId xmlns:a16="http://schemas.microsoft.com/office/drawing/2014/main" id="{FE110AF0-6CC2-4CA4-B600-50462070D0E3}"/>
               </a:ext>
             </a:extLst>
           </p:cNvPr>
@@ -17731,7 +17731,7 @@
           <p:cNvPr id="32" name="">
             <a:extLst xmlns:a="http://schemas.openxmlformats.org/drawingml/2006/main">
               <a:ext uri="{FF2B5EF4-FFF2-40B4-BE49-F238E27FC236}">
-                <a16:creationId xmlns:a16="http://schemas.microsoft.com/office/drawing/2014/main" id="{681D9695-B51C-466D-A3F0-291802B28ABB}"/>
+                <a16:creationId xmlns:a16="http://schemas.microsoft.com/office/drawing/2014/main" id="{7B098DE7-8B6C-4572-9504-6C2C2BBE98CC}"/>
               </a:ext>
             </a:extLst>
           </p:cNvPr>
@@ -17762,7 +17762,7 @@
           <p:cNvPr id="33" name="">
             <a:extLst xmlns:a="http://schemas.openxmlformats.org/drawingml/2006/main">
               <a:ext uri="{FF2B5EF4-FFF2-40B4-BE49-F238E27FC236}">
-                <a16:creationId xmlns:a16="http://schemas.microsoft.com/office/drawing/2014/main" id="{A940BAFE-AA20-43AD-8DE1-2452BDEC7993}"/>
+                <a16:creationId xmlns:a16="http://schemas.microsoft.com/office/drawing/2014/main" id="{BA3F49C5-B9B2-4931-A86A-2A7246AABEC3}"/>
               </a:ext>
             </a:extLst>
           </p:cNvPr>
@@ -17793,7 +17793,7 @@
           <p:cNvPr id="34" name="">
             <a:extLst xmlns:a="http://schemas.openxmlformats.org/drawingml/2006/main">
               <a:ext uri="{FF2B5EF4-FFF2-40B4-BE49-F238E27FC236}">
-                <a16:creationId xmlns:a16="http://schemas.microsoft.com/office/drawing/2014/main" id="{CC2625B9-CF0A-4D32-92D5-A539354AFCD4}"/>
+                <a16:creationId xmlns:a16="http://schemas.microsoft.com/office/drawing/2014/main" id="{0EED12A0-6231-4BDF-AAA2-031CBC315004}"/>
               </a:ext>
             </a:extLst>
           </p:cNvPr>
@@ -17826,7 +17826,7 @@
           <p:cNvPr id="35" name="">
             <a:extLst xmlns:a="http://schemas.openxmlformats.org/drawingml/2006/main">
               <a:ext uri="{FF2B5EF4-FFF2-40B4-BE49-F238E27FC236}">
-                <a16:creationId xmlns:a16="http://schemas.microsoft.com/office/drawing/2014/main" id="{8B1A014D-05CB-4255-8A9C-C0DE8C290C36}"/>
+                <a16:creationId xmlns:a16="http://schemas.microsoft.com/office/drawing/2014/main" id="{128B4667-5C7C-470A-8EED-9460ABF42E54}"/>
               </a:ext>
             </a:extLst>
           </p:cNvPr>
@@ -17888,7 +17888,7 @@
           <p:cNvPr id="36" name="">
             <a:extLst xmlns:a="http://schemas.openxmlformats.org/drawingml/2006/main">
               <a:ext uri="{FF2B5EF4-FFF2-40B4-BE49-F238E27FC236}">
-                <a16:creationId xmlns:a16="http://schemas.microsoft.com/office/drawing/2014/main" id="{D1C7F814-F396-4847-9EC5-9AD12E13E070}"/>
+                <a16:creationId xmlns:a16="http://schemas.microsoft.com/office/drawing/2014/main" id="{046E97AE-6516-4DBD-B534-E6B971D57F6E}"/>
               </a:ext>
             </a:extLst>
           </p:cNvPr>
@@ -17950,7 +17950,7 @@
           <p:cNvPr id="37" name="">
             <a:extLst xmlns:a="http://schemas.openxmlformats.org/drawingml/2006/main">
               <a:ext uri="{FF2B5EF4-FFF2-40B4-BE49-F238E27FC236}">
-                <a16:creationId xmlns:a16="http://schemas.microsoft.com/office/drawing/2014/main" id="{8D4D044F-01AF-4557-8E19-A25A79EFF7E1}"/>
+                <a16:creationId xmlns:a16="http://schemas.microsoft.com/office/drawing/2014/main" id="{6E27F1BD-2A62-4D89-9B1F-B6F8854DEEE6}"/>
               </a:ext>
             </a:extLst>
           </p:cNvPr>
@@ -18012,7 +18012,7 @@
           <p:cNvPr id="38" name="">
             <a:extLst xmlns:a="http://schemas.openxmlformats.org/drawingml/2006/main">
               <a:ext uri="{FF2B5EF4-FFF2-40B4-BE49-F238E27FC236}">
-                <a16:creationId xmlns:a16="http://schemas.microsoft.com/office/drawing/2014/main" id="{E723F369-E311-4AAC-8AEE-1B3A089F5E0B}"/>
+                <a16:creationId xmlns:a16="http://schemas.microsoft.com/office/drawing/2014/main" id="{38B6E72D-40F5-4A27-8051-FF37721FA710}"/>
               </a:ext>
             </a:extLst>
           </p:cNvPr>
@@ -18074,7 +18074,7 @@
           <p:cNvPr id="39" name="">
             <a:extLst xmlns:a="http://schemas.openxmlformats.org/drawingml/2006/main">
               <a:ext uri="{FF2B5EF4-FFF2-40B4-BE49-F238E27FC236}">
-                <a16:creationId xmlns:a16="http://schemas.microsoft.com/office/drawing/2014/main" id="{02728433-04B5-4EF3-9F2A-41433EE6AE59}"/>
+                <a16:creationId xmlns:a16="http://schemas.microsoft.com/office/drawing/2014/main" id="{C89D1CB7-727B-46BE-B77C-809F6CBC7F0D}"/>
               </a:ext>
             </a:extLst>
           </p:cNvPr>
@@ -18105,7 +18105,7 @@
           <p:cNvPr id="40" name="">
             <a:extLst xmlns:a="http://schemas.openxmlformats.org/drawingml/2006/main">
               <a:ext uri="{FF2B5EF4-FFF2-40B4-BE49-F238E27FC236}">
-                <a16:creationId xmlns:a16="http://schemas.microsoft.com/office/drawing/2014/main" id="{F8753153-B0D9-4FAA-85D9-6DE8DCBC379F}"/>
+                <a16:creationId xmlns:a16="http://schemas.microsoft.com/office/drawing/2014/main" id="{23AD55BA-A81A-48A4-805E-E4D9DB014A80}"/>
               </a:ext>
             </a:extLst>
           </p:cNvPr>
@@ -18136,7 +18136,7 @@
           <p:cNvPr id="41" name="">
             <a:extLst xmlns:a="http://schemas.openxmlformats.org/drawingml/2006/main">
               <a:ext uri="{FF2B5EF4-FFF2-40B4-BE49-F238E27FC236}">
-                <a16:creationId xmlns:a16="http://schemas.microsoft.com/office/drawing/2014/main" id="{7E11E22C-B142-4F00-AC95-AF8E329EF5F5}"/>
+                <a16:creationId xmlns:a16="http://schemas.microsoft.com/office/drawing/2014/main" id="{89C682DD-42FF-435D-ABA0-E07FF0CF4E25}"/>
               </a:ext>
             </a:extLst>
           </p:cNvPr>
@@ -18198,7 +18198,7 @@
           <p:cNvPr id="42" name="">
             <a:extLst xmlns:a="http://schemas.openxmlformats.org/drawingml/2006/main">
               <a:ext uri="{FF2B5EF4-FFF2-40B4-BE49-F238E27FC236}">
-                <a16:creationId xmlns:a16="http://schemas.microsoft.com/office/drawing/2014/main" id="{606B4621-59B7-4F2E-B845-9B25B9A641B0}"/>
+                <a16:creationId xmlns:a16="http://schemas.microsoft.com/office/drawing/2014/main" id="{2C04D58D-C920-462D-B750-AC283C160938}"/>
               </a:ext>
             </a:extLst>
           </p:cNvPr>
@@ -18260,7 +18260,7 @@
           <p:cNvPr id="43" name="">
             <a:extLst xmlns:a="http://schemas.openxmlformats.org/drawingml/2006/main">
               <a:ext uri="{FF2B5EF4-FFF2-40B4-BE49-F238E27FC236}">
-                <a16:creationId xmlns:a16="http://schemas.microsoft.com/office/drawing/2014/main" id="{5F98CCB3-E670-4BDE-A95C-03EF8C4A6D22}"/>
+                <a16:creationId xmlns:a16="http://schemas.microsoft.com/office/drawing/2014/main" id="{C82D1EB0-B6EC-4B75-8332-0A7B6C9EEB15}"/>
               </a:ext>
             </a:extLst>
           </p:cNvPr>
@@ -18322,7 +18322,7 @@
           <p:cNvPr id="44" name="">
             <a:extLst xmlns:a="http://schemas.openxmlformats.org/drawingml/2006/main">
               <a:ext uri="{FF2B5EF4-FFF2-40B4-BE49-F238E27FC236}">
-                <a16:creationId xmlns:a16="http://schemas.microsoft.com/office/drawing/2014/main" id="{3C895794-6389-4622-882A-E3402ADF02DA}"/>
+                <a16:creationId xmlns:a16="http://schemas.microsoft.com/office/drawing/2014/main" id="{0D3F279E-4044-4497-A915-3C4AC550E82A}"/>
               </a:ext>
             </a:extLst>
           </p:cNvPr>
@@ -18357,7 +18357,7 @@
           <p:cNvPr id="45" name="">
             <a:extLst xmlns:a="http://schemas.openxmlformats.org/drawingml/2006/main">
               <a:ext uri="{FF2B5EF4-FFF2-40B4-BE49-F238E27FC236}">
-                <a16:creationId xmlns:a16="http://schemas.microsoft.com/office/drawing/2014/main" id="{D8CA60CE-A10C-49EF-8F84-51570A20CDBC}"/>
+                <a16:creationId xmlns:a16="http://schemas.microsoft.com/office/drawing/2014/main" id="{E1E2E33C-87DF-4D32-B1F7-5C3906AE0E88}"/>
               </a:ext>
             </a:extLst>
           </p:cNvPr>
@@ -18408,7 +18408,7 @@
                 <a:latin typeface="Arial"/>
                 <a:ea typeface="Arial"/>
                 <a:cs typeface="Arial"/>
-                <a:hlinkClick xmlns:r="http://schemas.openxmlformats.org/officeDocument/2006/relationships" r:id="Rff35adb156374795"/>
+                <a:hlinkClick xmlns:r="http://schemas.openxmlformats.org/officeDocument/2006/relationships" r:id="R9073c5baca744729"/>
               </a:rPr>
               <a:t>READ EDITION 006  →  BRIEF.BRIDGEXCAPITAL.AI</a:t>
             </a:r>
@@ -18420,7 +18420,7 @@
           <p:cNvPr id="46" name="">
             <a:extLst xmlns:a="http://schemas.openxmlformats.org/drawingml/2006/main">
               <a:ext uri="{FF2B5EF4-FFF2-40B4-BE49-F238E27FC236}">
-                <a16:creationId xmlns:a16="http://schemas.microsoft.com/office/drawing/2014/main" id="{A3F15CC4-BDF2-416D-A9FF-B0378C33A46A}"/>
+                <a16:creationId xmlns:a16="http://schemas.microsoft.com/office/drawing/2014/main" id="{87137965-D96A-4297-A413-553B73D58C3F}"/>
               </a:ext>
             </a:extLst>
           </p:cNvPr>
@@ -18482,7 +18482,7 @@
           <p:cNvPr id="47" name="">
             <a:extLst xmlns:a="http://schemas.openxmlformats.org/drawingml/2006/main">
               <a:ext uri="{FF2B5EF4-FFF2-40B4-BE49-F238E27FC236}">
-                <a16:creationId xmlns:a16="http://schemas.microsoft.com/office/drawing/2014/main" id="{122DAB8A-7E1C-42FF-A9D9-17BDBD9D13B5}"/>
+                <a16:creationId xmlns:a16="http://schemas.microsoft.com/office/drawing/2014/main" id="{82BE9B75-CD12-47B3-80ED-73893BD8AD4A}"/>
               </a:ext>
             </a:extLst>
           </p:cNvPr>
@@ -18544,7 +18544,7 @@
           <p:cNvPr id="48" name="">
             <a:extLst xmlns:a="http://schemas.openxmlformats.org/drawingml/2006/main">
               <a:ext uri="{FF2B5EF4-FFF2-40B4-BE49-F238E27FC236}">
-                <a16:creationId xmlns:a16="http://schemas.microsoft.com/office/drawing/2014/main" id="{742B3BCB-BAF9-4414-8A0B-D2F05AB678B8}"/>
+                <a16:creationId xmlns:a16="http://schemas.microsoft.com/office/drawing/2014/main" id="{3AB2D5BF-5CF3-4D11-9603-29B9B0E892B0}"/>
               </a:ext>
             </a:extLst>
           </p:cNvPr>
@@ -18606,7 +18606,7 @@
           <p:cNvPr id="49" name="">
             <a:extLst xmlns:a="http://schemas.openxmlformats.org/drawingml/2006/main">
               <a:ext uri="{FF2B5EF4-FFF2-40B4-BE49-F238E27FC236}">
-                <a16:creationId xmlns:a16="http://schemas.microsoft.com/office/drawing/2014/main" id="{4B07559C-6D87-4045-A94C-0A7E2099D4E8}"/>
+                <a16:creationId xmlns:a16="http://schemas.microsoft.com/office/drawing/2014/main" id="{49AB77B2-AA41-450F-9CA5-774DFCA066BC}"/>
               </a:ext>
             </a:extLst>
           </p:cNvPr>
@@ -18666,7 +18666,7 @@
     </p:spTree>
     <p:extLst>
       <p:ext uri="{BB962C8B-B14F-4D97-AF65-F5344CB8AC3E}">
-        <p14:creationId xmlns:p14="http://schemas.microsoft.com/office/powerpoint/2010/main" val="1999523823"/>
+        <p14:creationId xmlns:p14="http://schemas.microsoft.com/office/powerpoint/2010/main" val="582665447"/>
       </p:ext>
     </p:extLst>
   </p:cSld>

</xml_diff>